<commit_message>
Fix final presentation section nav highlight
</commit_message>
<xml_diff>
--- a/FinalProject/SABRE_Final_Presentation.pptx
+++ b/FinalProject/SABRE_Final_Presentation.pptx
@@ -4410,6 +4410,50 @@
           </a:p>
         </p:txBody>
       </p:sp>
+      <p:sp>
+        <p:nvSpPr>
+          <p:cNvPr id="43" name="slide_page_number_codex"/>
+          <p:cNvSpPr txBox="1"/>
+          <p:nvPr/>
+        </p:nvSpPr>
+        <p:spPr>
+          <a:xfrm>
+            <a:off x="11350752" y="6528816"/>
+            <a:ext cx="713232" cy="182880"/>
+          </a:xfrm>
+          <a:prstGeom prst="rect">
+            <a:avLst/>
+          </a:prstGeom>
+          <a:noFill/>
+          <a:ln>
+            <a:noFill/>
+          </a:ln>
+        </p:spPr>
+        <p:txBody>
+          <a:bodyPr wrap="none" lIns="0" tIns="0" rIns="0" bIns="0">
+            <a:spAutoFit/>
+          </a:bodyPr>
+          <a:lstStyle/>
+          <a:p>
+            <a:pPr algn="r"/>
+            <a:r>
+              <a:rPr sz="800">
+                <a:solidFill>
+                  <a:srgbClr val="F5F7FA"/>
+                </a:solidFill>
+                <a:latin typeface="Aptos"/>
+              </a:rPr>
+              <a:t>01 / 16</a:t>
+            </a:r>
+            <a:endParaRPr sz="800">
+              <a:solidFill>
+                <a:srgbClr val="F5F7FA"/>
+              </a:solidFill>
+              <a:latin typeface="Aptos"/>
+            </a:endParaRPr>
+          </a:p>
+        </p:txBody>
+      </p:sp>
     </p:spTree>
   </p:cSld>
   <p:clrMapOvr>
@@ -6835,6 +6879,50 @@
           </a:p>
         </p:txBody>
       </p:sp>
+      <p:sp>
+        <p:nvSpPr>
+          <p:cNvPr id="130" name="slide_page_number_codex"/>
+          <p:cNvSpPr txBox="1"/>
+          <p:nvPr/>
+        </p:nvSpPr>
+        <p:spPr>
+          <a:xfrm>
+            <a:off x="11350752" y="6528816"/>
+            <a:ext cx="713232" cy="182880"/>
+          </a:xfrm>
+          <a:prstGeom prst="rect">
+            <a:avLst/>
+          </a:prstGeom>
+          <a:noFill/>
+          <a:ln>
+            <a:noFill/>
+          </a:ln>
+        </p:spPr>
+        <p:txBody>
+          <a:bodyPr wrap="none" lIns="0" tIns="0" rIns="0" bIns="0">
+            <a:spAutoFit/>
+          </a:bodyPr>
+          <a:lstStyle/>
+          <a:p>
+            <a:pPr algn="r"/>
+            <a:r>
+              <a:rPr sz="800">
+                <a:solidFill>
+                  <a:srgbClr val="6B7280"/>
+                </a:solidFill>
+                <a:latin typeface="Aptos"/>
+              </a:rPr>
+              <a:t>10 / 16</a:t>
+            </a:r>
+            <a:endParaRPr sz="800">
+              <a:solidFill>
+                <a:srgbClr val="6B7280"/>
+              </a:solidFill>
+              <a:latin typeface="Aptos"/>
+            </a:endParaRPr>
+          </a:p>
+        </p:txBody>
+      </p:sp>
     </p:spTree>
     <p:custDataLst>
       <p:tags r:id="rId5"/>
@@ -8759,6 +8847,50 @@
           </a:p>
         </p:txBody>
       </p:sp>
+      <p:sp>
+        <p:nvSpPr>
+          <p:cNvPr id="117" name="slide_page_number_codex"/>
+          <p:cNvSpPr txBox="1"/>
+          <p:nvPr/>
+        </p:nvSpPr>
+        <p:spPr>
+          <a:xfrm>
+            <a:off x="11350752" y="6528816"/>
+            <a:ext cx="713232" cy="182880"/>
+          </a:xfrm>
+          <a:prstGeom prst="rect">
+            <a:avLst/>
+          </a:prstGeom>
+          <a:noFill/>
+          <a:ln>
+            <a:noFill/>
+          </a:ln>
+        </p:spPr>
+        <p:txBody>
+          <a:bodyPr wrap="none" lIns="0" tIns="0" rIns="0" bIns="0">
+            <a:spAutoFit/>
+          </a:bodyPr>
+          <a:lstStyle/>
+          <a:p>
+            <a:pPr algn="r"/>
+            <a:r>
+              <a:rPr sz="800">
+                <a:solidFill>
+                  <a:srgbClr val="6B7280"/>
+                </a:solidFill>
+                <a:latin typeface="Aptos"/>
+              </a:rPr>
+              <a:t>11 / 16</a:t>
+            </a:r>
+            <a:endParaRPr sz="800">
+              <a:solidFill>
+                <a:srgbClr val="6B7280"/>
+              </a:solidFill>
+              <a:latin typeface="Aptos"/>
+            </a:endParaRPr>
+          </a:p>
+        </p:txBody>
+      </p:sp>
     </p:spTree>
     <p:custDataLst>
       <p:tags r:id="rId5"/>
@@ -11343,6 +11475,50 @@
           </a:p>
         </p:txBody>
       </p:sp>
+      <p:sp>
+        <p:nvSpPr>
+          <p:cNvPr id="139" name="slide_page_number_codex"/>
+          <p:cNvSpPr txBox="1"/>
+          <p:nvPr/>
+        </p:nvSpPr>
+        <p:spPr>
+          <a:xfrm>
+            <a:off x="11350752" y="6528816"/>
+            <a:ext cx="713232" cy="182880"/>
+          </a:xfrm>
+          <a:prstGeom prst="rect">
+            <a:avLst/>
+          </a:prstGeom>
+          <a:noFill/>
+          <a:ln>
+            <a:noFill/>
+          </a:ln>
+        </p:spPr>
+        <p:txBody>
+          <a:bodyPr wrap="none" lIns="0" tIns="0" rIns="0" bIns="0">
+            <a:spAutoFit/>
+          </a:bodyPr>
+          <a:lstStyle/>
+          <a:p>
+            <a:pPr algn="r"/>
+            <a:r>
+              <a:rPr sz="800">
+                <a:solidFill>
+                  <a:srgbClr val="6B7280"/>
+                </a:solidFill>
+                <a:latin typeface="Aptos"/>
+              </a:rPr>
+              <a:t>12 / 16</a:t>
+            </a:r>
+            <a:endParaRPr sz="800">
+              <a:solidFill>
+                <a:srgbClr val="6B7280"/>
+              </a:solidFill>
+              <a:latin typeface="Aptos"/>
+            </a:endParaRPr>
+          </a:p>
+        </p:txBody>
+      </p:sp>
     </p:spTree>
     <p:custDataLst>
       <p:tags r:id="rId5"/>
@@ -13362,6 +13538,50 @@
           </a:p>
         </p:txBody>
       </p:sp>
+      <p:sp>
+        <p:nvSpPr>
+          <p:cNvPr id="116" name="slide_page_number_codex"/>
+          <p:cNvSpPr txBox="1"/>
+          <p:nvPr/>
+        </p:nvSpPr>
+        <p:spPr>
+          <a:xfrm>
+            <a:off x="11350752" y="6528816"/>
+            <a:ext cx="713232" cy="182880"/>
+          </a:xfrm>
+          <a:prstGeom prst="rect">
+            <a:avLst/>
+          </a:prstGeom>
+          <a:noFill/>
+          <a:ln>
+            <a:noFill/>
+          </a:ln>
+        </p:spPr>
+        <p:txBody>
+          <a:bodyPr wrap="none" lIns="0" tIns="0" rIns="0" bIns="0">
+            <a:spAutoFit/>
+          </a:bodyPr>
+          <a:lstStyle/>
+          <a:p>
+            <a:pPr algn="r"/>
+            <a:r>
+              <a:rPr sz="800">
+                <a:solidFill>
+                  <a:srgbClr val="6B7280"/>
+                </a:solidFill>
+                <a:latin typeface="Aptos"/>
+              </a:rPr>
+              <a:t>13 / 16</a:t>
+            </a:r>
+            <a:endParaRPr sz="800">
+              <a:solidFill>
+                <a:srgbClr val="6B7280"/>
+              </a:solidFill>
+              <a:latin typeface="Aptos"/>
+            </a:endParaRPr>
+          </a:p>
+        </p:txBody>
+      </p:sp>
     </p:spTree>
     <p:custDataLst>
       <p:tags r:id="rId5"/>
@@ -14116,7 +14336,7 @@
             <a:avLst/>
           </a:prstGeom>
           <a:solidFill>
-            <a:srgbClr val="660066"/>
+            <a:srgbClr val="9672A0"/>
           </a:solidFill>
         </p:spPr>
         <p:txBody>
@@ -14298,6 +14518,7 @@
           </a:bodyPr>
           <a:lstStyle/>
           <a:p>
+            <a:pPr algn="ctr"/>
             <a:r>
               <a:rPr sz="2300" b="1">
                 <a:solidFill>
@@ -14479,6 +14700,7 @@
           </a:bodyPr>
           <a:lstStyle/>
           <a:p>
+            <a:pPr algn="ctr"/>
             <a:r>
               <a:rPr sz="2300" b="1">
                 <a:solidFill>
@@ -15069,6 +15291,50 @@
                 <a:srgbClr val="78697D"/>
               </a:solidFill>
               <a:latin typeface="微软雅黑" panose="020B0503020204020204" charset="-122"/>
+            </a:endParaRPr>
+          </a:p>
+        </p:txBody>
+      </p:sp>
+      <p:sp>
+        <p:nvSpPr>
+          <p:cNvPr id="89" name="slide_page_number_codex"/>
+          <p:cNvSpPr txBox="1"/>
+          <p:nvPr/>
+        </p:nvSpPr>
+        <p:spPr>
+          <a:xfrm>
+            <a:off x="11350752" y="6528816"/>
+            <a:ext cx="713232" cy="182880"/>
+          </a:xfrm>
+          <a:prstGeom prst="rect">
+            <a:avLst/>
+          </a:prstGeom>
+          <a:noFill/>
+          <a:ln>
+            <a:noFill/>
+          </a:ln>
+        </p:spPr>
+        <p:txBody>
+          <a:bodyPr wrap="none" lIns="0" tIns="0" rIns="0" bIns="0">
+            <a:spAutoFit/>
+          </a:bodyPr>
+          <a:lstStyle/>
+          <a:p>
+            <a:pPr algn="r"/>
+            <a:r>
+              <a:rPr sz="800">
+                <a:solidFill>
+                  <a:srgbClr val="6B7280"/>
+                </a:solidFill>
+                <a:latin typeface="Aptos"/>
+              </a:rPr>
+              <a:t>14 / 16</a:t>
+            </a:r>
+            <a:endParaRPr sz="800">
+              <a:solidFill>
+                <a:srgbClr val="6B7280"/>
+              </a:solidFill>
+              <a:latin typeface="Aptos"/>
             </a:endParaRPr>
           </a:p>
         </p:txBody>
@@ -15782,7 +16048,7 @@
             <a:avLst/>
           </a:prstGeom>
           <a:solidFill>
-            <a:srgbClr val="660066"/>
+            <a:srgbClr val="9672A0"/>
           </a:solidFill>
         </p:spPr>
         <p:txBody>
@@ -16627,6 +16893,50 @@
                 <a:srgbClr val="5F4B23"/>
               </a:solidFill>
               <a:latin typeface="微软雅黑" panose="020B0503020204020204" charset="-122"/>
+            </a:endParaRPr>
+          </a:p>
+        </p:txBody>
+      </p:sp>
+      <p:sp>
+        <p:nvSpPr>
+          <p:cNvPr id="88" name="slide_page_number_codex"/>
+          <p:cNvSpPr txBox="1"/>
+          <p:nvPr/>
+        </p:nvSpPr>
+        <p:spPr>
+          <a:xfrm>
+            <a:off x="11350752" y="6528816"/>
+            <a:ext cx="713232" cy="182880"/>
+          </a:xfrm>
+          <a:prstGeom prst="rect">
+            <a:avLst/>
+          </a:prstGeom>
+          <a:noFill/>
+          <a:ln>
+            <a:noFill/>
+          </a:ln>
+        </p:spPr>
+        <p:txBody>
+          <a:bodyPr wrap="none" lIns="0" tIns="0" rIns="0" bIns="0">
+            <a:spAutoFit/>
+          </a:bodyPr>
+          <a:lstStyle/>
+          <a:p>
+            <a:pPr algn="r"/>
+            <a:r>
+              <a:rPr sz="800">
+                <a:solidFill>
+                  <a:srgbClr val="6B7280"/>
+                </a:solidFill>
+                <a:latin typeface="Aptos"/>
+              </a:rPr>
+              <a:t>15 / 16</a:t>
+            </a:r>
+            <a:endParaRPr sz="800">
+              <a:solidFill>
+                <a:srgbClr val="6B7280"/>
+              </a:solidFill>
+              <a:latin typeface="Aptos"/>
             </a:endParaRPr>
           </a:p>
         </p:txBody>
@@ -17479,6 +17789,50 @@
               </a:solidFill>
               <a:latin typeface="Arial" panose="020B0604020202020204" pitchFamily="34" charset="0"/>
               <a:ea typeface="微软雅黑" panose="020B0503020204020204" charset="-122"/>
+            </a:endParaRPr>
+          </a:p>
+        </p:txBody>
+      </p:sp>
+      <p:sp>
+        <p:nvSpPr>
+          <p:cNvPr id="39" name="slide_page_number_codex"/>
+          <p:cNvSpPr txBox="1"/>
+          <p:nvPr/>
+        </p:nvSpPr>
+        <p:spPr>
+          <a:xfrm>
+            <a:off x="11350752" y="6528816"/>
+            <a:ext cx="713232" cy="182880"/>
+          </a:xfrm>
+          <a:prstGeom prst="rect">
+            <a:avLst/>
+          </a:prstGeom>
+          <a:noFill/>
+          <a:ln>
+            <a:noFill/>
+          </a:ln>
+        </p:spPr>
+        <p:txBody>
+          <a:bodyPr wrap="none" lIns="0" tIns="0" rIns="0" bIns="0">
+            <a:spAutoFit/>
+          </a:bodyPr>
+          <a:lstStyle/>
+          <a:p>
+            <a:pPr algn="r"/>
+            <a:r>
+              <a:rPr sz="800">
+                <a:solidFill>
+                  <a:srgbClr val="F5F7FA"/>
+                </a:solidFill>
+                <a:latin typeface="Aptos"/>
+              </a:rPr>
+              <a:t>16 / 16</a:t>
+            </a:r>
+            <a:endParaRPr sz="800">
+              <a:solidFill>
+                <a:srgbClr val="F5F7FA"/>
+              </a:solidFill>
+              <a:latin typeface="Aptos"/>
             </a:endParaRPr>
           </a:p>
         </p:txBody>
@@ -20411,6 +20765,50 @@
           </a:p>
         </p:txBody>
       </p:sp>
+      <p:sp>
+        <p:nvSpPr>
+          <p:cNvPr id="83" name="slide_page_number_codex"/>
+          <p:cNvSpPr txBox="1"/>
+          <p:nvPr/>
+        </p:nvSpPr>
+        <p:spPr>
+          <a:xfrm>
+            <a:off x="11350752" y="6528816"/>
+            <a:ext cx="713232" cy="182880"/>
+          </a:xfrm>
+          <a:prstGeom prst="rect">
+            <a:avLst/>
+          </a:prstGeom>
+          <a:noFill/>
+          <a:ln>
+            <a:noFill/>
+          </a:ln>
+        </p:spPr>
+        <p:txBody>
+          <a:bodyPr wrap="none" lIns="0" tIns="0" rIns="0" bIns="0">
+            <a:spAutoFit/>
+          </a:bodyPr>
+          <a:lstStyle/>
+          <a:p>
+            <a:pPr algn="r"/>
+            <a:r>
+              <a:rPr sz="800">
+                <a:solidFill>
+                  <a:srgbClr val="6B7280"/>
+                </a:solidFill>
+                <a:latin typeface="Aptos"/>
+              </a:rPr>
+              <a:t>02 / 16</a:t>
+            </a:r>
+            <a:endParaRPr sz="800">
+              <a:solidFill>
+                <a:srgbClr val="6B7280"/>
+              </a:solidFill>
+              <a:latin typeface="Aptos"/>
+            </a:endParaRPr>
+          </a:p>
+        </p:txBody>
+      </p:sp>
     </p:spTree>
   </p:cSld>
   <p:clrMapOvr>
@@ -23695,8 +24093,8 @@
         </p:nvSpPr>
         <p:spPr>
           <a:xfrm>
-            <a:off x="1170432" y="3841805"/>
-            <a:ext cx="235458" cy="94183"/>
+            <a:off x="1122680" y="3841750"/>
+            <a:ext cx="331470" cy="93980"/>
           </a:xfrm>
           <a:prstGeom prst="rect">
             <a:avLst/>
@@ -23705,7 +24103,7 @@
         </p:spPr>
         <p:txBody>
           <a:bodyPr wrap="square" lIns="36576" tIns="18288" rIns="36576" bIns="18288" anchor="t">
-            <a:spAutoFit/>
+            <a:noAutofit/>
           </a:bodyPr>
           <a:lstStyle/>
           <a:p>
@@ -23785,8 +24183,8 @@
         </p:nvSpPr>
         <p:spPr>
           <a:xfrm>
-            <a:off x="1773204" y="3841805"/>
-            <a:ext cx="235458" cy="94183"/>
+            <a:off x="1732915" y="3841750"/>
+            <a:ext cx="300990" cy="93980"/>
           </a:xfrm>
           <a:prstGeom prst="rect">
             <a:avLst/>
@@ -23795,7 +24193,7 @@
         </p:spPr>
         <p:txBody>
           <a:bodyPr wrap="square" lIns="36576" tIns="18288" rIns="36576" bIns="18288" anchor="t">
-            <a:spAutoFit/>
+            <a:noAutofit/>
           </a:bodyPr>
           <a:lstStyle/>
           <a:p>
@@ -23875,8 +24273,8 @@
         </p:nvSpPr>
         <p:spPr>
           <a:xfrm>
-            <a:off x="2375976" y="3841805"/>
-            <a:ext cx="235458" cy="94183"/>
+            <a:off x="2355850" y="3841750"/>
+            <a:ext cx="275590" cy="93980"/>
           </a:xfrm>
           <a:prstGeom prst="rect">
             <a:avLst/>
@@ -23885,7 +24283,7 @@
         </p:spPr>
         <p:txBody>
           <a:bodyPr wrap="square" lIns="36576" tIns="18288" rIns="36576" bIns="18288" anchor="t">
-            <a:spAutoFit/>
+            <a:noAutofit/>
           </a:bodyPr>
           <a:lstStyle/>
           <a:p>
@@ -23965,8 +24363,8 @@
         </p:nvSpPr>
         <p:spPr>
           <a:xfrm>
-            <a:off x="2978749" y="3841805"/>
-            <a:ext cx="235458" cy="94183"/>
+            <a:off x="2968625" y="3841750"/>
+            <a:ext cx="259080" cy="93980"/>
           </a:xfrm>
           <a:prstGeom prst="rect">
             <a:avLst/>
@@ -23975,7 +24373,7 @@
         </p:spPr>
         <p:txBody>
           <a:bodyPr wrap="square" lIns="36576" tIns="18288" rIns="36576" bIns="18288" anchor="t">
-            <a:spAutoFit/>
+            <a:noAutofit/>
           </a:bodyPr>
           <a:lstStyle/>
           <a:p>
@@ -24055,8 +24453,8 @@
         </p:nvSpPr>
         <p:spPr>
           <a:xfrm>
-            <a:off x="3581521" y="3841805"/>
-            <a:ext cx="235458" cy="94183"/>
+            <a:off x="3540760" y="3841750"/>
+            <a:ext cx="327025" cy="93980"/>
           </a:xfrm>
           <a:prstGeom prst="rect">
             <a:avLst/>
@@ -24065,7 +24463,7 @@
         </p:spPr>
         <p:txBody>
           <a:bodyPr wrap="square" lIns="36576" tIns="18288" rIns="36576" bIns="18288" anchor="t">
-            <a:spAutoFit/>
+            <a:noAutofit/>
           </a:bodyPr>
           <a:lstStyle/>
           <a:p>
@@ -24145,8 +24543,8 @@
         </p:nvSpPr>
         <p:spPr>
           <a:xfrm>
-            <a:off x="1170432" y="4378650"/>
-            <a:ext cx="235458" cy="94183"/>
+            <a:off x="1124585" y="4378960"/>
+            <a:ext cx="342265" cy="93980"/>
           </a:xfrm>
           <a:prstGeom prst="rect">
             <a:avLst/>
@@ -24155,7 +24553,7 @@
         </p:spPr>
         <p:txBody>
           <a:bodyPr wrap="square" lIns="36576" tIns="18288" rIns="36576" bIns="18288" anchor="t">
-            <a:spAutoFit/>
+            <a:noAutofit/>
           </a:bodyPr>
           <a:lstStyle/>
           <a:p>
@@ -24235,8 +24633,8 @@
         </p:nvSpPr>
         <p:spPr>
           <a:xfrm>
-            <a:off x="1773204" y="4378650"/>
-            <a:ext cx="235458" cy="94183"/>
+            <a:off x="1762760" y="4378960"/>
+            <a:ext cx="261620" cy="93980"/>
           </a:xfrm>
           <a:prstGeom prst="rect">
             <a:avLst/>
@@ -24245,7 +24643,7 @@
         </p:spPr>
         <p:txBody>
           <a:bodyPr wrap="square" lIns="36576" tIns="18288" rIns="36576" bIns="18288" anchor="t">
-            <a:spAutoFit/>
+            <a:noAutofit/>
           </a:bodyPr>
           <a:lstStyle/>
           <a:p>
@@ -24325,8 +24723,8 @@
         </p:nvSpPr>
         <p:spPr>
           <a:xfrm>
-            <a:off x="2375976" y="4378650"/>
-            <a:ext cx="235458" cy="94183"/>
+            <a:off x="2335530" y="4378960"/>
+            <a:ext cx="311785" cy="93980"/>
           </a:xfrm>
           <a:prstGeom prst="rect">
             <a:avLst/>
@@ -24335,7 +24733,7 @@
         </p:spPr>
         <p:txBody>
           <a:bodyPr wrap="square" lIns="36576" tIns="18288" rIns="36576" bIns="18288" anchor="t">
-            <a:spAutoFit/>
+            <a:noAutofit/>
           </a:bodyPr>
           <a:lstStyle/>
           <a:p>
@@ -24415,8 +24813,8 @@
         </p:nvSpPr>
         <p:spPr>
           <a:xfrm>
-            <a:off x="2978749" y="4378650"/>
-            <a:ext cx="235458" cy="94183"/>
+            <a:off x="2948305" y="4378960"/>
+            <a:ext cx="295910" cy="93980"/>
           </a:xfrm>
           <a:prstGeom prst="rect">
             <a:avLst/>
@@ -24425,7 +24823,7 @@
         </p:spPr>
         <p:txBody>
           <a:bodyPr wrap="square" lIns="36576" tIns="18288" rIns="36576" bIns="18288" anchor="t">
-            <a:spAutoFit/>
+            <a:noAutofit/>
           </a:bodyPr>
           <a:lstStyle/>
           <a:p>
@@ -24505,8 +24903,8 @@
         </p:nvSpPr>
         <p:spPr>
           <a:xfrm>
-            <a:off x="3581521" y="4378650"/>
-            <a:ext cx="235458" cy="94183"/>
+            <a:off x="3561080" y="4378960"/>
+            <a:ext cx="286385" cy="93980"/>
           </a:xfrm>
           <a:prstGeom prst="rect">
             <a:avLst/>
@@ -24515,7 +24913,7 @@
         </p:spPr>
         <p:txBody>
           <a:bodyPr wrap="square" lIns="36576" tIns="18288" rIns="36576" bIns="18288" anchor="t">
-            <a:spAutoFit/>
+            <a:noAutofit/>
           </a:bodyPr>
           <a:lstStyle/>
           <a:p>
@@ -24820,8 +25218,8 @@
         </p:nvSpPr>
         <p:spPr>
           <a:xfrm>
-            <a:off x="5925312" y="2779776"/>
-            <a:ext cx="1234440" cy="384048"/>
+            <a:off x="5944235" y="2780030"/>
+            <a:ext cx="1236345" cy="458470"/>
           </a:xfrm>
           <a:prstGeom prst="rect">
             <a:avLst/>
@@ -25123,6 +25521,50 @@
                 <a:srgbClr val="FFFFFF"/>
               </a:solidFill>
               <a:latin typeface="微软雅黑" panose="020B0503020204020204" charset="-122"/>
+            </a:endParaRPr>
+          </a:p>
+        </p:txBody>
+      </p:sp>
+      <p:sp>
+        <p:nvSpPr>
+          <p:cNvPr id="186" name="slide_page_number_codex"/>
+          <p:cNvSpPr txBox="1"/>
+          <p:nvPr/>
+        </p:nvSpPr>
+        <p:spPr>
+          <a:xfrm>
+            <a:off x="11350752" y="6528816"/>
+            <a:ext cx="713232" cy="182880"/>
+          </a:xfrm>
+          <a:prstGeom prst="rect">
+            <a:avLst/>
+          </a:prstGeom>
+          <a:noFill/>
+          <a:ln>
+            <a:noFill/>
+          </a:ln>
+        </p:spPr>
+        <p:txBody>
+          <a:bodyPr wrap="none" lIns="0" tIns="0" rIns="0" bIns="0">
+            <a:spAutoFit/>
+          </a:bodyPr>
+          <a:lstStyle/>
+          <a:p>
+            <a:pPr algn="r"/>
+            <a:r>
+              <a:rPr sz="800">
+                <a:solidFill>
+                  <a:srgbClr val="6B7280"/>
+                </a:solidFill>
+                <a:latin typeface="Aptos"/>
+              </a:rPr>
+              <a:t>03 / 16</a:t>
+            </a:r>
+            <a:endParaRPr sz="800">
+              <a:solidFill>
+                <a:srgbClr val="6B7280"/>
+              </a:solidFill>
+              <a:latin typeface="Aptos"/>
             </a:endParaRPr>
           </a:p>
         </p:txBody>
@@ -28214,6 +28656,50 @@
           </a:p>
         </p:txBody>
       </p:sp>
+      <p:sp>
+        <p:nvSpPr>
+          <p:cNvPr id="122" name="slide_page_number_codex"/>
+          <p:cNvSpPr txBox="1"/>
+          <p:nvPr/>
+        </p:nvSpPr>
+        <p:spPr>
+          <a:xfrm>
+            <a:off x="11350752" y="6528816"/>
+            <a:ext cx="713232" cy="182880"/>
+          </a:xfrm>
+          <a:prstGeom prst="rect">
+            <a:avLst/>
+          </a:prstGeom>
+          <a:noFill/>
+          <a:ln>
+            <a:noFill/>
+          </a:ln>
+        </p:spPr>
+        <p:txBody>
+          <a:bodyPr wrap="none" lIns="0" tIns="0" rIns="0" bIns="0">
+            <a:spAutoFit/>
+          </a:bodyPr>
+          <a:lstStyle/>
+          <a:p>
+            <a:pPr algn="r"/>
+            <a:r>
+              <a:rPr sz="800">
+                <a:solidFill>
+                  <a:srgbClr val="6B7280"/>
+                </a:solidFill>
+                <a:latin typeface="Aptos"/>
+              </a:rPr>
+              <a:t>04 / 16</a:t>
+            </a:r>
+            <a:endParaRPr sz="800">
+              <a:solidFill>
+                <a:srgbClr val="6B7280"/>
+              </a:solidFill>
+              <a:latin typeface="Aptos"/>
+            </a:endParaRPr>
+          </a:p>
+        </p:txBody>
+      </p:sp>
     </p:spTree>
     <p:custDataLst>
       <p:tags r:id="rId5"/>
@@ -29276,7 +29762,7 @@
         </p:nvSpPr>
         <p:spPr>
           <a:xfrm>
-            <a:off x="4023360" y="2148840"/>
+            <a:off x="4744720" y="2153285"/>
             <a:ext cx="2560320" cy="2240280"/>
           </a:xfrm>
           <a:prstGeom prst="roundRect">
@@ -29321,7 +29807,7 @@
         </p:nvSpPr>
         <p:spPr>
           <a:xfrm>
-            <a:off x="4206240" y="2331720"/>
+            <a:off x="4927600" y="2336165"/>
             <a:ext cx="2176272" cy="475488"/>
           </a:xfrm>
           <a:prstGeom prst="rect">
@@ -29366,7 +29852,7 @@
         </p:nvSpPr>
         <p:spPr>
           <a:xfrm>
-            <a:off x="4279392" y="2944368"/>
+            <a:off x="5000752" y="2948813"/>
             <a:ext cx="2057400" cy="219456"/>
           </a:xfrm>
           <a:prstGeom prst="rect">
@@ -29411,7 +29897,7 @@
         </p:nvSpPr>
         <p:spPr>
           <a:xfrm>
-            <a:off x="4251960" y="3401568"/>
+            <a:off x="4973320" y="3406013"/>
             <a:ext cx="2148840" cy="676656"/>
           </a:xfrm>
           <a:prstGeom prst="rect">
@@ -29456,7 +29942,7 @@
         </p:nvSpPr>
         <p:spPr>
           <a:xfrm>
-            <a:off x="7178040" y="2148840"/>
+            <a:off x="8437880" y="2153285"/>
             <a:ext cx="2560320" cy="2240280"/>
           </a:xfrm>
           <a:prstGeom prst="roundRect">
@@ -29501,7 +29987,7 @@
         </p:nvSpPr>
         <p:spPr>
           <a:xfrm>
-            <a:off x="7360919" y="2331720"/>
+            <a:off x="8620759" y="2336165"/>
             <a:ext cx="2176272" cy="475488"/>
           </a:xfrm>
           <a:prstGeom prst="rect">
@@ -29546,7 +30032,7 @@
         </p:nvSpPr>
         <p:spPr>
           <a:xfrm>
-            <a:off x="7434071" y="2944368"/>
+            <a:off x="8693911" y="2948813"/>
             <a:ext cx="2057400" cy="219456"/>
           </a:xfrm>
           <a:prstGeom prst="rect">
@@ -29591,7 +30077,7 @@
         </p:nvSpPr>
         <p:spPr>
           <a:xfrm>
-            <a:off x="7406640" y="3401568"/>
+            <a:off x="8666480" y="3406013"/>
             <a:ext cx="2148840" cy="676656"/>
           </a:xfrm>
           <a:prstGeom prst="rect">
@@ -29804,6 +30290,50 @@
                 <a:srgbClr val="FFFFFF"/>
               </a:solidFill>
               <a:latin typeface="微软雅黑" panose="020B0503020204020204" charset="-122"/>
+            </a:endParaRPr>
+          </a:p>
+        </p:txBody>
+      </p:sp>
+      <p:sp>
+        <p:nvSpPr>
+          <p:cNvPr id="109" name="slide_page_number_codex"/>
+          <p:cNvSpPr txBox="1"/>
+          <p:nvPr/>
+        </p:nvSpPr>
+        <p:spPr>
+          <a:xfrm>
+            <a:off x="11350752" y="6528816"/>
+            <a:ext cx="713232" cy="182880"/>
+          </a:xfrm>
+          <a:prstGeom prst="rect">
+            <a:avLst/>
+          </a:prstGeom>
+          <a:noFill/>
+          <a:ln>
+            <a:noFill/>
+          </a:ln>
+        </p:spPr>
+        <p:txBody>
+          <a:bodyPr wrap="none" lIns="0" tIns="0" rIns="0" bIns="0">
+            <a:spAutoFit/>
+          </a:bodyPr>
+          <a:lstStyle/>
+          <a:p>
+            <a:pPr algn="r"/>
+            <a:r>
+              <a:rPr sz="800">
+                <a:solidFill>
+                  <a:srgbClr val="6B7280"/>
+                </a:solidFill>
+                <a:latin typeface="Aptos"/>
+              </a:rPr>
+              <a:t>05 / 16</a:t>
+            </a:r>
+            <a:endParaRPr sz="800">
+              <a:solidFill>
+                <a:srgbClr val="6B7280"/>
+              </a:solidFill>
+              <a:latin typeface="Aptos"/>
             </a:endParaRPr>
           </a:p>
         </p:txBody>
@@ -31607,6 +32137,50 @@
           </a:p>
         </p:txBody>
       </p:sp>
+      <p:sp>
+        <p:nvSpPr>
+          <p:cNvPr id="114" name="slide_page_number_codex"/>
+          <p:cNvSpPr txBox="1"/>
+          <p:nvPr/>
+        </p:nvSpPr>
+        <p:spPr>
+          <a:xfrm>
+            <a:off x="11350752" y="6528816"/>
+            <a:ext cx="713232" cy="182880"/>
+          </a:xfrm>
+          <a:prstGeom prst="rect">
+            <a:avLst/>
+          </a:prstGeom>
+          <a:noFill/>
+          <a:ln>
+            <a:noFill/>
+          </a:ln>
+        </p:spPr>
+        <p:txBody>
+          <a:bodyPr wrap="none" lIns="0" tIns="0" rIns="0" bIns="0">
+            <a:spAutoFit/>
+          </a:bodyPr>
+          <a:lstStyle/>
+          <a:p>
+            <a:pPr algn="r"/>
+            <a:r>
+              <a:rPr sz="800">
+                <a:solidFill>
+                  <a:srgbClr val="6B7280"/>
+                </a:solidFill>
+                <a:latin typeface="Aptos"/>
+              </a:rPr>
+              <a:t>06 / 16</a:t>
+            </a:r>
+            <a:endParaRPr sz="800">
+              <a:solidFill>
+                <a:srgbClr val="6B7280"/>
+              </a:solidFill>
+              <a:latin typeface="Aptos"/>
+            </a:endParaRPr>
+          </a:p>
+        </p:txBody>
+      </p:sp>
     </p:spTree>
     <p:custDataLst>
       <p:tags r:id="rId5"/>
@@ -32639,7 +33213,7 @@
         <p:spPr>
           <a:xfrm>
             <a:off x="6985000" y="2565400"/>
-            <a:ext cx="4064000" cy="215444"/>
+            <a:ext cx="4064000" cy="215265"/>
           </a:xfrm>
           <a:prstGeom prst="rect">
             <a:avLst/>
@@ -32652,16 +33226,26 @@
           </a:bodyPr>
           <a:lstStyle/>
           <a:p>
-            <a:r>
-              <a:rPr sz="1000" b="1">
+            <a:pPr algn="ctr"/>
+            <a:r>
+              <a:rPr sz="1400" b="1">
                 <a:solidFill>
                   <a:srgbClr val="008080"/>
                 </a:solidFill>
                 <a:latin typeface="微软雅黑" panose="020B0503020204020204" charset="-122"/>
               </a:rPr>
-              <a:t>SABRE SWAP 搜索：局部候选选择</a:t>
-            </a:r>
-            <a:endParaRPr sz="1000" b="1">
+              <a:t>SABRE SWAP 搜索</a:t>
+            </a:r>
+            <a:r>
+              <a:rPr sz="1400" b="1">
+                <a:solidFill>
+                  <a:srgbClr val="008080"/>
+                </a:solidFill>
+                <a:latin typeface="微软雅黑" panose="020B0503020204020204" charset="-122"/>
+              </a:rPr>
+              <a:t>：局部候选选择</a:t>
+            </a:r>
+            <a:endParaRPr sz="1400" b="1">
               <a:solidFill>
                 <a:srgbClr val="008080"/>
               </a:solidFill>
@@ -32721,8 +33305,8 @@
         </p:nvSpPr>
         <p:spPr>
           <a:xfrm>
-            <a:off x="7848600" y="2946400"/>
-            <a:ext cx="2803525" cy="368935"/>
+            <a:off x="7539355" y="2946400"/>
+            <a:ext cx="3361055" cy="368935"/>
           </a:xfrm>
           <a:prstGeom prst="rect">
             <a:avLst/>
@@ -32742,7 +33326,25 @@
                 </a:solidFill>
                 <a:latin typeface="微软雅黑" panose="020B0503020204020204" charset="-122"/>
               </a:rPr>
-              <a:t>O(N^2.5) / gate</a:t>
+              <a:t>O(N^2.5) </a:t>
+            </a:r>
+            <a:r>
+              <a:rPr lang="en-US" sz="2400" b="1">
+                <a:solidFill>
+                  <a:srgbClr val="008983"/>
+                </a:solidFill>
+                <a:latin typeface="微软雅黑" panose="020B0503020204020204" charset="-122"/>
+              </a:rPr>
+              <a:t>per</a:t>
+            </a:r>
+            <a:r>
+              <a:rPr sz="2400" b="1">
+                <a:solidFill>
+                  <a:srgbClr val="008983"/>
+                </a:solidFill>
+                <a:latin typeface="微软雅黑" panose="020B0503020204020204" charset="-122"/>
+              </a:rPr>
+              <a:t> gate</a:t>
             </a:r>
             <a:endParaRPr sz="2400" b="1">
               <a:solidFill>
@@ -35905,6 +36507,50 @@
                 <a:srgbClr val="695A69"/>
               </a:solidFill>
               <a:latin typeface="微软雅黑" panose="020B0503020204020204" charset="-122"/>
+            </a:endParaRPr>
+          </a:p>
+        </p:txBody>
+      </p:sp>
+      <p:sp>
+        <p:nvSpPr>
+          <p:cNvPr id="201" name="slide_page_number_codex"/>
+          <p:cNvSpPr txBox="1"/>
+          <p:nvPr/>
+        </p:nvSpPr>
+        <p:spPr>
+          <a:xfrm>
+            <a:off x="11350752" y="6528816"/>
+            <a:ext cx="713232" cy="182880"/>
+          </a:xfrm>
+          <a:prstGeom prst="rect">
+            <a:avLst/>
+          </a:prstGeom>
+          <a:noFill/>
+          <a:ln>
+            <a:noFill/>
+          </a:ln>
+        </p:spPr>
+        <p:txBody>
+          <a:bodyPr wrap="none" lIns="0" tIns="0" rIns="0" bIns="0">
+            <a:spAutoFit/>
+          </a:bodyPr>
+          <a:lstStyle/>
+          <a:p>
+            <a:pPr algn="r"/>
+            <a:r>
+              <a:rPr sz="800">
+                <a:solidFill>
+                  <a:srgbClr val="6B7280"/>
+                </a:solidFill>
+                <a:latin typeface="Aptos"/>
+              </a:rPr>
+              <a:t>07 / 16</a:t>
+            </a:r>
+            <a:endParaRPr sz="800">
+              <a:solidFill>
+                <a:srgbClr val="6B7280"/>
+              </a:solidFill>
+              <a:latin typeface="Aptos"/>
             </a:endParaRPr>
           </a:p>
         </p:txBody>
@@ -38590,6 +39236,50 @@
           </a:p>
         </p:txBody>
       </p:sp>
+      <p:sp>
+        <p:nvSpPr>
+          <p:cNvPr id="88" name="slide_page_number_codex"/>
+          <p:cNvSpPr txBox="1"/>
+          <p:nvPr/>
+        </p:nvSpPr>
+        <p:spPr>
+          <a:xfrm>
+            <a:off x="11350752" y="6528816"/>
+            <a:ext cx="713232" cy="182880"/>
+          </a:xfrm>
+          <a:prstGeom prst="rect">
+            <a:avLst/>
+          </a:prstGeom>
+          <a:noFill/>
+          <a:ln>
+            <a:noFill/>
+          </a:ln>
+        </p:spPr>
+        <p:txBody>
+          <a:bodyPr wrap="none" lIns="0" tIns="0" rIns="0" bIns="0">
+            <a:spAutoFit/>
+          </a:bodyPr>
+          <a:lstStyle/>
+          <a:p>
+            <a:pPr algn="r"/>
+            <a:r>
+              <a:rPr sz="800">
+                <a:solidFill>
+                  <a:srgbClr val="6B7280"/>
+                </a:solidFill>
+                <a:latin typeface="Aptos"/>
+              </a:rPr>
+              <a:t>08 / 16</a:t>
+            </a:r>
+            <a:endParaRPr sz="800">
+              <a:solidFill>
+                <a:srgbClr val="6B7280"/>
+              </a:solidFill>
+              <a:latin typeface="Aptos"/>
+            </a:endParaRPr>
+          </a:p>
+        </p:txBody>
+      </p:sp>
     </p:spTree>
     <p:custDataLst>
       <p:tags r:id="rId5"/>
@@ -41368,6 +42058,50 @@
           </a:fontRef>
         </p:style>
       </p:cxnSp>
+      <p:sp>
+        <p:nvSpPr>
+          <p:cNvPr id="137" name="slide_page_number_codex"/>
+          <p:cNvSpPr txBox="1"/>
+          <p:nvPr/>
+        </p:nvSpPr>
+        <p:spPr>
+          <a:xfrm>
+            <a:off x="11350752" y="6528816"/>
+            <a:ext cx="713232" cy="182880"/>
+          </a:xfrm>
+          <a:prstGeom prst="rect">
+            <a:avLst/>
+          </a:prstGeom>
+          <a:noFill/>
+          <a:ln>
+            <a:noFill/>
+          </a:ln>
+        </p:spPr>
+        <p:txBody>
+          <a:bodyPr wrap="none" lIns="0" tIns="0" rIns="0" bIns="0">
+            <a:spAutoFit/>
+          </a:bodyPr>
+          <a:lstStyle/>
+          <a:p>
+            <a:pPr algn="r"/>
+            <a:r>
+              <a:rPr sz="800">
+                <a:solidFill>
+                  <a:srgbClr val="6B7280"/>
+                </a:solidFill>
+                <a:latin typeface="Aptos"/>
+              </a:rPr>
+              <a:t>09 / 16</a:t>
+            </a:r>
+            <a:endParaRPr sz="800">
+              <a:solidFill>
+                <a:srgbClr val="6B7280"/>
+              </a:solidFill>
+              <a:latin typeface="Aptos"/>
+            </a:endParaRPr>
+          </a:p>
+        </p:txBody>
+      </p:sp>
     </p:spTree>
     <p:custDataLst>
       <p:tags r:id="rId5"/>

</xml_diff>

<commit_message>
Remove animations from final presentation
</commit_message>
<xml_diff>
--- a/FinalProject/SABRE_Final_Presentation.pptx
+++ b/FinalProject/SABRE_Final_Presentation.pptx
@@ -4460,334 +4460,9 @@
     <a:masterClrMapping/>
   </p:clrMapOvr>
   <mc:AlternateContent xmlns:mc="http://schemas.openxmlformats.org/markup-compatibility/2006">
-    <mc:Choice xmlns:p14="http://schemas.microsoft.com/office/powerpoint/2010/main" Requires="p14">
-      <p:transition spd="slow" p14:dur="1500">
-        <p:split orient="vert"/>
-      </p:transition>
-    </mc:Choice>
-    <mc:Fallback>
-      <p:transition spd="slow">
-        <p:split orient="vert"/>
-      </p:transition>
-    </mc:Fallback>
+    <mc:Choice xmlns:p14="http://schemas.microsoft.com/office/powerpoint/2010/main" Requires="p14"/>
+    <mc:Fallback/>
   </mc:AlternateContent>
-  <p:timing>
-    <p:tnLst>
-      <p:par>
-        <p:cTn id="1" dur="indefinite" restart="never" nodeType="tmRoot">
-          <p:childTnLst>
-            <p:seq concurrent="1" nextAc="seek">
-              <p:cTn id="2" dur="indefinite" nodeType="mainSeq">
-                <p:childTnLst>
-                  <p:par>
-                    <p:cTn id="3" fill="hold">
-                      <p:stCondLst>
-                        <p:cond delay="indefinite"/>
-                        <p:cond evt="onBegin" delay="0">
-                          <p:tn val="2"/>
-                        </p:cond>
-                      </p:stCondLst>
-                      <p:childTnLst>
-                        <p:par>
-                          <p:cTn id="4" fill="hold">
-                            <p:stCondLst>
-                              <p:cond delay="0"/>
-                            </p:stCondLst>
-                            <p:childTnLst>
-                              <p:par>
-                                <p:cTn id="5" presetID="42" presetClass="entr" presetSubtype="0" fill="hold" grpId="0" nodeType="withEffect" nodePh="1">
-                                  <p:stCondLst>
-                                    <p:cond delay="0"/>
-                                  </p:stCondLst>
-                                  <p:endCondLst>
-                                    <p:cond evt="begin" delay="0">
-                                      <p:tn val="5"/>
-                                    </p:cond>
-                                  </p:endCondLst>
-                                  <p:childTnLst>
-                                    <p:set>
-                                      <p:cBhvr>
-                                        <p:cTn id="6" dur="1" fill="hold">
-                                          <p:stCondLst>
-                                            <p:cond delay="0"/>
-                                          </p:stCondLst>
-                                        </p:cTn>
-                                        <p:tgtEl>
-                                          <p:spTgt spid="38"/>
-                                        </p:tgtEl>
-                                        <p:attrNameLst>
-                                          <p:attrName>style.visibility</p:attrName>
-                                        </p:attrNameLst>
-                                      </p:cBhvr>
-                                      <p:to>
-                                        <p:strVal val="visible"/>
-                                      </p:to>
-                                    </p:set>
-                                    <p:animEffect transition="in" filter="fade">
-                                      <p:cBhvr>
-                                        <p:cTn id="7" dur="1000"/>
-                                        <p:tgtEl>
-                                          <p:spTgt spid="38"/>
-                                        </p:tgtEl>
-                                      </p:cBhvr>
-                                    </p:animEffect>
-                                    <p:anim calcmode="lin" valueType="num">
-                                      <p:cBhvr>
-                                        <p:cTn id="8" dur="1000" fill="hold"/>
-                                        <p:tgtEl>
-                                          <p:spTgt spid="38"/>
-                                        </p:tgtEl>
-                                        <p:attrNameLst>
-                                          <p:attrName>ppt_x</p:attrName>
-                                        </p:attrNameLst>
-                                      </p:cBhvr>
-                                      <p:tavLst>
-                                        <p:tav tm="0">
-                                          <p:val>
-                                            <p:strVal val="#ppt_x"/>
-                                          </p:val>
-                                        </p:tav>
-                                        <p:tav tm="100000">
-                                          <p:val>
-                                            <p:strVal val="#ppt_x"/>
-                                          </p:val>
-                                        </p:tav>
-                                      </p:tavLst>
-                                    </p:anim>
-                                    <p:anim calcmode="lin" valueType="num">
-                                      <p:cBhvr>
-                                        <p:cTn id="9" dur="1000" fill="hold"/>
-                                        <p:tgtEl>
-                                          <p:spTgt spid="38"/>
-                                        </p:tgtEl>
-                                        <p:attrNameLst>
-                                          <p:attrName>ppt_y</p:attrName>
-                                        </p:attrNameLst>
-                                      </p:cBhvr>
-                                      <p:tavLst>
-                                        <p:tav tm="0">
-                                          <p:val>
-                                            <p:strVal val="#ppt_y+.1"/>
-                                          </p:val>
-                                        </p:tav>
-                                        <p:tav tm="100000">
-                                          <p:val>
-                                            <p:strVal val="#ppt_y"/>
-                                          </p:val>
-                                        </p:tav>
-                                      </p:tavLst>
-                                    </p:anim>
-                                  </p:childTnLst>
-                                </p:cTn>
-                              </p:par>
-                              <p:par>
-                                <p:cTn id="10" presetID="42" presetClass="entr" presetSubtype="0" fill="hold" grpId="0" nodeType="withEffect" nodePh="1">
-                                  <p:stCondLst>
-                                    <p:cond delay="0"/>
-                                  </p:stCondLst>
-                                  <p:endCondLst>
-                                    <p:cond evt="begin" delay="0">
-                                      <p:tn val="10"/>
-                                    </p:cond>
-                                  </p:endCondLst>
-                                  <p:childTnLst>
-                                    <p:set>
-                                      <p:cBhvr>
-                                        <p:cTn id="11" dur="1" fill="hold">
-                                          <p:stCondLst>
-                                            <p:cond delay="0"/>
-                                          </p:stCondLst>
-                                        </p:cTn>
-                                        <p:tgtEl>
-                                          <p:spTgt spid="21"/>
-                                        </p:tgtEl>
-                                        <p:attrNameLst>
-                                          <p:attrName>style.visibility</p:attrName>
-                                        </p:attrNameLst>
-                                      </p:cBhvr>
-                                      <p:to>
-                                        <p:strVal val="visible"/>
-                                      </p:to>
-                                    </p:set>
-                                    <p:animEffect transition="in" filter="fade">
-                                      <p:cBhvr>
-                                        <p:cTn id="12" dur="1000"/>
-                                        <p:tgtEl>
-                                          <p:spTgt spid="21"/>
-                                        </p:tgtEl>
-                                      </p:cBhvr>
-                                    </p:animEffect>
-                                    <p:anim calcmode="lin" valueType="num">
-                                      <p:cBhvr>
-                                        <p:cTn id="13" dur="1000" fill="hold"/>
-                                        <p:tgtEl>
-                                          <p:spTgt spid="21"/>
-                                        </p:tgtEl>
-                                        <p:attrNameLst>
-                                          <p:attrName>ppt_x</p:attrName>
-                                        </p:attrNameLst>
-                                      </p:cBhvr>
-                                      <p:tavLst>
-                                        <p:tav tm="0">
-                                          <p:val>
-                                            <p:strVal val="#ppt_x"/>
-                                          </p:val>
-                                        </p:tav>
-                                        <p:tav tm="100000">
-                                          <p:val>
-                                            <p:strVal val="#ppt_x"/>
-                                          </p:val>
-                                        </p:tav>
-                                      </p:tavLst>
-                                    </p:anim>
-                                    <p:anim calcmode="lin" valueType="num">
-                                      <p:cBhvr>
-                                        <p:cTn id="14" dur="1000" fill="hold"/>
-                                        <p:tgtEl>
-                                          <p:spTgt spid="21"/>
-                                        </p:tgtEl>
-                                        <p:attrNameLst>
-                                          <p:attrName>ppt_y</p:attrName>
-                                        </p:attrNameLst>
-                                      </p:cBhvr>
-                                      <p:tavLst>
-                                        <p:tav tm="0">
-                                          <p:val>
-                                            <p:strVal val="#ppt_y+.1"/>
-                                          </p:val>
-                                        </p:tav>
-                                        <p:tav tm="100000">
-                                          <p:val>
-                                            <p:strVal val="#ppt_y"/>
-                                          </p:val>
-                                        </p:tav>
-                                      </p:tavLst>
-                                    </p:anim>
-                                  </p:childTnLst>
-                                </p:cTn>
-                              </p:par>
-                            </p:childTnLst>
-                          </p:cTn>
-                        </p:par>
-                        <p:par>
-                          <p:cTn id="15" fill="hold">
-                            <p:stCondLst>
-                              <p:cond delay="1000"/>
-                            </p:stCondLst>
-                            <p:childTnLst>
-                              <p:par>
-                                <p:cTn id="16" presetID="10" presetClass="entr" presetSubtype="0" fill="hold" grpId="0" nodeType="afterEffect">
-                                  <p:stCondLst>
-                                    <p:cond delay="0"/>
-                                  </p:stCondLst>
-                                  <p:childTnLst>
-                                    <p:set>
-                                      <p:cBhvr>
-                                        <p:cTn id="17" dur="1" fill="hold">
-                                          <p:stCondLst>
-                                            <p:cond delay="0"/>
-                                          </p:stCondLst>
-                                        </p:cTn>
-                                        <p:tgtEl>
-                                          <p:spTgt spid="17"/>
-                                        </p:tgtEl>
-                                        <p:attrNameLst>
-                                          <p:attrName>style.visibility</p:attrName>
-                                        </p:attrNameLst>
-                                      </p:cBhvr>
-                                      <p:to>
-                                        <p:strVal val="visible"/>
-                                      </p:to>
-                                    </p:set>
-                                    <p:animEffect transition="in" filter="fade">
-                                      <p:cBhvr>
-                                        <p:cTn id="18" dur="500"/>
-                                        <p:tgtEl>
-                                          <p:spTgt spid="17"/>
-                                        </p:tgtEl>
-                                      </p:cBhvr>
-                                    </p:animEffect>
-                                  </p:childTnLst>
-                                </p:cTn>
-                              </p:par>
-                            </p:childTnLst>
-                          </p:cTn>
-                        </p:par>
-                        <p:par>
-                          <p:cTn id="19" fill="hold">
-                            <p:stCondLst>
-                              <p:cond delay="1500"/>
-                            </p:stCondLst>
-                            <p:childTnLst>
-                              <p:par>
-                                <p:cTn id="20" presetID="10" presetClass="entr" presetSubtype="0" fill="hold" grpId="0" nodeType="afterEffect">
-                                  <p:stCondLst>
-                                    <p:cond delay="0"/>
-                                  </p:stCondLst>
-                                  <p:childTnLst>
-                                    <p:set>
-                                      <p:cBhvr>
-                                        <p:cTn id="21" dur="1" fill="hold">
-                                          <p:stCondLst>
-                                            <p:cond delay="0"/>
-                                          </p:stCondLst>
-                                        </p:cTn>
-                                        <p:tgtEl>
-                                          <p:spTgt spid="22"/>
-                                        </p:tgtEl>
-                                        <p:attrNameLst>
-                                          <p:attrName>style.visibility</p:attrName>
-                                        </p:attrNameLst>
-                                      </p:cBhvr>
-                                      <p:to>
-                                        <p:strVal val="visible"/>
-                                      </p:to>
-                                    </p:set>
-                                    <p:animEffect transition="in" filter="fade">
-                                      <p:cBhvr>
-                                        <p:cTn id="22" dur="500"/>
-                                        <p:tgtEl>
-                                          <p:spTgt spid="22"/>
-                                        </p:tgtEl>
-                                      </p:cBhvr>
-                                    </p:animEffect>
-                                  </p:childTnLst>
-                                </p:cTn>
-                              </p:par>
-                            </p:childTnLst>
-                          </p:cTn>
-                        </p:par>
-                      </p:childTnLst>
-                    </p:cTn>
-                  </p:par>
-                </p:childTnLst>
-              </p:cTn>
-              <p:prevCondLst>
-                <p:cond evt="onPrev" delay="0">
-                  <p:tgtEl>
-                    <p:sldTgt/>
-                  </p:tgtEl>
-                </p:cond>
-              </p:prevCondLst>
-              <p:nextCondLst>
-                <p:cond evt="onNext" delay="0">
-                  <p:tgtEl>
-                    <p:sldTgt/>
-                  </p:tgtEl>
-                </p:cond>
-              </p:nextCondLst>
-            </p:seq>
-          </p:childTnLst>
-        </p:cTn>
-      </p:par>
-    </p:tnLst>
-    <p:bldLst>
-      <p:bldP spid="17" grpId="0" animBg="1"/>
-      <p:bldP spid="22" grpId="0" animBg="1"/>
-      <p:bldP spid="38" grpId="0"/>
-      <p:bldP spid="21" grpId="0"/>
-    </p:bldLst>
-  </p:timing>
 </p:sld>
 </file>
 
@@ -6391,7 +6066,7 @@
           <a:lstStyle/>
           <a:p>
             <a:r>
-              <a:rPr sz="850" b="1">
+              <a:rPr sz="1100" b="1">
                 <a:solidFill>
                   <a:srgbClr val="FFFFFF"/>
                 </a:solidFill>
@@ -6399,7 +6074,7 @@
               </a:rPr>
               <a:t>启发式函数同时编码当前门距离、未来门影响和近期重叠 SWAP 惩罚。</a:t>
             </a:r>
-            <a:endParaRPr sz="850" b="1">
+            <a:endParaRPr sz="1100" b="1">
               <a:solidFill>
                 <a:srgbClr val="FFFFFF"/>
               </a:solidFill>
@@ -6932,151 +6607,9 @@
     <a:masterClrMapping/>
   </p:clrMapOvr>
   <mc:AlternateContent xmlns:mc="http://schemas.openxmlformats.org/markup-compatibility/2006" xmlns:p159="http://schemas.microsoft.com/office/powerpoint/2015/09/main">
-    <mc:Choice Requires="p159">
-      <p:transition xmlns:p14="http://schemas.microsoft.com/office/powerpoint/2010/main" spd="slow" p14:dur="2000">
-        <p159:morph option="byObject"/>
-      </p:transition>
-    </mc:Choice>
-    <mc:Fallback>
-      <p:transition spd="slow">
-        <p:fade/>
-      </p:transition>
-    </mc:Fallback>
+    <mc:Choice Requires="p159"/>
+    <mc:Fallback/>
   </mc:AlternateContent>
-  <p:timing>
-    <p:tnLst>
-      <p:par>
-        <p:cTn id="1" dur="indefinite" restart="never" nodeType="tmRoot">
-          <p:childTnLst>
-            <p:seq concurrent="1" nextAc="seek">
-              <p:cTn id="2" dur="indefinite" nodeType="mainSeq">
-                <p:childTnLst>
-                  <p:par>
-                    <p:cTn id="3" fill="hold">
-                      <p:stCondLst>
-                        <p:cond delay="indefinite"/>
-                        <p:cond evt="onBegin" delay="0">
-                          <p:tn val="2"/>
-                        </p:cond>
-                      </p:stCondLst>
-                      <p:childTnLst>
-                        <p:par>
-                          <p:cTn id="4" fill="hold">
-                            <p:stCondLst>
-                              <p:cond delay="0"/>
-                            </p:stCondLst>
-                            <p:childTnLst>
-                              <p:par>
-                                <p:cTn id="5" presetID="10" presetClass="entr" presetSubtype="0" fill="hold" grpId="0" nodeType="afterEffect">
-                                  <p:stCondLst>
-                                    <p:cond delay="0"/>
-                                  </p:stCondLst>
-                                  <p:childTnLst>
-                                    <p:set>
-                                      <p:cBhvr>
-                                        <p:cTn id="6" dur="1" fill="hold">
-                                          <p:stCondLst>
-                                            <p:cond delay="0"/>
-                                          </p:stCondLst>
-                                        </p:cTn>
-                                        <p:tgtEl>
-                                          <p:spTgt spid="64"/>
-                                        </p:tgtEl>
-                                        <p:attrNameLst>
-                                          <p:attrName>style.visibility</p:attrName>
-                                        </p:attrNameLst>
-                                      </p:cBhvr>
-                                      <p:to>
-                                        <p:strVal val="visible"/>
-                                      </p:to>
-                                    </p:set>
-                                    <p:animEffect transition="in" filter="fade">
-                                      <p:cBhvr>
-                                        <p:cTn id="7" dur="500"/>
-                                        <p:tgtEl>
-                                          <p:spTgt spid="64"/>
-                                        </p:tgtEl>
-                                      </p:cBhvr>
-                                    </p:animEffect>
-                                  </p:childTnLst>
-                                </p:cTn>
-                              </p:par>
-                            </p:childTnLst>
-                          </p:cTn>
-                        </p:par>
-                        <p:par>
-                          <p:cTn id="8" fill="hold">
-                            <p:stCondLst>
-                              <p:cond delay="500"/>
-                            </p:stCondLst>
-                            <p:childTnLst>
-                              <p:par>
-                                <p:cTn id="9" presetID="10" presetClass="entr" presetSubtype="0" fill="hold" grpId="0" nodeType="afterEffect">
-                                  <p:stCondLst>
-                                    <p:cond delay="0"/>
-                                  </p:stCondLst>
-                                  <p:childTnLst>
-                                    <p:set>
-                                      <p:cBhvr>
-                                        <p:cTn id="10" dur="1" fill="hold">
-                                          <p:stCondLst>
-                                            <p:cond delay="0"/>
-                                          </p:stCondLst>
-                                        </p:cTn>
-                                        <p:tgtEl>
-                                          <p:spTgt spid="87"/>
-                                        </p:tgtEl>
-                                        <p:attrNameLst>
-                                          <p:attrName>style.visibility</p:attrName>
-                                        </p:attrNameLst>
-                                      </p:cBhvr>
-                                      <p:to>
-                                        <p:strVal val="visible"/>
-                                      </p:to>
-                                    </p:set>
-                                    <p:animEffect transition="in" filter="fade">
-                                      <p:cBhvr>
-                                        <p:cTn id="11" dur="500"/>
-                                        <p:tgtEl>
-                                          <p:spTgt spid="87"/>
-                                        </p:tgtEl>
-                                      </p:cBhvr>
-                                    </p:animEffect>
-                                  </p:childTnLst>
-                                </p:cTn>
-                              </p:par>
-                            </p:childTnLst>
-                          </p:cTn>
-                        </p:par>
-                      </p:childTnLst>
-                    </p:cTn>
-                  </p:par>
-                </p:childTnLst>
-              </p:cTn>
-              <p:prevCondLst>
-                <p:cond evt="onPrev" delay="0">
-                  <p:tgtEl>
-                    <p:sldTgt/>
-                  </p:tgtEl>
-                </p:cond>
-              </p:prevCondLst>
-              <p:nextCondLst>
-                <p:cond evt="onNext" delay="0">
-                  <p:tgtEl>
-                    <p:sldTgt/>
-                  </p:tgtEl>
-                </p:cond>
-              </p:nextCondLst>
-            </p:seq>
-          </p:childTnLst>
-        </p:cTn>
-      </p:par>
-    </p:tnLst>
-    <p:bldLst>
-      <p:bldP spid="64" grpId="0" animBg="1"/>
-      <p:bldP spid="87" grpId="0" animBg="1"/>
-    </p:bldLst>
-  </p:timing>
 </p:sld>
 </file>
 
@@ -8900,151 +8433,9 @@
     <a:masterClrMapping/>
   </p:clrMapOvr>
   <mc:AlternateContent xmlns:mc="http://schemas.openxmlformats.org/markup-compatibility/2006" xmlns:p159="http://schemas.microsoft.com/office/powerpoint/2015/09/main">
-    <mc:Choice Requires="p159">
-      <p:transition xmlns:p14="http://schemas.microsoft.com/office/powerpoint/2010/main" spd="slow" p14:dur="2000">
-        <p159:morph option="byObject"/>
-      </p:transition>
-    </mc:Choice>
-    <mc:Fallback>
-      <p:transition spd="slow">
-        <p:fade/>
-      </p:transition>
-    </mc:Fallback>
+    <mc:Choice Requires="p159"/>
+    <mc:Fallback/>
   </mc:AlternateContent>
-  <p:timing>
-    <p:tnLst>
-      <p:par>
-        <p:cTn id="1" dur="indefinite" restart="never" nodeType="tmRoot">
-          <p:childTnLst>
-            <p:seq concurrent="1" nextAc="seek">
-              <p:cTn id="2" dur="indefinite" nodeType="mainSeq">
-                <p:childTnLst>
-                  <p:par>
-                    <p:cTn id="3" fill="hold">
-                      <p:stCondLst>
-                        <p:cond delay="indefinite"/>
-                        <p:cond evt="onBegin" delay="0">
-                          <p:tn val="2"/>
-                        </p:cond>
-                      </p:stCondLst>
-                      <p:childTnLst>
-                        <p:par>
-                          <p:cTn id="4" fill="hold">
-                            <p:stCondLst>
-                              <p:cond delay="0"/>
-                            </p:stCondLst>
-                            <p:childTnLst>
-                              <p:par>
-                                <p:cTn id="5" presetID="10" presetClass="entr" presetSubtype="0" fill="hold" grpId="0" nodeType="afterEffect">
-                                  <p:stCondLst>
-                                    <p:cond delay="0"/>
-                                  </p:stCondLst>
-                                  <p:childTnLst>
-                                    <p:set>
-                                      <p:cBhvr>
-                                        <p:cTn id="6" dur="1" fill="hold">
-                                          <p:stCondLst>
-                                            <p:cond delay="0"/>
-                                          </p:stCondLst>
-                                        </p:cTn>
-                                        <p:tgtEl>
-                                          <p:spTgt spid="64"/>
-                                        </p:tgtEl>
-                                        <p:attrNameLst>
-                                          <p:attrName>style.visibility</p:attrName>
-                                        </p:attrNameLst>
-                                      </p:cBhvr>
-                                      <p:to>
-                                        <p:strVal val="visible"/>
-                                      </p:to>
-                                    </p:set>
-                                    <p:animEffect transition="in" filter="fade">
-                                      <p:cBhvr>
-                                        <p:cTn id="7" dur="500"/>
-                                        <p:tgtEl>
-                                          <p:spTgt spid="64"/>
-                                        </p:tgtEl>
-                                      </p:cBhvr>
-                                    </p:animEffect>
-                                  </p:childTnLst>
-                                </p:cTn>
-                              </p:par>
-                            </p:childTnLst>
-                          </p:cTn>
-                        </p:par>
-                        <p:par>
-                          <p:cTn id="8" fill="hold">
-                            <p:stCondLst>
-                              <p:cond delay="500"/>
-                            </p:stCondLst>
-                            <p:childTnLst>
-                              <p:par>
-                                <p:cTn id="9" presetID="10" presetClass="entr" presetSubtype="0" fill="hold" grpId="0" nodeType="afterEffect">
-                                  <p:stCondLst>
-                                    <p:cond delay="0"/>
-                                  </p:stCondLst>
-                                  <p:childTnLst>
-                                    <p:set>
-                                      <p:cBhvr>
-                                        <p:cTn id="10" dur="1" fill="hold">
-                                          <p:stCondLst>
-                                            <p:cond delay="0"/>
-                                          </p:stCondLst>
-                                        </p:cTn>
-                                        <p:tgtEl>
-                                          <p:spTgt spid="87"/>
-                                        </p:tgtEl>
-                                        <p:attrNameLst>
-                                          <p:attrName>style.visibility</p:attrName>
-                                        </p:attrNameLst>
-                                      </p:cBhvr>
-                                      <p:to>
-                                        <p:strVal val="visible"/>
-                                      </p:to>
-                                    </p:set>
-                                    <p:animEffect transition="in" filter="fade">
-                                      <p:cBhvr>
-                                        <p:cTn id="11" dur="500"/>
-                                        <p:tgtEl>
-                                          <p:spTgt spid="87"/>
-                                        </p:tgtEl>
-                                      </p:cBhvr>
-                                    </p:animEffect>
-                                  </p:childTnLst>
-                                </p:cTn>
-                              </p:par>
-                            </p:childTnLst>
-                          </p:cTn>
-                        </p:par>
-                      </p:childTnLst>
-                    </p:cTn>
-                  </p:par>
-                </p:childTnLst>
-              </p:cTn>
-              <p:prevCondLst>
-                <p:cond evt="onPrev" delay="0">
-                  <p:tgtEl>
-                    <p:sldTgt/>
-                  </p:tgtEl>
-                </p:cond>
-              </p:prevCondLst>
-              <p:nextCondLst>
-                <p:cond evt="onNext" delay="0">
-                  <p:tgtEl>
-                    <p:sldTgt/>
-                  </p:tgtEl>
-                </p:cond>
-              </p:nextCondLst>
-            </p:seq>
-          </p:childTnLst>
-        </p:cTn>
-      </p:par>
-    </p:tnLst>
-    <p:bldLst>
-      <p:bldP spid="64" grpId="0" animBg="1"/>
-      <p:bldP spid="87" grpId="0" animBg="1"/>
-    </p:bldLst>
-  </p:timing>
 </p:sld>
 </file>
 
@@ -11528,151 +10919,9 @@
     <a:masterClrMapping/>
   </p:clrMapOvr>
   <mc:AlternateContent xmlns:mc="http://schemas.openxmlformats.org/markup-compatibility/2006" xmlns:p159="http://schemas.microsoft.com/office/powerpoint/2015/09/main">
-    <mc:Choice Requires="p159">
-      <p:transition xmlns:p14="http://schemas.microsoft.com/office/powerpoint/2010/main" spd="slow" p14:dur="2000">
-        <p159:morph option="byObject"/>
-      </p:transition>
-    </mc:Choice>
-    <mc:Fallback>
-      <p:transition spd="slow">
-        <p:fade/>
-      </p:transition>
-    </mc:Fallback>
+    <mc:Choice Requires="p159"/>
+    <mc:Fallback/>
   </mc:AlternateContent>
-  <p:timing>
-    <p:tnLst>
-      <p:par>
-        <p:cTn id="1" dur="indefinite" restart="never" nodeType="tmRoot">
-          <p:childTnLst>
-            <p:seq concurrent="1" nextAc="seek">
-              <p:cTn id="2" dur="indefinite" nodeType="mainSeq">
-                <p:childTnLst>
-                  <p:par>
-                    <p:cTn id="3" fill="hold">
-                      <p:stCondLst>
-                        <p:cond delay="indefinite"/>
-                        <p:cond evt="onBegin" delay="0">
-                          <p:tn val="2"/>
-                        </p:cond>
-                      </p:stCondLst>
-                      <p:childTnLst>
-                        <p:par>
-                          <p:cTn id="4" fill="hold">
-                            <p:stCondLst>
-                              <p:cond delay="0"/>
-                            </p:stCondLst>
-                            <p:childTnLst>
-                              <p:par>
-                                <p:cTn id="5" presetID="10" presetClass="entr" presetSubtype="0" fill="hold" grpId="0" nodeType="afterEffect">
-                                  <p:stCondLst>
-                                    <p:cond delay="0"/>
-                                  </p:stCondLst>
-                                  <p:childTnLst>
-                                    <p:set>
-                                      <p:cBhvr>
-                                        <p:cTn id="6" dur="1" fill="hold">
-                                          <p:stCondLst>
-                                            <p:cond delay="0"/>
-                                          </p:stCondLst>
-                                        </p:cTn>
-                                        <p:tgtEl>
-                                          <p:spTgt spid="64"/>
-                                        </p:tgtEl>
-                                        <p:attrNameLst>
-                                          <p:attrName>style.visibility</p:attrName>
-                                        </p:attrNameLst>
-                                      </p:cBhvr>
-                                      <p:to>
-                                        <p:strVal val="visible"/>
-                                      </p:to>
-                                    </p:set>
-                                    <p:animEffect transition="in" filter="fade">
-                                      <p:cBhvr>
-                                        <p:cTn id="7" dur="500"/>
-                                        <p:tgtEl>
-                                          <p:spTgt spid="64"/>
-                                        </p:tgtEl>
-                                      </p:cBhvr>
-                                    </p:animEffect>
-                                  </p:childTnLst>
-                                </p:cTn>
-                              </p:par>
-                            </p:childTnLst>
-                          </p:cTn>
-                        </p:par>
-                        <p:par>
-                          <p:cTn id="8" fill="hold">
-                            <p:stCondLst>
-                              <p:cond delay="500"/>
-                            </p:stCondLst>
-                            <p:childTnLst>
-                              <p:par>
-                                <p:cTn id="9" presetID="10" presetClass="entr" presetSubtype="0" fill="hold" grpId="0" nodeType="afterEffect">
-                                  <p:stCondLst>
-                                    <p:cond delay="0"/>
-                                  </p:stCondLst>
-                                  <p:childTnLst>
-                                    <p:set>
-                                      <p:cBhvr>
-                                        <p:cTn id="10" dur="1" fill="hold">
-                                          <p:stCondLst>
-                                            <p:cond delay="0"/>
-                                          </p:stCondLst>
-                                        </p:cTn>
-                                        <p:tgtEl>
-                                          <p:spTgt spid="87"/>
-                                        </p:tgtEl>
-                                        <p:attrNameLst>
-                                          <p:attrName>style.visibility</p:attrName>
-                                        </p:attrNameLst>
-                                      </p:cBhvr>
-                                      <p:to>
-                                        <p:strVal val="visible"/>
-                                      </p:to>
-                                    </p:set>
-                                    <p:animEffect transition="in" filter="fade">
-                                      <p:cBhvr>
-                                        <p:cTn id="11" dur="500"/>
-                                        <p:tgtEl>
-                                          <p:spTgt spid="87"/>
-                                        </p:tgtEl>
-                                      </p:cBhvr>
-                                    </p:animEffect>
-                                  </p:childTnLst>
-                                </p:cTn>
-                              </p:par>
-                            </p:childTnLst>
-                          </p:cTn>
-                        </p:par>
-                      </p:childTnLst>
-                    </p:cTn>
-                  </p:par>
-                </p:childTnLst>
-              </p:cTn>
-              <p:prevCondLst>
-                <p:cond evt="onPrev" delay="0">
-                  <p:tgtEl>
-                    <p:sldTgt/>
-                  </p:tgtEl>
-                </p:cond>
-              </p:prevCondLst>
-              <p:nextCondLst>
-                <p:cond evt="onNext" delay="0">
-                  <p:tgtEl>
-                    <p:sldTgt/>
-                  </p:tgtEl>
-                </p:cond>
-              </p:nextCondLst>
-            </p:seq>
-          </p:childTnLst>
-        </p:cTn>
-      </p:par>
-    </p:tnLst>
-    <p:bldLst>
-      <p:bldP spid="64" grpId="0" animBg="1"/>
-      <p:bldP spid="87" grpId="0" animBg="1"/>
-    </p:bldLst>
-  </p:timing>
 </p:sld>
 </file>
 
@@ -13591,151 +12840,9 @@
     <a:masterClrMapping/>
   </p:clrMapOvr>
   <mc:AlternateContent xmlns:mc="http://schemas.openxmlformats.org/markup-compatibility/2006" xmlns:p159="http://schemas.microsoft.com/office/powerpoint/2015/09/main">
-    <mc:Choice Requires="p159">
-      <p:transition xmlns:p14="http://schemas.microsoft.com/office/powerpoint/2010/main" spd="slow" p14:dur="2000">
-        <p159:morph option="byObject"/>
-      </p:transition>
-    </mc:Choice>
-    <mc:Fallback>
-      <p:transition spd="slow">
-        <p:fade/>
-      </p:transition>
-    </mc:Fallback>
+    <mc:Choice Requires="p159"/>
+    <mc:Fallback/>
   </mc:AlternateContent>
-  <p:timing>
-    <p:tnLst>
-      <p:par>
-        <p:cTn id="1" dur="indefinite" restart="never" nodeType="tmRoot">
-          <p:childTnLst>
-            <p:seq concurrent="1" nextAc="seek">
-              <p:cTn id="2" dur="indefinite" nodeType="mainSeq">
-                <p:childTnLst>
-                  <p:par>
-                    <p:cTn id="3" fill="hold">
-                      <p:stCondLst>
-                        <p:cond delay="indefinite"/>
-                        <p:cond evt="onBegin" delay="0">
-                          <p:tn val="2"/>
-                        </p:cond>
-                      </p:stCondLst>
-                      <p:childTnLst>
-                        <p:par>
-                          <p:cTn id="4" fill="hold">
-                            <p:stCondLst>
-                              <p:cond delay="0"/>
-                            </p:stCondLst>
-                            <p:childTnLst>
-                              <p:par>
-                                <p:cTn id="5" presetID="10" presetClass="entr" presetSubtype="0" fill="hold" grpId="0" nodeType="afterEffect">
-                                  <p:stCondLst>
-                                    <p:cond delay="0"/>
-                                  </p:stCondLst>
-                                  <p:childTnLst>
-                                    <p:set>
-                                      <p:cBhvr>
-                                        <p:cTn id="6" dur="1" fill="hold">
-                                          <p:stCondLst>
-                                            <p:cond delay="0"/>
-                                          </p:stCondLst>
-                                        </p:cTn>
-                                        <p:tgtEl>
-                                          <p:spTgt spid="64"/>
-                                        </p:tgtEl>
-                                        <p:attrNameLst>
-                                          <p:attrName>style.visibility</p:attrName>
-                                        </p:attrNameLst>
-                                      </p:cBhvr>
-                                      <p:to>
-                                        <p:strVal val="visible"/>
-                                      </p:to>
-                                    </p:set>
-                                    <p:animEffect transition="in" filter="fade">
-                                      <p:cBhvr>
-                                        <p:cTn id="7" dur="500"/>
-                                        <p:tgtEl>
-                                          <p:spTgt spid="64"/>
-                                        </p:tgtEl>
-                                      </p:cBhvr>
-                                    </p:animEffect>
-                                  </p:childTnLst>
-                                </p:cTn>
-                              </p:par>
-                            </p:childTnLst>
-                          </p:cTn>
-                        </p:par>
-                        <p:par>
-                          <p:cTn id="8" fill="hold">
-                            <p:stCondLst>
-                              <p:cond delay="500"/>
-                            </p:stCondLst>
-                            <p:childTnLst>
-                              <p:par>
-                                <p:cTn id="9" presetID="10" presetClass="entr" presetSubtype="0" fill="hold" grpId="0" nodeType="afterEffect">
-                                  <p:stCondLst>
-                                    <p:cond delay="0"/>
-                                  </p:stCondLst>
-                                  <p:childTnLst>
-                                    <p:set>
-                                      <p:cBhvr>
-                                        <p:cTn id="10" dur="1" fill="hold">
-                                          <p:stCondLst>
-                                            <p:cond delay="0"/>
-                                          </p:stCondLst>
-                                        </p:cTn>
-                                        <p:tgtEl>
-                                          <p:spTgt spid="87"/>
-                                        </p:tgtEl>
-                                        <p:attrNameLst>
-                                          <p:attrName>style.visibility</p:attrName>
-                                        </p:attrNameLst>
-                                      </p:cBhvr>
-                                      <p:to>
-                                        <p:strVal val="visible"/>
-                                      </p:to>
-                                    </p:set>
-                                    <p:animEffect transition="in" filter="fade">
-                                      <p:cBhvr>
-                                        <p:cTn id="11" dur="500"/>
-                                        <p:tgtEl>
-                                          <p:spTgt spid="87"/>
-                                        </p:tgtEl>
-                                      </p:cBhvr>
-                                    </p:animEffect>
-                                  </p:childTnLst>
-                                </p:cTn>
-                              </p:par>
-                            </p:childTnLst>
-                          </p:cTn>
-                        </p:par>
-                      </p:childTnLst>
-                    </p:cTn>
-                  </p:par>
-                </p:childTnLst>
-              </p:cTn>
-              <p:prevCondLst>
-                <p:cond evt="onPrev" delay="0">
-                  <p:tgtEl>
-                    <p:sldTgt/>
-                  </p:tgtEl>
-                </p:cond>
-              </p:prevCondLst>
-              <p:nextCondLst>
-                <p:cond evt="onNext" delay="0">
-                  <p:tgtEl>
-                    <p:sldTgt/>
-                  </p:tgtEl>
-                </p:cond>
-              </p:nextCondLst>
-            </p:seq>
-          </p:childTnLst>
-        </p:cTn>
-      </p:par>
-    </p:tnLst>
-    <p:bldLst>
-      <p:bldP spid="64" grpId="0" animBg="1"/>
-      <p:bldP spid="87" grpId="0" animBg="1"/>
-    </p:bldLst>
-  </p:timing>
 </p:sld>
 </file>
 
@@ -14456,7 +13563,7 @@
         </p:nvSpPr>
         <p:spPr>
           <a:xfrm>
-            <a:off x="1092200" y="2413000"/>
+            <a:off x="914400" y="2179320"/>
             <a:ext cx="3111500" cy="1968500"/>
           </a:xfrm>
           <a:prstGeom prst="roundRect">
@@ -14504,7 +13611,7 @@
         </p:nvSpPr>
         <p:spPr>
           <a:xfrm>
-            <a:off x="1270000" y="2578100"/>
+            <a:off x="1092200" y="2344420"/>
             <a:ext cx="2755900" cy="353943"/>
           </a:xfrm>
           <a:prstGeom prst="rect">
@@ -14545,7 +13652,7 @@
         </p:nvSpPr>
         <p:spPr>
           <a:xfrm>
-            <a:off x="1270000" y="3048000"/>
+            <a:off x="1092200" y="2814320"/>
             <a:ext cx="2755900" cy="192360"/>
           </a:xfrm>
           <a:prstGeom prst="rect">
@@ -14598,7 +13705,7 @@
         </p:nvSpPr>
         <p:spPr>
           <a:xfrm>
-            <a:off x="1320800" y="3365500"/>
+            <a:off x="1143000" y="3131820"/>
             <a:ext cx="2654300" cy="301621"/>
           </a:xfrm>
           <a:prstGeom prst="rect">
@@ -14638,7 +13745,7 @@
         </p:nvSpPr>
         <p:spPr>
           <a:xfrm>
-            <a:off x="4635500" y="2413000"/>
+            <a:off x="4457700" y="2179320"/>
             <a:ext cx="3111500" cy="1968500"/>
           </a:xfrm>
           <a:prstGeom prst="roundRect">
@@ -14686,7 +13793,7 @@
         </p:nvSpPr>
         <p:spPr>
           <a:xfrm>
-            <a:off x="4813300" y="2578100"/>
+            <a:off x="4635500" y="2344420"/>
             <a:ext cx="2755900" cy="353943"/>
           </a:xfrm>
           <a:prstGeom prst="rect">
@@ -14727,7 +13834,7 @@
         </p:nvSpPr>
         <p:spPr>
           <a:xfrm>
-            <a:off x="4813300" y="3048000"/>
+            <a:off x="4635500" y="2814320"/>
             <a:ext cx="2755900" cy="192360"/>
           </a:xfrm>
           <a:prstGeom prst="rect">
@@ -14780,7 +13887,7 @@
         </p:nvSpPr>
         <p:spPr>
           <a:xfrm>
-            <a:off x="4864100" y="3365500"/>
+            <a:off x="4686300" y="3131820"/>
             <a:ext cx="2654300" cy="301621"/>
           </a:xfrm>
           <a:prstGeom prst="rect">
@@ -14820,7 +13927,7 @@
         </p:nvSpPr>
         <p:spPr>
           <a:xfrm>
-            <a:off x="8178800" y="2413000"/>
+            <a:off x="8001000" y="2179320"/>
             <a:ext cx="3111500" cy="1968500"/>
           </a:xfrm>
           <a:prstGeom prst="roundRect">
@@ -14868,7 +13975,7 @@
         </p:nvSpPr>
         <p:spPr>
           <a:xfrm>
-            <a:off x="8356600" y="2578100"/>
+            <a:off x="8178800" y="2344420"/>
             <a:ext cx="2755900" cy="353943"/>
           </a:xfrm>
           <a:prstGeom prst="rect">
@@ -14911,7 +14018,7 @@
         </p:nvSpPr>
         <p:spPr>
           <a:xfrm>
-            <a:off x="8356600" y="3048000"/>
+            <a:off x="8178800" y="2814320"/>
             <a:ext cx="2755900" cy="192360"/>
           </a:xfrm>
           <a:prstGeom prst="rect">
@@ -14964,7 +14071,7 @@
         </p:nvSpPr>
         <p:spPr>
           <a:xfrm>
-            <a:off x="8407400" y="3365500"/>
+            <a:off x="8229600" y="3131820"/>
             <a:ext cx="2654300" cy="301621"/>
           </a:xfrm>
           <a:prstGeom prst="rect">
@@ -15004,7 +14111,7 @@
         </p:nvSpPr>
         <p:spPr>
           <a:xfrm>
-            <a:off x="1308100" y="4699000"/>
+            <a:off x="1130300" y="4465320"/>
             <a:ext cx="4635500" cy="838200"/>
           </a:xfrm>
           <a:prstGeom prst="roundRect">
@@ -15052,7 +14159,7 @@
         </p:nvSpPr>
         <p:spPr>
           <a:xfrm>
-            <a:off x="1485900" y="4864100"/>
+            <a:off x="1308100" y="4630420"/>
             <a:ext cx="4279900" cy="176972"/>
           </a:xfrm>
           <a:prstGeom prst="rect">
@@ -15093,7 +14200,7 @@
         </p:nvSpPr>
         <p:spPr>
           <a:xfrm>
-            <a:off x="1485900" y="5116830"/>
+            <a:off x="1308100" y="4883150"/>
             <a:ext cx="4279900" cy="276999"/>
           </a:xfrm>
           <a:prstGeom prst="rect">
@@ -15133,7 +14240,7 @@
         </p:nvSpPr>
         <p:spPr>
           <a:xfrm>
-            <a:off x="6477000" y="4699000"/>
+            <a:off x="6299200" y="4465320"/>
             <a:ext cx="4635500" cy="838200"/>
           </a:xfrm>
           <a:prstGeom prst="roundRect">
@@ -15181,7 +14288,7 @@
         </p:nvSpPr>
         <p:spPr>
           <a:xfrm>
-            <a:off x="6654800" y="4864100"/>
+            <a:off x="6477000" y="4630420"/>
             <a:ext cx="4279900" cy="176972"/>
           </a:xfrm>
           <a:prstGeom prst="rect">
@@ -15222,7 +14329,7 @@
         </p:nvSpPr>
         <p:spPr>
           <a:xfrm>
-            <a:off x="6654800" y="5116830"/>
+            <a:off x="6477000" y="4883150"/>
             <a:ext cx="4279900" cy="276999"/>
           </a:xfrm>
           <a:prstGeom prst="rect">
@@ -15348,151 +14455,9 @@
     <a:masterClrMapping/>
   </p:clrMapOvr>
   <mc:AlternateContent xmlns:mc="http://schemas.openxmlformats.org/markup-compatibility/2006" xmlns:p159="http://schemas.microsoft.com/office/powerpoint/2015/09/main">
-    <mc:Choice Requires="p159">
-      <p:transition xmlns:p14="http://schemas.microsoft.com/office/powerpoint/2010/main" spd="slow" p14:dur="2000">
-        <p159:morph option="byObject"/>
-      </p:transition>
-    </mc:Choice>
-    <mc:Fallback>
-      <p:transition spd="slow">
-        <p:fade/>
-      </p:transition>
-    </mc:Fallback>
+    <mc:Choice Requires="p159"/>
+    <mc:Fallback/>
   </mc:AlternateContent>
-  <p:timing>
-    <p:tnLst>
-      <p:par>
-        <p:cTn id="1" dur="indefinite" restart="never" nodeType="tmRoot">
-          <p:childTnLst>
-            <p:seq concurrent="1" nextAc="seek">
-              <p:cTn id="2" dur="indefinite" nodeType="mainSeq">
-                <p:childTnLst>
-                  <p:par>
-                    <p:cTn id="3" fill="hold">
-                      <p:stCondLst>
-                        <p:cond delay="indefinite"/>
-                        <p:cond evt="onBegin" delay="0">
-                          <p:tn val="2"/>
-                        </p:cond>
-                      </p:stCondLst>
-                      <p:childTnLst>
-                        <p:par>
-                          <p:cTn id="4" fill="hold">
-                            <p:stCondLst>
-                              <p:cond delay="0"/>
-                            </p:stCondLst>
-                            <p:childTnLst>
-                              <p:par>
-                                <p:cTn id="5" presetID="10" presetClass="entr" presetSubtype="0" fill="hold" grpId="0" nodeType="afterEffect">
-                                  <p:stCondLst>
-                                    <p:cond delay="0"/>
-                                  </p:stCondLst>
-                                  <p:childTnLst>
-                                    <p:set>
-                                      <p:cBhvr>
-                                        <p:cTn id="6" dur="1" fill="hold">
-                                          <p:stCondLst>
-                                            <p:cond delay="0"/>
-                                          </p:stCondLst>
-                                        </p:cTn>
-                                        <p:tgtEl>
-                                          <p:spTgt spid="64"/>
-                                        </p:tgtEl>
-                                        <p:attrNameLst>
-                                          <p:attrName>style.visibility</p:attrName>
-                                        </p:attrNameLst>
-                                      </p:cBhvr>
-                                      <p:to>
-                                        <p:strVal val="visible"/>
-                                      </p:to>
-                                    </p:set>
-                                    <p:animEffect transition="in" filter="fade">
-                                      <p:cBhvr>
-                                        <p:cTn id="7" dur="500"/>
-                                        <p:tgtEl>
-                                          <p:spTgt spid="64"/>
-                                        </p:tgtEl>
-                                      </p:cBhvr>
-                                    </p:animEffect>
-                                  </p:childTnLst>
-                                </p:cTn>
-                              </p:par>
-                            </p:childTnLst>
-                          </p:cTn>
-                        </p:par>
-                        <p:par>
-                          <p:cTn id="8" fill="hold">
-                            <p:stCondLst>
-                              <p:cond delay="500"/>
-                            </p:stCondLst>
-                            <p:childTnLst>
-                              <p:par>
-                                <p:cTn id="9" presetID="10" presetClass="entr" presetSubtype="0" fill="hold" grpId="0" nodeType="afterEffect">
-                                  <p:stCondLst>
-                                    <p:cond delay="0"/>
-                                  </p:stCondLst>
-                                  <p:childTnLst>
-                                    <p:set>
-                                      <p:cBhvr>
-                                        <p:cTn id="10" dur="1" fill="hold">
-                                          <p:stCondLst>
-                                            <p:cond delay="0"/>
-                                          </p:stCondLst>
-                                        </p:cTn>
-                                        <p:tgtEl>
-                                          <p:spTgt spid="87"/>
-                                        </p:tgtEl>
-                                        <p:attrNameLst>
-                                          <p:attrName>style.visibility</p:attrName>
-                                        </p:attrNameLst>
-                                      </p:cBhvr>
-                                      <p:to>
-                                        <p:strVal val="visible"/>
-                                      </p:to>
-                                    </p:set>
-                                    <p:animEffect transition="in" filter="fade">
-                                      <p:cBhvr>
-                                        <p:cTn id="11" dur="500"/>
-                                        <p:tgtEl>
-                                          <p:spTgt spid="87"/>
-                                        </p:tgtEl>
-                                      </p:cBhvr>
-                                    </p:animEffect>
-                                  </p:childTnLst>
-                                </p:cTn>
-                              </p:par>
-                            </p:childTnLst>
-                          </p:cTn>
-                        </p:par>
-                      </p:childTnLst>
-                    </p:cTn>
-                  </p:par>
-                </p:childTnLst>
-              </p:cTn>
-              <p:prevCondLst>
-                <p:cond evt="onPrev" delay="0">
-                  <p:tgtEl>
-                    <p:sldTgt/>
-                  </p:tgtEl>
-                </p:cond>
-              </p:prevCondLst>
-              <p:nextCondLst>
-                <p:cond evt="onNext" delay="0">
-                  <p:tgtEl>
-                    <p:sldTgt/>
-                  </p:tgtEl>
-                </p:cond>
-              </p:nextCondLst>
-            </p:seq>
-          </p:childTnLst>
-        </p:cTn>
-      </p:par>
-    </p:tnLst>
-    <p:bldLst>
-      <p:bldP spid="64" grpId="0" animBg="1"/>
-      <p:bldP spid="87" grpId="0" animBg="1"/>
-    </p:bldLst>
-  </p:timing>
 </p:sld>
 </file>
 
@@ -16950,151 +15915,9 @@
     <a:masterClrMapping/>
   </p:clrMapOvr>
   <mc:AlternateContent xmlns:mc="http://schemas.openxmlformats.org/markup-compatibility/2006" xmlns:p159="http://schemas.microsoft.com/office/powerpoint/2015/09/main">
-    <mc:Choice Requires="p159">
-      <p:transition xmlns:p14="http://schemas.microsoft.com/office/powerpoint/2010/main" spd="slow" p14:dur="2000">
-        <p159:morph option="byObject"/>
-      </p:transition>
-    </mc:Choice>
-    <mc:Fallback>
-      <p:transition spd="slow">
-        <p:fade/>
-      </p:transition>
-    </mc:Fallback>
+    <mc:Choice Requires="p159"/>
+    <mc:Fallback/>
   </mc:AlternateContent>
-  <p:timing>
-    <p:tnLst>
-      <p:par>
-        <p:cTn id="1" dur="indefinite" restart="never" nodeType="tmRoot">
-          <p:childTnLst>
-            <p:seq concurrent="1" nextAc="seek">
-              <p:cTn id="2" dur="indefinite" nodeType="mainSeq">
-                <p:childTnLst>
-                  <p:par>
-                    <p:cTn id="3" fill="hold">
-                      <p:stCondLst>
-                        <p:cond delay="indefinite"/>
-                        <p:cond evt="onBegin" delay="0">
-                          <p:tn val="2"/>
-                        </p:cond>
-                      </p:stCondLst>
-                      <p:childTnLst>
-                        <p:par>
-                          <p:cTn id="4" fill="hold">
-                            <p:stCondLst>
-                              <p:cond delay="0"/>
-                            </p:stCondLst>
-                            <p:childTnLst>
-                              <p:par>
-                                <p:cTn id="5" presetID="10" presetClass="entr" presetSubtype="0" fill="hold" grpId="0" nodeType="afterEffect">
-                                  <p:stCondLst>
-                                    <p:cond delay="0"/>
-                                  </p:stCondLst>
-                                  <p:childTnLst>
-                                    <p:set>
-                                      <p:cBhvr>
-                                        <p:cTn id="6" dur="1" fill="hold">
-                                          <p:stCondLst>
-                                            <p:cond delay="0"/>
-                                          </p:stCondLst>
-                                        </p:cTn>
-                                        <p:tgtEl>
-                                          <p:spTgt spid="64"/>
-                                        </p:tgtEl>
-                                        <p:attrNameLst>
-                                          <p:attrName>style.visibility</p:attrName>
-                                        </p:attrNameLst>
-                                      </p:cBhvr>
-                                      <p:to>
-                                        <p:strVal val="visible"/>
-                                      </p:to>
-                                    </p:set>
-                                    <p:animEffect transition="in" filter="fade">
-                                      <p:cBhvr>
-                                        <p:cTn id="7" dur="500"/>
-                                        <p:tgtEl>
-                                          <p:spTgt spid="64"/>
-                                        </p:tgtEl>
-                                      </p:cBhvr>
-                                    </p:animEffect>
-                                  </p:childTnLst>
-                                </p:cTn>
-                              </p:par>
-                            </p:childTnLst>
-                          </p:cTn>
-                        </p:par>
-                        <p:par>
-                          <p:cTn id="8" fill="hold">
-                            <p:stCondLst>
-                              <p:cond delay="500"/>
-                            </p:stCondLst>
-                            <p:childTnLst>
-                              <p:par>
-                                <p:cTn id="9" presetID="10" presetClass="entr" presetSubtype="0" fill="hold" grpId="0" nodeType="afterEffect">
-                                  <p:stCondLst>
-                                    <p:cond delay="0"/>
-                                  </p:stCondLst>
-                                  <p:childTnLst>
-                                    <p:set>
-                                      <p:cBhvr>
-                                        <p:cTn id="10" dur="1" fill="hold">
-                                          <p:stCondLst>
-                                            <p:cond delay="0"/>
-                                          </p:stCondLst>
-                                        </p:cTn>
-                                        <p:tgtEl>
-                                          <p:spTgt spid="87"/>
-                                        </p:tgtEl>
-                                        <p:attrNameLst>
-                                          <p:attrName>style.visibility</p:attrName>
-                                        </p:attrNameLst>
-                                      </p:cBhvr>
-                                      <p:to>
-                                        <p:strVal val="visible"/>
-                                      </p:to>
-                                    </p:set>
-                                    <p:animEffect transition="in" filter="fade">
-                                      <p:cBhvr>
-                                        <p:cTn id="11" dur="500"/>
-                                        <p:tgtEl>
-                                          <p:spTgt spid="87"/>
-                                        </p:tgtEl>
-                                      </p:cBhvr>
-                                    </p:animEffect>
-                                  </p:childTnLst>
-                                </p:cTn>
-                              </p:par>
-                            </p:childTnLst>
-                          </p:cTn>
-                        </p:par>
-                      </p:childTnLst>
-                    </p:cTn>
-                  </p:par>
-                </p:childTnLst>
-              </p:cTn>
-              <p:prevCondLst>
-                <p:cond evt="onPrev" delay="0">
-                  <p:tgtEl>
-                    <p:sldTgt/>
-                  </p:tgtEl>
-                </p:cond>
-              </p:prevCondLst>
-              <p:nextCondLst>
-                <p:cond evt="onNext" delay="0">
-                  <p:tgtEl>
-                    <p:sldTgt/>
-                  </p:tgtEl>
-                </p:cond>
-              </p:nextCondLst>
-            </p:seq>
-          </p:childTnLst>
-        </p:cTn>
-      </p:par>
-    </p:tnLst>
-    <p:bldLst>
-      <p:bldP spid="64" grpId="0" animBg="1"/>
-      <p:bldP spid="87" grpId="0" animBg="1"/>
-    </p:bldLst>
-  </p:timing>
 </p:sld>
 </file>
 
@@ -17466,39 +16289,6 @@
           </a:p>
         </p:txBody>
       </p:sp>
-      <p:pic>
-        <p:nvPicPr>
-          <p:cNvPr id="12" name="5fb7f4e6457c9">
-            <a:hlinkClick r:id="" action="ppaction://media"/>
-          </p:cNvPr>
-          <p:cNvPicPr>
-            <a:picLocks noChangeAspect="1"/>
-          </p:cNvPicPr>
-          <p:nvPr>
-            <a:audioFile r:link="rId2"/>
-            <p:extLst>
-              <p:ext uri="{DAA4B4D4-6D71-4841-9C94-3DE7FCFB9230}">
-                <p14:media xmlns:p14="http://schemas.microsoft.com/office/powerpoint/2010/main" r:embed="rId3"/>
-              </p:ext>
-            </p:extLst>
-          </p:nvPr>
-        </p:nvPicPr>
-        <p:blipFill>
-          <a:blip r:embed="rId4"/>
-          <a:stretch>
-            <a:fillRect/>
-          </a:stretch>
-        </p:blipFill>
-        <p:spPr>
-          <a:xfrm>
-            <a:off x="13017068" y="-65840"/>
-            <a:ext cx="609600" cy="609600"/>
-          </a:xfrm>
-          <a:prstGeom prst="rect">
-            <a:avLst/>
-          </a:prstGeom>
-        </p:spPr>
-      </p:pic>
       <p:grpSp>
         <p:nvGrpSpPr>
           <p:cNvPr id="13" name="组合 12"/>
@@ -17522,12 +16312,12 @@
             <p:nvPr userDrawn="1"/>
           </p:nvPicPr>
           <p:blipFill>
-            <a:blip r:embed="rId5" cstate="print">
+            <a:blip r:embed="rId2" cstate="print">
               <a:lum bright="70000" contrast="-70000"/>
               <a:extLst>
                 <a:ext uri="{BEBA8EAE-BF5A-486C-A8C5-ECC9F3942E4B}">
                   <a14:imgProps xmlns:a14="http://schemas.microsoft.com/office/drawing/2010/main">
-                    <a14:imgLayer r:embed="rId6">
+                    <a14:imgLayer r:embed="rId3">
                       <a14:imgEffect>
                         <a14:brightnessContrast bright="12000" contrast="-40000"/>
                       </a14:imgEffect>
@@ -17568,7 +16358,7 @@
             <p:nvPr/>
           </p:nvPicPr>
           <p:blipFill rotWithShape="1">
-            <a:blip r:embed="rId7">
+            <a:blip r:embed="rId4">
               <a:biLevel thresh="25000"/>
             </a:blip>
             <a:srcRect l="30188"/>
@@ -17645,7 +16435,7 @@
           <p:nvPr/>
         </p:nvPicPr>
         <p:blipFill>
-          <a:blip r:embed="rId8" cstate="print">
+          <a:blip r:embed="rId5" cstate="print">
             <a:lum bright="70000" contrast="-70000"/>
             <a:extLst>
               <a:ext uri="{28A0092B-C50C-407E-A947-70E740481C1C}">
@@ -17843,370 +16633,9 @@
     <a:masterClrMapping/>
   </p:clrMapOvr>
   <mc:AlternateContent xmlns:mc="http://schemas.openxmlformats.org/markup-compatibility/2006">
-    <mc:Choice xmlns:p14="http://schemas.microsoft.com/office/powerpoint/2010/main" Requires="p14">
-      <p:transition spd="slow" p14:dur="1500">
-        <p:split orient="vert"/>
-      </p:transition>
-    </mc:Choice>
-    <mc:Fallback>
-      <p:transition spd="slow">
-        <p:split orient="vert"/>
-      </p:transition>
-    </mc:Fallback>
+    <mc:Choice xmlns:p14="http://schemas.microsoft.com/office/powerpoint/2010/main" Requires="p14"/>
+    <mc:Fallback/>
   </mc:AlternateContent>
-  <p:timing>
-    <p:tnLst>
-      <p:par>
-        <p:cTn id="1" dur="indefinite" restart="never" nodeType="tmRoot">
-          <p:childTnLst>
-            <p:seq concurrent="1" nextAc="seek">
-              <p:cTn id="2" dur="indefinite" nodeType="mainSeq">
-                <p:childTnLst>
-                  <p:par>
-                    <p:cTn id="3" fill="hold">
-                      <p:stCondLst>
-                        <p:cond delay="indefinite"/>
-                        <p:cond evt="onBegin" delay="0">
-                          <p:tn val="2"/>
-                        </p:cond>
-                      </p:stCondLst>
-                      <p:childTnLst>
-                        <p:par>
-                          <p:cTn id="4" fill="hold">
-                            <p:stCondLst>
-                              <p:cond delay="0"/>
-                            </p:stCondLst>
-                            <p:childTnLst>
-                              <p:par>
-                                <p:cTn id="5" presetID="1" presetClass="mediacall" presetSubtype="0" fill="hold" nodeType="afterEffect">
-                                  <p:stCondLst>
-                                    <p:cond delay="0"/>
-                                  </p:stCondLst>
-                                  <p:childTnLst>
-                                    <p:cmd type="call" cmd="playFrom(0.0)">
-                                      <p:cBhvr>
-                                        <p:cTn id="6" dur="1" fill="hold"/>
-                                        <p:tgtEl>
-                                          <p:spTgt spid="12"/>
-                                        </p:tgtEl>
-                                      </p:cBhvr>
-                                    </p:cmd>
-                                  </p:childTnLst>
-                                </p:cTn>
-                              </p:par>
-                              <p:par>
-                                <p:cTn id="7" presetID="42" presetClass="entr" presetSubtype="0" fill="hold" grpId="0" nodeType="withEffect" nodePh="1">
-                                  <p:stCondLst>
-                                    <p:cond delay="0"/>
-                                  </p:stCondLst>
-                                  <p:endCondLst>
-                                    <p:cond evt="begin" delay="0">
-                                      <p:tn val="7"/>
-                                    </p:cond>
-                                  </p:endCondLst>
-                                  <p:childTnLst>
-                                    <p:set>
-                                      <p:cBhvr>
-                                        <p:cTn id="8" dur="1" fill="hold">
-                                          <p:stCondLst>
-                                            <p:cond delay="0"/>
-                                          </p:stCondLst>
-                                        </p:cTn>
-                                        <p:tgtEl>
-                                          <p:spTgt spid="38"/>
-                                        </p:tgtEl>
-                                        <p:attrNameLst>
-                                          <p:attrName>style.visibility</p:attrName>
-                                        </p:attrNameLst>
-                                      </p:cBhvr>
-                                      <p:to>
-                                        <p:strVal val="visible"/>
-                                      </p:to>
-                                    </p:set>
-                                    <p:animEffect transition="in" filter="fade">
-                                      <p:cBhvr>
-                                        <p:cTn id="9" dur="1000"/>
-                                        <p:tgtEl>
-                                          <p:spTgt spid="38"/>
-                                        </p:tgtEl>
-                                      </p:cBhvr>
-                                    </p:animEffect>
-                                    <p:anim calcmode="lin" valueType="num">
-                                      <p:cBhvr>
-                                        <p:cTn id="10" dur="1000" fill="hold"/>
-                                        <p:tgtEl>
-                                          <p:spTgt spid="38"/>
-                                        </p:tgtEl>
-                                        <p:attrNameLst>
-                                          <p:attrName>ppt_x</p:attrName>
-                                        </p:attrNameLst>
-                                      </p:cBhvr>
-                                      <p:tavLst>
-                                        <p:tav tm="0">
-                                          <p:val>
-                                            <p:strVal val="#ppt_x"/>
-                                          </p:val>
-                                        </p:tav>
-                                        <p:tav tm="100000">
-                                          <p:val>
-                                            <p:strVal val="#ppt_x"/>
-                                          </p:val>
-                                        </p:tav>
-                                      </p:tavLst>
-                                    </p:anim>
-                                    <p:anim calcmode="lin" valueType="num">
-                                      <p:cBhvr>
-                                        <p:cTn id="11" dur="1000" fill="hold"/>
-                                        <p:tgtEl>
-                                          <p:spTgt spid="38"/>
-                                        </p:tgtEl>
-                                        <p:attrNameLst>
-                                          <p:attrName>ppt_y</p:attrName>
-                                        </p:attrNameLst>
-                                      </p:cBhvr>
-                                      <p:tavLst>
-                                        <p:tav tm="0">
-                                          <p:val>
-                                            <p:strVal val="#ppt_y+.1"/>
-                                          </p:val>
-                                        </p:tav>
-                                        <p:tav tm="100000">
-                                          <p:val>
-                                            <p:strVal val="#ppt_y"/>
-                                          </p:val>
-                                        </p:tav>
-                                      </p:tavLst>
-                                    </p:anim>
-                                  </p:childTnLst>
-                                </p:cTn>
-                              </p:par>
-                              <p:par>
-                                <p:cTn id="12" presetID="42" presetClass="entr" presetSubtype="0" fill="hold" grpId="0" nodeType="withEffect" nodePh="1">
-                                  <p:stCondLst>
-                                    <p:cond delay="0"/>
-                                  </p:stCondLst>
-                                  <p:endCondLst>
-                                    <p:cond evt="begin" delay="0">
-                                      <p:tn val="12"/>
-                                    </p:cond>
-                                  </p:endCondLst>
-                                  <p:childTnLst>
-                                    <p:set>
-                                      <p:cBhvr>
-                                        <p:cTn id="13" dur="1" fill="hold">
-                                          <p:stCondLst>
-                                            <p:cond delay="0"/>
-                                          </p:stCondLst>
-                                        </p:cTn>
-                                        <p:tgtEl>
-                                          <p:spTgt spid="21"/>
-                                        </p:tgtEl>
-                                        <p:attrNameLst>
-                                          <p:attrName>style.visibility</p:attrName>
-                                        </p:attrNameLst>
-                                      </p:cBhvr>
-                                      <p:to>
-                                        <p:strVal val="visible"/>
-                                      </p:to>
-                                    </p:set>
-                                    <p:animEffect transition="in" filter="fade">
-                                      <p:cBhvr>
-                                        <p:cTn id="14" dur="1000"/>
-                                        <p:tgtEl>
-                                          <p:spTgt spid="21"/>
-                                        </p:tgtEl>
-                                      </p:cBhvr>
-                                    </p:animEffect>
-                                    <p:anim calcmode="lin" valueType="num">
-                                      <p:cBhvr>
-                                        <p:cTn id="15" dur="1000" fill="hold"/>
-                                        <p:tgtEl>
-                                          <p:spTgt spid="21"/>
-                                        </p:tgtEl>
-                                        <p:attrNameLst>
-                                          <p:attrName>ppt_x</p:attrName>
-                                        </p:attrNameLst>
-                                      </p:cBhvr>
-                                      <p:tavLst>
-                                        <p:tav tm="0">
-                                          <p:val>
-                                            <p:strVal val="#ppt_x"/>
-                                          </p:val>
-                                        </p:tav>
-                                        <p:tav tm="100000">
-                                          <p:val>
-                                            <p:strVal val="#ppt_x"/>
-                                          </p:val>
-                                        </p:tav>
-                                      </p:tavLst>
-                                    </p:anim>
-                                    <p:anim calcmode="lin" valueType="num">
-                                      <p:cBhvr>
-                                        <p:cTn id="16" dur="1000" fill="hold"/>
-                                        <p:tgtEl>
-                                          <p:spTgt spid="21"/>
-                                        </p:tgtEl>
-                                        <p:attrNameLst>
-                                          <p:attrName>ppt_y</p:attrName>
-                                        </p:attrNameLst>
-                                      </p:cBhvr>
-                                      <p:tavLst>
-                                        <p:tav tm="0">
-                                          <p:val>
-                                            <p:strVal val="#ppt_y+.1"/>
-                                          </p:val>
-                                        </p:tav>
-                                        <p:tav tm="100000">
-                                          <p:val>
-                                            <p:strVal val="#ppt_y"/>
-                                          </p:val>
-                                        </p:tav>
-                                      </p:tavLst>
-                                    </p:anim>
-                                  </p:childTnLst>
-                                </p:cTn>
-                              </p:par>
-                            </p:childTnLst>
-                          </p:cTn>
-                        </p:par>
-                        <p:par>
-                          <p:cTn id="17" fill="hold">
-                            <p:stCondLst>
-                              <p:cond delay="0"/>
-                            </p:stCondLst>
-                            <p:childTnLst>
-                              <p:par>
-                                <p:cTn id="18" presetID="10" presetClass="entr" presetSubtype="0" fill="hold" grpId="0" nodeType="afterEffect">
-                                  <p:stCondLst>
-                                    <p:cond delay="0"/>
-                                  </p:stCondLst>
-                                  <p:childTnLst>
-                                    <p:set>
-                                      <p:cBhvr>
-                                        <p:cTn id="19" dur="1" fill="hold">
-                                          <p:stCondLst>
-                                            <p:cond delay="0"/>
-                                          </p:stCondLst>
-                                        </p:cTn>
-                                        <p:tgtEl>
-                                          <p:spTgt spid="17"/>
-                                        </p:tgtEl>
-                                        <p:attrNameLst>
-                                          <p:attrName>style.visibility</p:attrName>
-                                        </p:attrNameLst>
-                                      </p:cBhvr>
-                                      <p:to>
-                                        <p:strVal val="visible"/>
-                                      </p:to>
-                                    </p:set>
-                                    <p:animEffect transition="in" filter="fade">
-                                      <p:cBhvr>
-                                        <p:cTn id="20" dur="500"/>
-                                        <p:tgtEl>
-                                          <p:spTgt spid="17"/>
-                                        </p:tgtEl>
-                                      </p:cBhvr>
-                                    </p:animEffect>
-                                  </p:childTnLst>
-                                </p:cTn>
-                              </p:par>
-                            </p:childTnLst>
-                          </p:cTn>
-                        </p:par>
-                        <p:par>
-                          <p:cTn id="21" fill="hold">
-                            <p:stCondLst>
-                              <p:cond delay="500"/>
-                            </p:stCondLst>
-                            <p:childTnLst>
-                              <p:par>
-                                <p:cTn id="22" presetID="10" presetClass="entr" presetSubtype="0" fill="hold" grpId="0" nodeType="afterEffect">
-                                  <p:stCondLst>
-                                    <p:cond delay="0"/>
-                                  </p:stCondLst>
-                                  <p:childTnLst>
-                                    <p:set>
-                                      <p:cBhvr>
-                                        <p:cTn id="23" dur="1" fill="hold">
-                                          <p:stCondLst>
-                                            <p:cond delay="0"/>
-                                          </p:stCondLst>
-                                        </p:cTn>
-                                        <p:tgtEl>
-                                          <p:spTgt spid="22"/>
-                                        </p:tgtEl>
-                                        <p:attrNameLst>
-                                          <p:attrName>style.visibility</p:attrName>
-                                        </p:attrNameLst>
-                                      </p:cBhvr>
-                                      <p:to>
-                                        <p:strVal val="visible"/>
-                                      </p:to>
-                                    </p:set>
-                                    <p:animEffect transition="in" filter="fade">
-                                      <p:cBhvr>
-                                        <p:cTn id="24" dur="500"/>
-                                        <p:tgtEl>
-                                          <p:spTgt spid="22"/>
-                                        </p:tgtEl>
-                                      </p:cBhvr>
-                                    </p:animEffect>
-                                  </p:childTnLst>
-                                </p:cTn>
-                              </p:par>
-                            </p:childTnLst>
-                          </p:cTn>
-                        </p:par>
-                      </p:childTnLst>
-                    </p:cTn>
-                  </p:par>
-                </p:childTnLst>
-              </p:cTn>
-              <p:prevCondLst>
-                <p:cond evt="onPrev" delay="0">
-                  <p:tgtEl>
-                    <p:sldTgt/>
-                  </p:tgtEl>
-                </p:cond>
-              </p:prevCondLst>
-              <p:nextCondLst>
-                <p:cond evt="onNext" delay="0">
-                  <p:tgtEl>
-                    <p:sldTgt/>
-                  </p:tgtEl>
-                </p:cond>
-              </p:nextCondLst>
-            </p:seq>
-            <p:audio>
-              <p:cMediaNode vol="80000" numSld="999" showWhenStopped="0">
-                <p:cTn id="25" repeatCount="indefinite" fill="remove" display="0">
-                  <p:stCondLst>
-                    <p:cond delay="indefinite"/>
-                  </p:stCondLst>
-                  <p:endCondLst>
-                    <p:cond evt="onStopAudio" delay="0">
-                      <p:tgtEl>
-                        <p:sldTgt/>
-                      </p:tgtEl>
-                    </p:cond>
-                  </p:endCondLst>
-                </p:cTn>
-                <p:tgtEl>
-                  <p:spTgt spid="12"/>
-                </p:tgtEl>
-              </p:cMediaNode>
-            </p:audio>
-          </p:childTnLst>
-        </p:cTn>
-      </p:par>
-    </p:tnLst>
-    <p:bldLst>
-      <p:bldP spid="17" grpId="0" animBg="1"/>
-      <p:bldP spid="22" grpId="0" animBg="1"/>
-      <p:bldP spid="38" grpId="0"/>
-      <p:bldP spid="21" grpId="0"/>
-    </p:bldLst>
-  </p:timing>
 </p:sld>
 </file>
 
@@ -20815,191 +19244,9 @@
     <a:masterClrMapping/>
   </p:clrMapOvr>
   <mc:AlternateContent xmlns:mc="http://schemas.openxmlformats.org/markup-compatibility/2006">
-    <mc:Choice xmlns:p14="http://schemas.microsoft.com/office/powerpoint/2010/main" Requires="p14">
-      <p:transition spd="slow" p14:dur="1500">
-        <p:split orient="vert"/>
-      </p:transition>
-    </mc:Choice>
-    <mc:Fallback>
-      <p:transition spd="slow">
-        <p:split orient="vert"/>
-      </p:transition>
-    </mc:Fallback>
+    <mc:Choice xmlns:p14="http://schemas.microsoft.com/office/powerpoint/2010/main" Requires="p14"/>
+    <mc:Fallback/>
   </mc:AlternateContent>
-  <p:timing>
-    <p:tnLst>
-      <p:par>
-        <p:cTn id="1" dur="indefinite" restart="never" nodeType="tmRoot">
-          <p:childTnLst>
-            <p:seq concurrent="1" nextAc="seek">
-              <p:cTn id="2" dur="indefinite" nodeType="mainSeq">
-                <p:childTnLst>
-                  <p:par>
-                    <p:cTn id="3" fill="hold">
-                      <p:stCondLst>
-                        <p:cond delay="indefinite"/>
-                        <p:cond evt="onBegin" delay="0">
-                          <p:tn val="2"/>
-                        </p:cond>
-                      </p:stCondLst>
-                      <p:childTnLst>
-                        <p:par>
-                          <p:cTn id="4" fill="hold">
-                            <p:stCondLst>
-                              <p:cond delay="0"/>
-                            </p:stCondLst>
-                            <p:childTnLst>
-                              <p:par>
-                                <p:cTn id="5" presetID="22" presetClass="entr" presetSubtype="8" fill="hold" nodeType="afterEffect">
-                                  <p:stCondLst>
-                                    <p:cond delay="0"/>
-                                  </p:stCondLst>
-                                  <p:childTnLst>
-                                    <p:set>
-                                      <p:cBhvr>
-                                        <p:cTn id="6" dur="1" fill="hold">
-                                          <p:stCondLst>
-                                            <p:cond delay="0"/>
-                                          </p:stCondLst>
-                                        </p:cTn>
-                                        <p:tgtEl>
-                                          <p:spTgt spid="18"/>
-                                        </p:tgtEl>
-                                        <p:attrNameLst>
-                                          <p:attrName>style.visibility</p:attrName>
-                                        </p:attrNameLst>
-                                      </p:cBhvr>
-                                      <p:to>
-                                        <p:strVal val="visible"/>
-                                      </p:to>
-                                    </p:set>
-                                    <p:animEffect transition="in" filter="wipe(left)">
-                                      <p:cBhvr>
-                                        <p:cTn id="7" dur="750"/>
-                                        <p:tgtEl>
-                                          <p:spTgt spid="18"/>
-                                        </p:tgtEl>
-                                      </p:cBhvr>
-                                    </p:animEffect>
-                                  </p:childTnLst>
-                                </p:cTn>
-                              </p:par>
-                            </p:childTnLst>
-                          </p:cTn>
-                        </p:par>
-                        <p:par>
-                          <p:cTn id="8" fill="hold">
-                            <p:stCondLst>
-                              <p:cond delay="1000"/>
-                            </p:stCondLst>
-                            <p:childTnLst>
-                              <p:par>
-                                <p:cTn id="9" presetID="22" presetClass="entr" presetSubtype="8" fill="hold" nodeType="afterEffect">
-                                  <p:stCondLst>
-                                    <p:cond delay="0"/>
-                                  </p:stCondLst>
-                                  <p:childTnLst>
-                                    <p:set>
-                                      <p:cBhvr>
-                                        <p:cTn id="10" dur="1" fill="hold">
-                                          <p:stCondLst>
-                                            <p:cond delay="0"/>
-                                          </p:stCondLst>
-                                        </p:cTn>
-                                        <p:tgtEl>
-                                          <p:spTgt spid="36"/>
-                                        </p:tgtEl>
-                                        <p:attrNameLst>
-                                          <p:attrName>style.visibility</p:attrName>
-                                        </p:attrNameLst>
-                                      </p:cBhvr>
-                                      <p:to>
-                                        <p:strVal val="visible"/>
-                                      </p:to>
-                                    </p:set>
-                                    <p:animEffect transition="in" filter="wipe(left)">
-                                      <p:cBhvr>
-                                        <p:cTn id="11" dur="750"/>
-                                        <p:tgtEl>
-                                          <p:spTgt spid="36"/>
-                                        </p:tgtEl>
-                                      </p:cBhvr>
-                                    </p:animEffect>
-                                  </p:childTnLst>
-                                </p:cTn>
-                              </p:par>
-                            </p:childTnLst>
-                          </p:cTn>
-                        </p:par>
-                        <p:par>
-                          <p:cTn id="12" fill="hold">
-                            <p:stCondLst>
-                              <p:cond delay="2000"/>
-                            </p:stCondLst>
-                            <p:childTnLst>
-                              <p:par>
-                                <p:cTn id="13" presetID="22" presetClass="entr" presetSubtype="8" fill="hold" nodeType="afterEffect">
-                                  <p:stCondLst>
-                                    <p:cond delay="0"/>
-                                  </p:stCondLst>
-                                  <p:childTnLst>
-                                    <p:set>
-                                      <p:cBhvr>
-                                        <p:cTn id="14" dur="1" fill="hold">
-                                          <p:stCondLst>
-                                            <p:cond delay="0"/>
-                                          </p:stCondLst>
-                                        </p:cTn>
-                                        <p:tgtEl>
-                                          <p:spTgt spid="43"/>
-                                        </p:tgtEl>
-                                        <p:attrNameLst>
-                                          <p:attrName>style.visibility</p:attrName>
-                                        </p:attrNameLst>
-                                      </p:cBhvr>
-                                      <p:to>
-                                        <p:strVal val="visible"/>
-                                      </p:to>
-                                    </p:set>
-                                    <p:animEffect transition="in" filter="wipe(left)">
-                                      <p:cBhvr>
-                                        <p:cTn id="15" dur="750"/>
-                                        <p:tgtEl>
-                                          <p:spTgt spid="43"/>
-                                        </p:tgtEl>
-                                      </p:cBhvr>
-                                    </p:animEffect>
-                                  </p:childTnLst>
-                                </p:cTn>
-                              </p:par>
-                            </p:childTnLst>
-                          </p:cTn>
-                        </p:par>
-                      </p:childTnLst>
-                    </p:cTn>
-                  </p:par>
-                </p:childTnLst>
-              </p:cTn>
-              <p:prevCondLst>
-                <p:cond evt="onPrev" delay="0">
-                  <p:tgtEl>
-                    <p:sldTgt/>
-                  </p:tgtEl>
-                </p:cond>
-              </p:prevCondLst>
-              <p:nextCondLst>
-                <p:cond evt="onNext" delay="0">
-                  <p:tgtEl>
-                    <p:sldTgt/>
-                  </p:tgtEl>
-                </p:cond>
-              </p:nextCondLst>
-            </p:seq>
-          </p:childTnLst>
-        </p:cTn>
-      </p:par>
-    </p:tnLst>
-  </p:timing>
 </p:sld>
 </file>
 
@@ -25578,151 +23825,9 @@
     <a:masterClrMapping/>
   </p:clrMapOvr>
   <mc:AlternateContent xmlns:mc="http://schemas.openxmlformats.org/markup-compatibility/2006" xmlns:p159="http://schemas.microsoft.com/office/powerpoint/2015/09/main">
-    <mc:Choice Requires="p159">
-      <p:transition xmlns:p14="http://schemas.microsoft.com/office/powerpoint/2010/main" spd="slow" p14:dur="2000">
-        <p159:morph option="byObject"/>
-      </p:transition>
-    </mc:Choice>
-    <mc:Fallback>
-      <p:transition spd="slow">
-        <p:fade/>
-      </p:transition>
-    </mc:Fallback>
+    <mc:Choice Requires="p159"/>
+    <mc:Fallback/>
   </mc:AlternateContent>
-  <p:timing>
-    <p:tnLst>
-      <p:par>
-        <p:cTn id="1" dur="indefinite" restart="never" nodeType="tmRoot">
-          <p:childTnLst>
-            <p:seq concurrent="1" nextAc="seek">
-              <p:cTn id="2" dur="indefinite" nodeType="mainSeq">
-                <p:childTnLst>
-                  <p:par>
-                    <p:cTn id="3" fill="hold">
-                      <p:stCondLst>
-                        <p:cond delay="indefinite"/>
-                        <p:cond evt="onBegin" delay="0">
-                          <p:tn val="2"/>
-                        </p:cond>
-                      </p:stCondLst>
-                      <p:childTnLst>
-                        <p:par>
-                          <p:cTn id="4" fill="hold">
-                            <p:stCondLst>
-                              <p:cond delay="0"/>
-                            </p:stCondLst>
-                            <p:childTnLst>
-                              <p:par>
-                                <p:cTn id="5" presetID="10" presetClass="entr" presetSubtype="0" fill="hold" grpId="0" nodeType="afterEffect">
-                                  <p:stCondLst>
-                                    <p:cond delay="0"/>
-                                  </p:stCondLst>
-                                  <p:childTnLst>
-                                    <p:set>
-                                      <p:cBhvr>
-                                        <p:cTn id="6" dur="1" fill="hold">
-                                          <p:stCondLst>
-                                            <p:cond delay="0"/>
-                                          </p:stCondLst>
-                                        </p:cTn>
-                                        <p:tgtEl>
-                                          <p:spTgt spid="64"/>
-                                        </p:tgtEl>
-                                        <p:attrNameLst>
-                                          <p:attrName>style.visibility</p:attrName>
-                                        </p:attrNameLst>
-                                      </p:cBhvr>
-                                      <p:to>
-                                        <p:strVal val="visible"/>
-                                      </p:to>
-                                    </p:set>
-                                    <p:animEffect transition="in" filter="fade">
-                                      <p:cBhvr>
-                                        <p:cTn id="7" dur="500"/>
-                                        <p:tgtEl>
-                                          <p:spTgt spid="64"/>
-                                        </p:tgtEl>
-                                      </p:cBhvr>
-                                    </p:animEffect>
-                                  </p:childTnLst>
-                                </p:cTn>
-                              </p:par>
-                            </p:childTnLst>
-                          </p:cTn>
-                        </p:par>
-                        <p:par>
-                          <p:cTn id="8" fill="hold">
-                            <p:stCondLst>
-                              <p:cond delay="500"/>
-                            </p:stCondLst>
-                            <p:childTnLst>
-                              <p:par>
-                                <p:cTn id="9" presetID="10" presetClass="entr" presetSubtype="0" fill="hold" grpId="0" nodeType="afterEffect">
-                                  <p:stCondLst>
-                                    <p:cond delay="0"/>
-                                  </p:stCondLst>
-                                  <p:childTnLst>
-                                    <p:set>
-                                      <p:cBhvr>
-                                        <p:cTn id="10" dur="1" fill="hold">
-                                          <p:stCondLst>
-                                            <p:cond delay="0"/>
-                                          </p:stCondLst>
-                                        </p:cTn>
-                                        <p:tgtEl>
-                                          <p:spTgt spid="87"/>
-                                        </p:tgtEl>
-                                        <p:attrNameLst>
-                                          <p:attrName>style.visibility</p:attrName>
-                                        </p:attrNameLst>
-                                      </p:cBhvr>
-                                      <p:to>
-                                        <p:strVal val="visible"/>
-                                      </p:to>
-                                    </p:set>
-                                    <p:animEffect transition="in" filter="fade">
-                                      <p:cBhvr>
-                                        <p:cTn id="11" dur="500"/>
-                                        <p:tgtEl>
-                                          <p:spTgt spid="87"/>
-                                        </p:tgtEl>
-                                      </p:cBhvr>
-                                    </p:animEffect>
-                                  </p:childTnLst>
-                                </p:cTn>
-                              </p:par>
-                            </p:childTnLst>
-                          </p:cTn>
-                        </p:par>
-                      </p:childTnLst>
-                    </p:cTn>
-                  </p:par>
-                </p:childTnLst>
-              </p:cTn>
-              <p:prevCondLst>
-                <p:cond evt="onPrev" delay="0">
-                  <p:tgtEl>
-                    <p:sldTgt/>
-                  </p:tgtEl>
-                </p:cond>
-              </p:prevCondLst>
-              <p:nextCondLst>
-                <p:cond evt="onNext" delay="0">
-                  <p:tgtEl>
-                    <p:sldTgt/>
-                  </p:tgtEl>
-                </p:cond>
-              </p:nextCondLst>
-            </p:seq>
-          </p:childTnLst>
-        </p:cTn>
-      </p:par>
-    </p:tnLst>
-    <p:bldLst>
-      <p:bldP spid="64" grpId="0" animBg="1"/>
-      <p:bldP spid="87" grpId="0" animBg="1"/>
-    </p:bldLst>
-  </p:timing>
 </p:sld>
 </file>
 
@@ -26495,7 +24600,7 @@
         </p:nvSpPr>
         <p:spPr>
           <a:xfrm>
-            <a:off x="889000" y="2235200"/>
+            <a:off x="393700" y="1923415"/>
             <a:ext cx="3276600" cy="3810000"/>
           </a:xfrm>
           <a:prstGeom prst="roundRect">
@@ -26543,7 +24648,7 @@
         </p:nvSpPr>
         <p:spPr>
           <a:xfrm>
-            <a:off x="4572000" y="2235200"/>
+            <a:off x="4076700" y="1923415"/>
             <a:ext cx="3022600" cy="3810000"/>
           </a:xfrm>
           <a:prstGeom prst="roundRect">
@@ -26591,7 +24696,7 @@
         </p:nvSpPr>
         <p:spPr>
           <a:xfrm>
-            <a:off x="8318500" y="2235200"/>
+            <a:off x="7823200" y="1923415"/>
             <a:ext cx="3810000" cy="3810000"/>
           </a:xfrm>
           <a:prstGeom prst="roundRect">
@@ -26639,7 +24744,7 @@
         </p:nvSpPr>
         <p:spPr>
           <a:xfrm>
-            <a:off x="1219200" y="2565400"/>
+            <a:off x="723900" y="2253615"/>
             <a:ext cx="2667000" cy="200055"/>
           </a:xfrm>
           <a:prstGeom prst="rect">
@@ -26702,7 +24807,7 @@
         </p:nvSpPr>
         <p:spPr>
           <a:xfrm>
-            <a:off x="4902200" y="2565400"/>
+            <a:off x="4406900" y="2253615"/>
             <a:ext cx="2362200" cy="200055"/>
           </a:xfrm>
           <a:prstGeom prst="rect">
@@ -26765,7 +24870,7 @@
         </p:nvSpPr>
         <p:spPr>
           <a:xfrm>
-            <a:off x="8712200" y="2565400"/>
+            <a:off x="8216900" y="2253615"/>
             <a:ext cx="3022600" cy="200055"/>
           </a:xfrm>
           <a:prstGeom prst="rect">
@@ -26808,7 +24913,7 @@
         </p:nvSpPr>
         <p:spPr>
           <a:xfrm>
-            <a:off x="1282700" y="3441700"/>
+            <a:off x="787400" y="3129915"/>
             <a:ext cx="330200" cy="130805"/>
           </a:xfrm>
           <a:prstGeom prst="rect">
@@ -26850,7 +24955,7 @@
         </p:nvCxnSpPr>
         <p:spPr>
           <a:xfrm>
-            <a:off x="1714500" y="3505200"/>
+            <a:off x="1219200" y="3193415"/>
             <a:ext cx="1981200" cy="0"/>
           </a:xfrm>
           <a:prstGeom prst="line">
@@ -26885,7 +24990,7 @@
         </p:nvSpPr>
         <p:spPr>
           <a:xfrm>
-            <a:off x="1282700" y="4013200"/>
+            <a:off x="787400" y="3701415"/>
             <a:ext cx="330200" cy="130805"/>
           </a:xfrm>
           <a:prstGeom prst="rect">
@@ -26927,7 +25032,7 @@
         </p:nvCxnSpPr>
         <p:spPr>
           <a:xfrm>
-            <a:off x="1714500" y="4076700"/>
+            <a:off x="1219200" y="3764915"/>
             <a:ext cx="1981200" cy="0"/>
           </a:xfrm>
           <a:prstGeom prst="line">
@@ -26962,7 +25067,7 @@
         </p:nvSpPr>
         <p:spPr>
           <a:xfrm>
-            <a:off x="1282700" y="4584700"/>
+            <a:off x="787400" y="4272915"/>
             <a:ext cx="330200" cy="130805"/>
           </a:xfrm>
           <a:prstGeom prst="rect">
@@ -27004,7 +25109,7 @@
         </p:nvCxnSpPr>
         <p:spPr>
           <a:xfrm>
-            <a:off x="1714500" y="4648200"/>
+            <a:off x="1219200" y="4336415"/>
             <a:ext cx="1981200" cy="0"/>
           </a:xfrm>
           <a:prstGeom prst="line">
@@ -27039,7 +25144,7 @@
         </p:nvCxnSpPr>
         <p:spPr>
           <a:xfrm>
-            <a:off x="2781300" y="3505200"/>
+            <a:off x="2286000" y="3193415"/>
             <a:ext cx="0" cy="1143000"/>
           </a:xfrm>
           <a:prstGeom prst="line">
@@ -27074,7 +25179,7 @@
         </p:nvSpPr>
         <p:spPr>
           <a:xfrm>
-            <a:off x="2692400" y="3416300"/>
+            <a:off x="2197100" y="3104515"/>
             <a:ext cx="177800" cy="177800"/>
           </a:xfrm>
           <a:prstGeom prst="ellipse">
@@ -27122,7 +25227,7 @@
         </p:nvSpPr>
         <p:spPr>
           <a:xfrm>
-            <a:off x="2654300" y="4521200"/>
+            <a:off x="2159000" y="4209415"/>
             <a:ext cx="254000" cy="254000"/>
           </a:xfrm>
           <a:prstGeom prst="ellipse">
@@ -27170,7 +25275,7 @@
         </p:nvCxnSpPr>
         <p:spPr>
           <a:xfrm>
-            <a:off x="2679700" y="4648200"/>
+            <a:off x="2184400" y="4336415"/>
             <a:ext cx="203200" cy="0"/>
           </a:xfrm>
           <a:prstGeom prst="line">
@@ -27205,7 +25310,7 @@
         </p:nvCxnSpPr>
         <p:spPr>
           <a:xfrm>
-            <a:off x="2781300" y="4546600"/>
+            <a:off x="2286000" y="4234815"/>
             <a:ext cx="0" cy="203200"/>
           </a:xfrm>
           <a:prstGeom prst="line">
@@ -27240,7 +25345,7 @@
         </p:nvSpPr>
         <p:spPr>
           <a:xfrm>
-            <a:off x="1892300" y="4940300"/>
+            <a:off x="1397000" y="4628515"/>
             <a:ext cx="2032000" cy="130805"/>
           </a:xfrm>
           <a:prstGeom prst="rect">
@@ -27283,7 +25388,7 @@
         </p:nvCxnSpPr>
         <p:spPr>
           <a:xfrm>
-            <a:off x="5435600" y="3695700"/>
+            <a:off x="4940300" y="3383915"/>
             <a:ext cx="1270000" cy="0"/>
           </a:xfrm>
           <a:prstGeom prst="line">
@@ -27318,7 +25423,7 @@
         </p:nvCxnSpPr>
         <p:spPr>
           <a:xfrm>
-            <a:off x="5435600" y="3695700"/>
+            <a:off x="4940300" y="3383915"/>
             <a:ext cx="635000" cy="1016000"/>
           </a:xfrm>
           <a:prstGeom prst="line">
@@ -27353,7 +25458,7 @@
         </p:nvCxnSpPr>
         <p:spPr>
           <a:xfrm flipV="1">
-            <a:off x="6070600" y="3695700"/>
+            <a:off x="5575300" y="3383915"/>
             <a:ext cx="635000" cy="1016000"/>
           </a:xfrm>
           <a:prstGeom prst="line">
@@ -27388,7 +25493,7 @@
         </p:nvSpPr>
         <p:spPr>
           <a:xfrm>
-            <a:off x="5232400" y="3492500"/>
+            <a:off x="4737100" y="3180715"/>
             <a:ext cx="406400" cy="406400"/>
           </a:xfrm>
           <a:prstGeom prst="ellipse">
@@ -27436,7 +25541,7 @@
         </p:nvSpPr>
         <p:spPr>
           <a:xfrm>
-            <a:off x="5232400" y="3632200"/>
+            <a:off x="4737100" y="3320415"/>
             <a:ext cx="406400" cy="130805"/>
           </a:xfrm>
           <a:prstGeom prst="rect">
@@ -27479,7 +25584,7 @@
         </p:nvSpPr>
         <p:spPr>
           <a:xfrm>
-            <a:off x="6502400" y="3492500"/>
+            <a:off x="6007100" y="3180715"/>
             <a:ext cx="406400" cy="406400"/>
           </a:xfrm>
           <a:prstGeom prst="ellipse">
@@ -27527,7 +25632,7 @@
         </p:nvSpPr>
         <p:spPr>
           <a:xfrm>
-            <a:off x="6502400" y="3632200"/>
+            <a:off x="6007100" y="3320415"/>
             <a:ext cx="406400" cy="130805"/>
           </a:xfrm>
           <a:prstGeom prst="rect">
@@ -27570,7 +25675,7 @@
         </p:nvSpPr>
         <p:spPr>
           <a:xfrm>
-            <a:off x="5867400" y="4508500"/>
+            <a:off x="5372100" y="4196715"/>
             <a:ext cx="406400" cy="406400"/>
           </a:xfrm>
           <a:prstGeom prst="ellipse">
@@ -27618,7 +25723,7 @@
         </p:nvSpPr>
         <p:spPr>
           <a:xfrm>
-            <a:off x="5867400" y="4648200"/>
+            <a:off x="5372100" y="4336415"/>
             <a:ext cx="406400" cy="130805"/>
           </a:xfrm>
           <a:prstGeom prst="rect">
@@ -27661,7 +25766,7 @@
         </p:nvSpPr>
         <p:spPr>
           <a:xfrm>
-            <a:off x="5080000" y="5092700"/>
+            <a:off x="4584700" y="4780915"/>
             <a:ext cx="2006600" cy="258532"/>
           </a:xfrm>
           <a:prstGeom prst="rect">
@@ -27704,7 +25809,7 @@
         </p:nvSpPr>
         <p:spPr>
           <a:xfrm>
-            <a:off x="8839200" y="3365500"/>
+            <a:off x="8343900" y="3053715"/>
             <a:ext cx="609600" cy="123111"/>
           </a:xfrm>
           <a:prstGeom prst="rect">
@@ -27746,7 +25851,7 @@
         </p:nvCxnSpPr>
         <p:spPr>
           <a:xfrm>
-            <a:off x="9550400" y="3429000"/>
+            <a:off x="9055100" y="3117215"/>
             <a:ext cx="1879600" cy="0"/>
           </a:xfrm>
           <a:prstGeom prst="line">
@@ -27781,7 +25886,7 @@
         </p:nvSpPr>
         <p:spPr>
           <a:xfrm>
-            <a:off x="8839200" y="3848100"/>
+            <a:off x="8343900" y="3536315"/>
             <a:ext cx="609600" cy="123111"/>
           </a:xfrm>
           <a:prstGeom prst="rect">
@@ -27823,7 +25928,7 @@
         </p:nvCxnSpPr>
         <p:spPr>
           <a:xfrm>
-            <a:off x="9550400" y="3911600"/>
+            <a:off x="9055100" y="3599815"/>
             <a:ext cx="1879600" cy="0"/>
           </a:xfrm>
           <a:prstGeom prst="line">
@@ -27858,7 +25963,7 @@
         </p:nvSpPr>
         <p:spPr>
           <a:xfrm>
-            <a:off x="8839200" y="4330700"/>
+            <a:off x="8343900" y="4018915"/>
             <a:ext cx="609600" cy="123111"/>
           </a:xfrm>
           <a:prstGeom prst="rect">
@@ -27900,7 +26005,7 @@
         </p:nvCxnSpPr>
         <p:spPr>
           <a:xfrm>
-            <a:off x="9550400" y="4394200"/>
+            <a:off x="9055100" y="4082415"/>
             <a:ext cx="1879600" cy="0"/>
           </a:xfrm>
           <a:prstGeom prst="line">
@@ -27935,7 +26040,7 @@
         </p:nvCxnSpPr>
         <p:spPr>
           <a:xfrm>
-            <a:off x="10020300" y="3911600"/>
+            <a:off x="9525000" y="3599815"/>
             <a:ext cx="0" cy="482600"/>
           </a:xfrm>
           <a:prstGeom prst="line">
@@ -27970,7 +26075,7 @@
         </p:nvCxnSpPr>
         <p:spPr>
           <a:xfrm>
-            <a:off x="9944100" y="3835400"/>
+            <a:off x="9448800" y="3523615"/>
             <a:ext cx="152400" cy="152400"/>
           </a:xfrm>
           <a:prstGeom prst="line">
@@ -28005,7 +26110,7 @@
         </p:nvCxnSpPr>
         <p:spPr>
           <a:xfrm flipV="1">
-            <a:off x="9944100" y="3835400"/>
+            <a:off x="9448800" y="3523615"/>
             <a:ext cx="152400" cy="152400"/>
           </a:xfrm>
           <a:prstGeom prst="line">
@@ -28040,7 +26145,7 @@
         </p:nvCxnSpPr>
         <p:spPr>
           <a:xfrm>
-            <a:off x="9944100" y="4318000"/>
+            <a:off x="9448800" y="4006215"/>
             <a:ext cx="152400" cy="152400"/>
           </a:xfrm>
           <a:prstGeom prst="line">
@@ -28075,7 +26180,7 @@
         </p:nvCxnSpPr>
         <p:spPr>
           <a:xfrm flipV="1">
-            <a:off x="9944100" y="4318000"/>
+            <a:off x="9448800" y="4006215"/>
             <a:ext cx="152400" cy="152400"/>
           </a:xfrm>
           <a:prstGeom prst="line">
@@ -28110,7 +26215,7 @@
         </p:nvCxnSpPr>
         <p:spPr>
           <a:xfrm>
-            <a:off x="10820400" y="3429000"/>
+            <a:off x="10325100" y="3117215"/>
             <a:ext cx="0" cy="482600"/>
           </a:xfrm>
           <a:prstGeom prst="line">
@@ -28145,7 +26250,7 @@
         </p:nvSpPr>
         <p:spPr>
           <a:xfrm>
-            <a:off x="10744200" y="3352800"/>
+            <a:off x="10248900" y="3041015"/>
             <a:ext cx="152400" cy="152400"/>
           </a:xfrm>
           <a:prstGeom prst="ellipse">
@@ -28193,7 +26298,7 @@
         </p:nvSpPr>
         <p:spPr>
           <a:xfrm>
-            <a:off x="10706100" y="3797300"/>
+            <a:off x="10210800" y="3485515"/>
             <a:ext cx="228600" cy="228600"/>
           </a:xfrm>
           <a:prstGeom prst="ellipse">
@@ -28241,7 +26346,7 @@
         </p:nvCxnSpPr>
         <p:spPr>
           <a:xfrm>
-            <a:off x="10731500" y="3911600"/>
+            <a:off x="10236200" y="3599815"/>
             <a:ext cx="177800" cy="0"/>
           </a:xfrm>
           <a:prstGeom prst="line">
@@ -28276,7 +26381,7 @@
         </p:nvCxnSpPr>
         <p:spPr>
           <a:xfrm>
-            <a:off x="10820400" y="3822700"/>
+            <a:off x="10325100" y="3510915"/>
             <a:ext cx="0" cy="177800"/>
           </a:xfrm>
           <a:prstGeom prst="line">
@@ -28311,7 +26416,7 @@
         </p:nvSpPr>
         <p:spPr>
           <a:xfrm>
-            <a:off x="9448800" y="4775200"/>
+            <a:off x="8953500" y="4463415"/>
             <a:ext cx="1968500" cy="255455"/>
           </a:xfrm>
           <a:prstGeom prst="rect">
@@ -28364,7 +26469,7 @@
         </p:nvCxnSpPr>
         <p:spPr>
           <a:xfrm>
-            <a:off x="4229100" y="4140200"/>
+            <a:off x="3733800" y="3828415"/>
             <a:ext cx="279400" cy="0"/>
           </a:xfrm>
           <a:prstGeom prst="line">
@@ -28400,7 +26505,7 @@
         </p:nvSpPr>
         <p:spPr>
           <a:xfrm>
-            <a:off x="4076700" y="4318000"/>
+            <a:off x="3581400" y="4006215"/>
             <a:ext cx="609600" cy="120033"/>
           </a:xfrm>
           <a:prstGeom prst="rect">
@@ -28443,7 +26548,7 @@
         </p:nvCxnSpPr>
         <p:spPr>
           <a:xfrm>
-            <a:off x="7670800" y="4140200"/>
+            <a:off x="7175500" y="3828415"/>
             <a:ext cx="558800" cy="0"/>
           </a:xfrm>
           <a:prstGeom prst="line">
@@ -28479,7 +26584,7 @@
         </p:nvSpPr>
         <p:spPr>
           <a:xfrm>
-            <a:off x="7708900" y="4318000"/>
+            <a:off x="7213600" y="4006215"/>
             <a:ext cx="533400" cy="227755"/>
           </a:xfrm>
           <a:prstGeom prst="rect">
@@ -28523,7 +26628,7 @@
         </p:nvSpPr>
         <p:spPr>
           <a:xfrm>
-            <a:off x="2628900" y="6096000"/>
+            <a:off x="1752600" y="6045200"/>
             <a:ext cx="7772400" cy="431800"/>
           </a:xfrm>
           <a:prstGeom prst="roundRect">
@@ -28571,7 +26676,7 @@
         </p:nvSpPr>
         <p:spPr>
           <a:xfrm>
-            <a:off x="2921000" y="6235700"/>
+            <a:off x="2044700" y="6184900"/>
             <a:ext cx="7188200" cy="161583"/>
           </a:xfrm>
           <a:prstGeom prst="rect">
@@ -28709,151 +26814,9 @@
     <a:masterClrMapping/>
   </p:clrMapOvr>
   <mc:AlternateContent xmlns:mc="http://schemas.openxmlformats.org/markup-compatibility/2006" xmlns:p159="http://schemas.microsoft.com/office/powerpoint/2015/09/main">
-    <mc:Choice Requires="p159">
-      <p:transition xmlns:p14="http://schemas.microsoft.com/office/powerpoint/2010/main" spd="slow" p14:dur="2000">
-        <p159:morph option="byObject"/>
-      </p:transition>
-    </mc:Choice>
-    <mc:Fallback>
-      <p:transition spd="slow">
-        <p:fade/>
-      </p:transition>
-    </mc:Fallback>
+    <mc:Choice Requires="p159"/>
+    <mc:Fallback/>
   </mc:AlternateContent>
-  <p:timing>
-    <p:tnLst>
-      <p:par>
-        <p:cTn id="1" dur="indefinite" restart="never" nodeType="tmRoot">
-          <p:childTnLst>
-            <p:seq concurrent="1" nextAc="seek">
-              <p:cTn id="2" dur="indefinite" nodeType="mainSeq">
-                <p:childTnLst>
-                  <p:par>
-                    <p:cTn id="3" fill="hold">
-                      <p:stCondLst>
-                        <p:cond delay="indefinite"/>
-                        <p:cond evt="onBegin" delay="0">
-                          <p:tn val="2"/>
-                        </p:cond>
-                      </p:stCondLst>
-                      <p:childTnLst>
-                        <p:par>
-                          <p:cTn id="4" fill="hold">
-                            <p:stCondLst>
-                              <p:cond delay="0"/>
-                            </p:stCondLst>
-                            <p:childTnLst>
-                              <p:par>
-                                <p:cTn id="5" presetID="10" presetClass="entr" presetSubtype="0" fill="hold" grpId="0" nodeType="afterEffect">
-                                  <p:stCondLst>
-                                    <p:cond delay="0"/>
-                                  </p:stCondLst>
-                                  <p:childTnLst>
-                                    <p:set>
-                                      <p:cBhvr>
-                                        <p:cTn id="6" dur="1" fill="hold">
-                                          <p:stCondLst>
-                                            <p:cond delay="0"/>
-                                          </p:stCondLst>
-                                        </p:cTn>
-                                        <p:tgtEl>
-                                          <p:spTgt spid="64"/>
-                                        </p:tgtEl>
-                                        <p:attrNameLst>
-                                          <p:attrName>style.visibility</p:attrName>
-                                        </p:attrNameLst>
-                                      </p:cBhvr>
-                                      <p:to>
-                                        <p:strVal val="visible"/>
-                                      </p:to>
-                                    </p:set>
-                                    <p:animEffect transition="in" filter="fade">
-                                      <p:cBhvr>
-                                        <p:cTn id="7" dur="500"/>
-                                        <p:tgtEl>
-                                          <p:spTgt spid="64"/>
-                                        </p:tgtEl>
-                                      </p:cBhvr>
-                                    </p:animEffect>
-                                  </p:childTnLst>
-                                </p:cTn>
-                              </p:par>
-                            </p:childTnLst>
-                          </p:cTn>
-                        </p:par>
-                        <p:par>
-                          <p:cTn id="8" fill="hold">
-                            <p:stCondLst>
-                              <p:cond delay="500"/>
-                            </p:stCondLst>
-                            <p:childTnLst>
-                              <p:par>
-                                <p:cTn id="9" presetID="10" presetClass="entr" presetSubtype="0" fill="hold" grpId="0" nodeType="afterEffect">
-                                  <p:stCondLst>
-                                    <p:cond delay="0"/>
-                                  </p:stCondLst>
-                                  <p:childTnLst>
-                                    <p:set>
-                                      <p:cBhvr>
-                                        <p:cTn id="10" dur="1" fill="hold">
-                                          <p:stCondLst>
-                                            <p:cond delay="0"/>
-                                          </p:stCondLst>
-                                        </p:cTn>
-                                        <p:tgtEl>
-                                          <p:spTgt spid="87"/>
-                                        </p:tgtEl>
-                                        <p:attrNameLst>
-                                          <p:attrName>style.visibility</p:attrName>
-                                        </p:attrNameLst>
-                                      </p:cBhvr>
-                                      <p:to>
-                                        <p:strVal val="visible"/>
-                                      </p:to>
-                                    </p:set>
-                                    <p:animEffect transition="in" filter="fade">
-                                      <p:cBhvr>
-                                        <p:cTn id="11" dur="500"/>
-                                        <p:tgtEl>
-                                          <p:spTgt spid="87"/>
-                                        </p:tgtEl>
-                                      </p:cBhvr>
-                                    </p:animEffect>
-                                  </p:childTnLst>
-                                </p:cTn>
-                              </p:par>
-                            </p:childTnLst>
-                          </p:cTn>
-                        </p:par>
-                      </p:childTnLst>
-                    </p:cTn>
-                  </p:par>
-                </p:childTnLst>
-              </p:cTn>
-              <p:prevCondLst>
-                <p:cond evt="onPrev" delay="0">
-                  <p:tgtEl>
-                    <p:sldTgt/>
-                  </p:tgtEl>
-                </p:cond>
-              </p:prevCondLst>
-              <p:nextCondLst>
-                <p:cond evt="onNext" delay="0">
-                  <p:tgtEl>
-                    <p:sldTgt/>
-                  </p:tgtEl>
-                </p:cond>
-              </p:nextCondLst>
-            </p:seq>
-          </p:childTnLst>
-        </p:cTn>
-      </p:par>
-    </p:tnLst>
-    <p:bldLst>
-      <p:bldP spid="64" grpId="0" animBg="1"/>
-      <p:bldP spid="87" grpId="0" animBg="1"/>
-    </p:bldLst>
-  </p:timing>
 </p:sld>
 </file>
 
@@ -30347,151 +28310,9 @@
     <a:masterClrMapping/>
   </p:clrMapOvr>
   <mc:AlternateContent xmlns:mc="http://schemas.openxmlformats.org/markup-compatibility/2006" xmlns:p159="http://schemas.microsoft.com/office/powerpoint/2015/09/main">
-    <mc:Choice Requires="p159">
-      <p:transition xmlns:p14="http://schemas.microsoft.com/office/powerpoint/2010/main" spd="slow" p14:dur="2000">
-        <p159:morph option="byObject"/>
-      </p:transition>
-    </mc:Choice>
-    <mc:Fallback>
-      <p:transition spd="slow">
-        <p:fade/>
-      </p:transition>
-    </mc:Fallback>
+    <mc:Choice Requires="p159"/>
+    <mc:Fallback/>
   </mc:AlternateContent>
-  <p:timing>
-    <p:tnLst>
-      <p:par>
-        <p:cTn id="1" dur="indefinite" restart="never" nodeType="tmRoot">
-          <p:childTnLst>
-            <p:seq concurrent="1" nextAc="seek">
-              <p:cTn id="2" dur="indefinite" nodeType="mainSeq">
-                <p:childTnLst>
-                  <p:par>
-                    <p:cTn id="3" fill="hold">
-                      <p:stCondLst>
-                        <p:cond delay="indefinite"/>
-                        <p:cond evt="onBegin" delay="0">
-                          <p:tn val="2"/>
-                        </p:cond>
-                      </p:stCondLst>
-                      <p:childTnLst>
-                        <p:par>
-                          <p:cTn id="4" fill="hold">
-                            <p:stCondLst>
-                              <p:cond delay="0"/>
-                            </p:stCondLst>
-                            <p:childTnLst>
-                              <p:par>
-                                <p:cTn id="5" presetID="10" presetClass="entr" presetSubtype="0" fill="hold" grpId="0" nodeType="afterEffect">
-                                  <p:stCondLst>
-                                    <p:cond delay="0"/>
-                                  </p:stCondLst>
-                                  <p:childTnLst>
-                                    <p:set>
-                                      <p:cBhvr>
-                                        <p:cTn id="6" dur="1" fill="hold">
-                                          <p:stCondLst>
-                                            <p:cond delay="0"/>
-                                          </p:stCondLst>
-                                        </p:cTn>
-                                        <p:tgtEl>
-                                          <p:spTgt spid="64"/>
-                                        </p:tgtEl>
-                                        <p:attrNameLst>
-                                          <p:attrName>style.visibility</p:attrName>
-                                        </p:attrNameLst>
-                                      </p:cBhvr>
-                                      <p:to>
-                                        <p:strVal val="visible"/>
-                                      </p:to>
-                                    </p:set>
-                                    <p:animEffect transition="in" filter="fade">
-                                      <p:cBhvr>
-                                        <p:cTn id="7" dur="500"/>
-                                        <p:tgtEl>
-                                          <p:spTgt spid="64"/>
-                                        </p:tgtEl>
-                                      </p:cBhvr>
-                                    </p:animEffect>
-                                  </p:childTnLst>
-                                </p:cTn>
-                              </p:par>
-                            </p:childTnLst>
-                          </p:cTn>
-                        </p:par>
-                        <p:par>
-                          <p:cTn id="8" fill="hold">
-                            <p:stCondLst>
-                              <p:cond delay="500"/>
-                            </p:stCondLst>
-                            <p:childTnLst>
-                              <p:par>
-                                <p:cTn id="9" presetID="10" presetClass="entr" presetSubtype="0" fill="hold" grpId="0" nodeType="afterEffect">
-                                  <p:stCondLst>
-                                    <p:cond delay="0"/>
-                                  </p:stCondLst>
-                                  <p:childTnLst>
-                                    <p:set>
-                                      <p:cBhvr>
-                                        <p:cTn id="10" dur="1" fill="hold">
-                                          <p:stCondLst>
-                                            <p:cond delay="0"/>
-                                          </p:stCondLst>
-                                        </p:cTn>
-                                        <p:tgtEl>
-                                          <p:spTgt spid="87"/>
-                                        </p:tgtEl>
-                                        <p:attrNameLst>
-                                          <p:attrName>style.visibility</p:attrName>
-                                        </p:attrNameLst>
-                                      </p:cBhvr>
-                                      <p:to>
-                                        <p:strVal val="visible"/>
-                                      </p:to>
-                                    </p:set>
-                                    <p:animEffect transition="in" filter="fade">
-                                      <p:cBhvr>
-                                        <p:cTn id="11" dur="500"/>
-                                        <p:tgtEl>
-                                          <p:spTgt spid="87"/>
-                                        </p:tgtEl>
-                                      </p:cBhvr>
-                                    </p:animEffect>
-                                  </p:childTnLst>
-                                </p:cTn>
-                              </p:par>
-                            </p:childTnLst>
-                          </p:cTn>
-                        </p:par>
-                      </p:childTnLst>
-                    </p:cTn>
-                  </p:par>
-                </p:childTnLst>
-              </p:cTn>
-              <p:prevCondLst>
-                <p:cond evt="onPrev" delay="0">
-                  <p:tgtEl>
-                    <p:sldTgt/>
-                  </p:tgtEl>
-                </p:cond>
-              </p:prevCondLst>
-              <p:nextCondLst>
-                <p:cond evt="onNext" delay="0">
-                  <p:tgtEl>
-                    <p:sldTgt/>
-                  </p:tgtEl>
-                </p:cond>
-              </p:nextCondLst>
-            </p:seq>
-          </p:childTnLst>
-        </p:cTn>
-      </p:par>
-    </p:tnLst>
-    <p:bldLst>
-      <p:bldP spid="64" grpId="0" animBg="1"/>
-      <p:bldP spid="87" grpId="0" animBg="1"/>
-    </p:bldLst>
-  </p:timing>
 </p:sld>
 </file>
 
@@ -32190,151 +30011,9 @@
     <a:masterClrMapping/>
   </p:clrMapOvr>
   <mc:AlternateContent xmlns:mc="http://schemas.openxmlformats.org/markup-compatibility/2006" xmlns:p159="http://schemas.microsoft.com/office/powerpoint/2015/09/main">
-    <mc:Choice Requires="p159">
-      <p:transition xmlns:p14="http://schemas.microsoft.com/office/powerpoint/2010/main" spd="slow" p14:dur="2000">
-        <p159:morph option="byObject"/>
-      </p:transition>
-    </mc:Choice>
-    <mc:Fallback>
-      <p:transition spd="slow">
-        <p:fade/>
-      </p:transition>
-    </mc:Fallback>
+    <mc:Choice Requires="p159"/>
+    <mc:Fallback/>
   </mc:AlternateContent>
-  <p:timing>
-    <p:tnLst>
-      <p:par>
-        <p:cTn id="1" dur="indefinite" restart="never" nodeType="tmRoot">
-          <p:childTnLst>
-            <p:seq concurrent="1" nextAc="seek">
-              <p:cTn id="2" dur="indefinite" nodeType="mainSeq">
-                <p:childTnLst>
-                  <p:par>
-                    <p:cTn id="3" fill="hold">
-                      <p:stCondLst>
-                        <p:cond delay="indefinite"/>
-                        <p:cond evt="onBegin" delay="0">
-                          <p:tn val="2"/>
-                        </p:cond>
-                      </p:stCondLst>
-                      <p:childTnLst>
-                        <p:par>
-                          <p:cTn id="4" fill="hold">
-                            <p:stCondLst>
-                              <p:cond delay="0"/>
-                            </p:stCondLst>
-                            <p:childTnLst>
-                              <p:par>
-                                <p:cTn id="5" presetID="10" presetClass="entr" presetSubtype="0" fill="hold" grpId="0" nodeType="afterEffect">
-                                  <p:stCondLst>
-                                    <p:cond delay="0"/>
-                                  </p:stCondLst>
-                                  <p:childTnLst>
-                                    <p:set>
-                                      <p:cBhvr>
-                                        <p:cTn id="6" dur="1" fill="hold">
-                                          <p:stCondLst>
-                                            <p:cond delay="0"/>
-                                          </p:stCondLst>
-                                        </p:cTn>
-                                        <p:tgtEl>
-                                          <p:spTgt spid="64"/>
-                                        </p:tgtEl>
-                                        <p:attrNameLst>
-                                          <p:attrName>style.visibility</p:attrName>
-                                        </p:attrNameLst>
-                                      </p:cBhvr>
-                                      <p:to>
-                                        <p:strVal val="visible"/>
-                                      </p:to>
-                                    </p:set>
-                                    <p:animEffect transition="in" filter="fade">
-                                      <p:cBhvr>
-                                        <p:cTn id="7" dur="500"/>
-                                        <p:tgtEl>
-                                          <p:spTgt spid="64"/>
-                                        </p:tgtEl>
-                                      </p:cBhvr>
-                                    </p:animEffect>
-                                  </p:childTnLst>
-                                </p:cTn>
-                              </p:par>
-                            </p:childTnLst>
-                          </p:cTn>
-                        </p:par>
-                        <p:par>
-                          <p:cTn id="8" fill="hold">
-                            <p:stCondLst>
-                              <p:cond delay="500"/>
-                            </p:stCondLst>
-                            <p:childTnLst>
-                              <p:par>
-                                <p:cTn id="9" presetID="10" presetClass="entr" presetSubtype="0" fill="hold" grpId="0" nodeType="afterEffect">
-                                  <p:stCondLst>
-                                    <p:cond delay="0"/>
-                                  </p:stCondLst>
-                                  <p:childTnLst>
-                                    <p:set>
-                                      <p:cBhvr>
-                                        <p:cTn id="10" dur="1" fill="hold">
-                                          <p:stCondLst>
-                                            <p:cond delay="0"/>
-                                          </p:stCondLst>
-                                        </p:cTn>
-                                        <p:tgtEl>
-                                          <p:spTgt spid="87"/>
-                                        </p:tgtEl>
-                                        <p:attrNameLst>
-                                          <p:attrName>style.visibility</p:attrName>
-                                        </p:attrNameLst>
-                                      </p:cBhvr>
-                                      <p:to>
-                                        <p:strVal val="visible"/>
-                                      </p:to>
-                                    </p:set>
-                                    <p:animEffect transition="in" filter="fade">
-                                      <p:cBhvr>
-                                        <p:cTn id="11" dur="500"/>
-                                        <p:tgtEl>
-                                          <p:spTgt spid="87"/>
-                                        </p:tgtEl>
-                                      </p:cBhvr>
-                                    </p:animEffect>
-                                  </p:childTnLst>
-                                </p:cTn>
-                              </p:par>
-                            </p:childTnLst>
-                          </p:cTn>
-                        </p:par>
-                      </p:childTnLst>
-                    </p:cTn>
-                  </p:par>
-                </p:childTnLst>
-              </p:cTn>
-              <p:prevCondLst>
-                <p:cond evt="onPrev" delay="0">
-                  <p:tgtEl>
-                    <p:sldTgt/>
-                  </p:tgtEl>
-                </p:cond>
-              </p:prevCondLst>
-              <p:nextCondLst>
-                <p:cond evt="onNext" delay="0">
-                  <p:tgtEl>
-                    <p:sldTgt/>
-                  </p:tgtEl>
-                </p:cond>
-              </p:nextCondLst>
-            </p:seq>
-          </p:childTnLst>
-        </p:cTn>
-      </p:par>
-    </p:tnLst>
-    <p:bldLst>
-      <p:bldP spid="64" grpId="0" animBg="1"/>
-      <p:bldP spid="87" grpId="0" animBg="1"/>
-    </p:bldLst>
-  </p:timing>
 </p:sld>
 </file>
 
@@ -33053,7 +30732,7 @@
         </p:nvSpPr>
         <p:spPr>
           <a:xfrm>
-            <a:off x="965200" y="2235200"/>
+            <a:off x="944880" y="1898015"/>
             <a:ext cx="4826000" cy="3835400"/>
           </a:xfrm>
           <a:prstGeom prst="roundRect">
@@ -33101,7 +30780,7 @@
         </p:nvSpPr>
         <p:spPr>
           <a:xfrm>
-            <a:off x="6604000" y="2235200"/>
+            <a:off x="6583680" y="1898015"/>
             <a:ext cx="4826000" cy="3835400"/>
           </a:xfrm>
           <a:prstGeom prst="roundRect">
@@ -33149,7 +30828,7 @@
         </p:nvSpPr>
         <p:spPr>
           <a:xfrm>
-            <a:off x="1333500" y="2565400"/>
+            <a:off x="1313180" y="2228215"/>
             <a:ext cx="4064000" cy="215444"/>
           </a:xfrm>
           <a:prstGeom prst="rect">
@@ -33212,7 +30891,7 @@
         </p:nvSpPr>
         <p:spPr>
           <a:xfrm>
-            <a:off x="6985000" y="2565400"/>
+            <a:off x="6964680" y="2228215"/>
             <a:ext cx="4064000" cy="215265"/>
           </a:xfrm>
           <a:prstGeom prst="rect">
@@ -33262,7 +30941,7 @@
         </p:nvSpPr>
         <p:spPr>
           <a:xfrm>
-            <a:off x="2197100" y="2946400"/>
+            <a:off x="2176780" y="2609215"/>
             <a:ext cx="2349500" cy="430887"/>
           </a:xfrm>
           <a:prstGeom prst="rect">
@@ -33305,7 +30984,7 @@
         </p:nvSpPr>
         <p:spPr>
           <a:xfrm>
-            <a:off x="7539355" y="2946400"/>
+            <a:off x="7519035" y="2609215"/>
             <a:ext cx="3361055" cy="368935"/>
           </a:xfrm>
           <a:prstGeom prst="rect">
@@ -33363,7 +31042,7 @@
         </p:nvCxnSpPr>
         <p:spPr>
           <a:xfrm>
-            <a:off x="1625600" y="5064125"/>
+            <a:off x="1605280" y="4726940"/>
             <a:ext cx="3302000" cy="0"/>
           </a:xfrm>
           <a:prstGeom prst="line">
@@ -33398,7 +31077,7 @@
         </p:nvCxnSpPr>
         <p:spPr>
           <a:xfrm>
-            <a:off x="1625600" y="4730750"/>
+            <a:off x="1605280" y="4393565"/>
             <a:ext cx="3302000" cy="0"/>
           </a:xfrm>
           <a:prstGeom prst="line">
@@ -33433,7 +31112,7 @@
         </p:nvCxnSpPr>
         <p:spPr>
           <a:xfrm>
-            <a:off x="1625600" y="4397375"/>
+            <a:off x="1605280" y="4060190"/>
             <a:ext cx="3302000" cy="0"/>
           </a:xfrm>
           <a:prstGeom prst="line">
@@ -33468,7 +31147,7 @@
         </p:nvCxnSpPr>
         <p:spPr>
           <a:xfrm>
-            <a:off x="1625600" y="5397500"/>
+            <a:off x="1605280" y="5060315"/>
             <a:ext cx="3302000" cy="0"/>
           </a:xfrm>
           <a:prstGeom prst="line">
@@ -33503,7 +31182,7 @@
         </p:nvCxnSpPr>
         <p:spPr>
           <a:xfrm>
-            <a:off x="1625600" y="4064000"/>
+            <a:off x="1605280" y="3726815"/>
             <a:ext cx="0" cy="1333500"/>
           </a:xfrm>
           <a:prstGeom prst="line">
@@ -33538,7 +31217,7 @@
         </p:nvSpPr>
         <p:spPr>
           <a:xfrm>
-            <a:off x="4622800" y="5499100"/>
+            <a:off x="4602480" y="5161915"/>
             <a:ext cx="381000" cy="123111"/>
           </a:xfrm>
           <a:prstGeom prst="rect">
@@ -33580,7 +31259,7 @@
         </p:nvSpPr>
         <p:spPr>
           <a:xfrm>
-            <a:off x="1574800" y="3886200"/>
+            <a:off x="1554480" y="3549015"/>
             <a:ext cx="584200" cy="224677"/>
           </a:xfrm>
           <a:prstGeom prst="rect">
@@ -33623,7 +31302,7 @@
         </p:nvCxnSpPr>
         <p:spPr>
           <a:xfrm>
-            <a:off x="2451100" y="5359400"/>
+            <a:off x="2430780" y="5022215"/>
             <a:ext cx="0" cy="76200"/>
           </a:xfrm>
           <a:prstGeom prst="line">
@@ -33658,7 +31337,7 @@
         </p:nvSpPr>
         <p:spPr>
           <a:xfrm>
-            <a:off x="2349500" y="5499100"/>
+            <a:off x="2329180" y="5161915"/>
             <a:ext cx="203200" cy="115416"/>
           </a:xfrm>
           <a:prstGeom prst="rect">
@@ -33701,7 +31380,7 @@
         </p:nvCxnSpPr>
         <p:spPr>
           <a:xfrm>
-            <a:off x="3276600" y="5359400"/>
+            <a:off x="3256280" y="5022215"/>
             <a:ext cx="0" cy="76200"/>
           </a:xfrm>
           <a:prstGeom prst="line">
@@ -33736,7 +31415,7 @@
         </p:nvSpPr>
         <p:spPr>
           <a:xfrm>
-            <a:off x="3175000" y="5499100"/>
+            <a:off x="3154680" y="5161915"/>
             <a:ext cx="203200" cy="115416"/>
           </a:xfrm>
           <a:prstGeom prst="rect">
@@ -33779,7 +31458,7 @@
         </p:nvCxnSpPr>
         <p:spPr>
           <a:xfrm>
-            <a:off x="4102100" y="5359400"/>
+            <a:off x="4081780" y="5022215"/>
             <a:ext cx="0" cy="76200"/>
           </a:xfrm>
           <a:prstGeom prst="line">
@@ -33814,7 +31493,7 @@
         </p:nvSpPr>
         <p:spPr>
           <a:xfrm>
-            <a:off x="4000500" y="5499100"/>
+            <a:off x="3980180" y="5161915"/>
             <a:ext cx="203200" cy="115416"/>
           </a:xfrm>
           <a:prstGeom prst="rect">
@@ -33857,7 +31536,7 @@
         </p:nvCxnSpPr>
         <p:spPr>
           <a:xfrm>
-            <a:off x="7264400" y="5064125"/>
+            <a:off x="7244080" y="4726940"/>
             <a:ext cx="3302000" cy="0"/>
           </a:xfrm>
           <a:prstGeom prst="line">
@@ -33892,7 +31571,7 @@
         </p:nvCxnSpPr>
         <p:spPr>
           <a:xfrm>
-            <a:off x="7264400" y="4730750"/>
+            <a:off x="7244080" y="4393565"/>
             <a:ext cx="3302000" cy="0"/>
           </a:xfrm>
           <a:prstGeom prst="line">
@@ -33927,7 +31606,7 @@
         </p:nvCxnSpPr>
         <p:spPr>
           <a:xfrm>
-            <a:off x="7264400" y="4397375"/>
+            <a:off x="7244080" y="4060190"/>
             <a:ext cx="3302000" cy="0"/>
           </a:xfrm>
           <a:prstGeom prst="line">
@@ -33962,7 +31641,7 @@
         </p:nvCxnSpPr>
         <p:spPr>
           <a:xfrm>
-            <a:off x="7264400" y="5397500"/>
+            <a:off x="7244080" y="5060315"/>
             <a:ext cx="3302000" cy="0"/>
           </a:xfrm>
           <a:prstGeom prst="line">
@@ -33997,7 +31676,7 @@
         </p:nvCxnSpPr>
         <p:spPr>
           <a:xfrm>
-            <a:off x="7264400" y="4064000"/>
+            <a:off x="7244080" y="3726815"/>
             <a:ext cx="0" cy="1333500"/>
           </a:xfrm>
           <a:prstGeom prst="line">
@@ -34032,7 +31711,7 @@
         </p:nvSpPr>
         <p:spPr>
           <a:xfrm>
-            <a:off x="10261600" y="5499100"/>
+            <a:off x="10241280" y="5161915"/>
             <a:ext cx="381000" cy="123111"/>
           </a:xfrm>
           <a:prstGeom prst="rect">
@@ -34074,7 +31753,7 @@
         </p:nvSpPr>
         <p:spPr>
           <a:xfrm>
-            <a:off x="7213600" y="3886200"/>
+            <a:off x="7193280" y="3549015"/>
             <a:ext cx="584200" cy="224677"/>
           </a:xfrm>
           <a:prstGeom prst="rect">
@@ -34114,7 +31793,7 @@
         </p:nvCxnSpPr>
         <p:spPr>
           <a:xfrm>
-            <a:off x="8089900" y="5359400"/>
+            <a:off x="8069580" y="5022215"/>
             <a:ext cx="0" cy="76200"/>
           </a:xfrm>
           <a:prstGeom prst="line">
@@ -34149,7 +31828,7 @@
         </p:nvSpPr>
         <p:spPr>
           <a:xfrm>
-            <a:off x="7988300" y="5499100"/>
+            <a:off x="7967980" y="5161915"/>
             <a:ext cx="203200" cy="115416"/>
           </a:xfrm>
           <a:prstGeom prst="rect">
@@ -34192,7 +31871,7 @@
         </p:nvCxnSpPr>
         <p:spPr>
           <a:xfrm>
-            <a:off x="8915400" y="5359400"/>
+            <a:off x="8895080" y="5022215"/>
             <a:ext cx="0" cy="76200"/>
           </a:xfrm>
           <a:prstGeom prst="line">
@@ -34227,7 +31906,7 @@
         </p:nvSpPr>
         <p:spPr>
           <a:xfrm>
-            <a:off x="8813800" y="5499100"/>
+            <a:off x="8793480" y="5161915"/>
             <a:ext cx="203200" cy="115416"/>
           </a:xfrm>
           <a:prstGeom prst="rect">
@@ -34270,7 +31949,7 @@
         </p:nvCxnSpPr>
         <p:spPr>
           <a:xfrm>
-            <a:off x="9740900" y="5359400"/>
+            <a:off x="9720580" y="5022215"/>
             <a:ext cx="0" cy="76200"/>
           </a:xfrm>
           <a:prstGeom prst="line">
@@ -34305,7 +31984,7 @@
         </p:nvSpPr>
         <p:spPr>
           <a:xfrm>
-            <a:off x="9639300" y="5499100"/>
+            <a:off x="9618980" y="5161915"/>
             <a:ext cx="203200" cy="115416"/>
           </a:xfrm>
           <a:prstGeom prst="rect">
@@ -34348,7 +32027,7 @@
         </p:nvCxnSpPr>
         <p:spPr>
           <a:xfrm flipV="1">
-            <a:off x="1625600" y="5395830"/>
+            <a:off x="1605280" y="5058645"/>
             <a:ext cx="137583" cy="1670"/>
           </a:xfrm>
           <a:prstGeom prst="line">
@@ -34383,7 +32062,7 @@
         </p:nvCxnSpPr>
         <p:spPr>
           <a:xfrm flipV="1">
-            <a:off x="1763183" y="5393755"/>
+            <a:off x="1742863" y="5056570"/>
             <a:ext cx="137584" cy="2075"/>
           </a:xfrm>
           <a:prstGeom prst="line">
@@ -34418,7 +32097,7 @@
         </p:nvCxnSpPr>
         <p:spPr>
           <a:xfrm flipV="1">
-            <a:off x="1900767" y="5391179"/>
+            <a:off x="1880447" y="5053994"/>
             <a:ext cx="137583" cy="2576"/>
           </a:xfrm>
           <a:prstGeom prst="line">
@@ -34453,7 +32132,7 @@
         </p:nvCxnSpPr>
         <p:spPr>
           <a:xfrm flipV="1">
-            <a:off x="2038350" y="5387980"/>
+            <a:off x="2018030" y="5050795"/>
             <a:ext cx="137583" cy="3199"/>
           </a:xfrm>
           <a:prstGeom prst="line">
@@ -34488,7 +32167,7 @@
         </p:nvCxnSpPr>
         <p:spPr>
           <a:xfrm flipV="1">
-            <a:off x="2175933" y="5384006"/>
+            <a:off x="2155613" y="5046821"/>
             <a:ext cx="137584" cy="3974"/>
           </a:xfrm>
           <a:prstGeom prst="line">
@@ -34523,7 +32202,7 @@
         </p:nvCxnSpPr>
         <p:spPr>
           <a:xfrm flipV="1">
-            <a:off x="2313517" y="5379071"/>
+            <a:off x="2293197" y="5041886"/>
             <a:ext cx="137583" cy="4935"/>
           </a:xfrm>
           <a:prstGeom prst="line">
@@ -34558,7 +32237,7 @@
         </p:nvCxnSpPr>
         <p:spPr>
           <a:xfrm flipV="1">
-            <a:off x="2451100" y="5372943"/>
+            <a:off x="2430780" y="5035758"/>
             <a:ext cx="137583" cy="6128"/>
           </a:xfrm>
           <a:prstGeom prst="line">
@@ -34593,7 +32272,7 @@
         </p:nvCxnSpPr>
         <p:spPr>
           <a:xfrm flipV="1">
-            <a:off x="2588683" y="5365331"/>
+            <a:off x="2568363" y="5028146"/>
             <a:ext cx="137584" cy="7612"/>
           </a:xfrm>
           <a:prstGeom prst="line">
@@ -34628,7 +32307,7 @@
         </p:nvCxnSpPr>
         <p:spPr>
           <a:xfrm flipV="1">
-            <a:off x="2726267" y="5355878"/>
+            <a:off x="2705947" y="5018693"/>
             <a:ext cx="137583" cy="9453"/>
           </a:xfrm>
           <a:prstGeom prst="line">
@@ -34663,7 +32342,7 @@
         </p:nvCxnSpPr>
         <p:spPr>
           <a:xfrm flipV="1">
-            <a:off x="2863850" y="5344138"/>
+            <a:off x="2843530" y="5006953"/>
             <a:ext cx="137583" cy="11740"/>
           </a:xfrm>
           <a:prstGeom prst="line">
@@ -34698,7 +32377,7 @@
         </p:nvCxnSpPr>
         <p:spPr>
           <a:xfrm flipV="1">
-            <a:off x="3001433" y="5329558"/>
+            <a:off x="2981113" y="4992373"/>
             <a:ext cx="137584" cy="14580"/>
           </a:xfrm>
           <a:prstGeom prst="line">
@@ -34733,7 +32412,7 @@
         </p:nvCxnSpPr>
         <p:spPr>
           <a:xfrm flipV="1">
-            <a:off x="3139017" y="5311450"/>
+            <a:off x="3118697" y="4974265"/>
             <a:ext cx="137583" cy="18108"/>
           </a:xfrm>
           <a:prstGeom prst="line">
@@ -34768,7 +32447,7 @@
         </p:nvCxnSpPr>
         <p:spPr>
           <a:xfrm flipV="1">
-            <a:off x="3276600" y="5288962"/>
+            <a:off x="3256280" y="4951777"/>
             <a:ext cx="137583" cy="22488"/>
           </a:xfrm>
           <a:prstGeom prst="line">
@@ -34803,7 +32482,7 @@
         </p:nvCxnSpPr>
         <p:spPr>
           <a:xfrm flipV="1">
-            <a:off x="3414183" y="5261033"/>
+            <a:off x="3393863" y="4923848"/>
             <a:ext cx="137584" cy="27929"/>
           </a:xfrm>
           <a:prstGeom prst="line">
@@ -34838,7 +32517,7 @@
         </p:nvCxnSpPr>
         <p:spPr>
           <a:xfrm flipV="1">
-            <a:off x="3551767" y="5226347"/>
+            <a:off x="3531447" y="4889162"/>
             <a:ext cx="137583" cy="34686"/>
           </a:xfrm>
           <a:prstGeom prst="line">
@@ -34873,7 +32552,7 @@
         </p:nvCxnSpPr>
         <p:spPr>
           <a:xfrm flipV="1">
-            <a:off x="3689350" y="5183270"/>
+            <a:off x="3669030" y="4846085"/>
             <a:ext cx="137583" cy="43077"/>
           </a:xfrm>
           <a:prstGeom prst="line">
@@ -34908,7 +32587,7 @@
         </p:nvCxnSpPr>
         <p:spPr>
           <a:xfrm flipV="1">
-            <a:off x="3826933" y="5129771"/>
+            <a:off x="3806613" y="4792586"/>
             <a:ext cx="137584" cy="53499"/>
           </a:xfrm>
           <a:prstGeom prst="line">
@@ -34943,7 +32622,7 @@
         </p:nvCxnSpPr>
         <p:spPr>
           <a:xfrm flipV="1">
-            <a:off x="3964517" y="5063329"/>
+            <a:off x="3944197" y="4726144"/>
             <a:ext cx="137583" cy="66442"/>
           </a:xfrm>
           <a:prstGeom prst="line">
@@ -34978,7 +32657,7 @@
         </p:nvCxnSpPr>
         <p:spPr>
           <a:xfrm flipV="1">
-            <a:off x="4102100" y="4980813"/>
+            <a:off x="4081780" y="4643628"/>
             <a:ext cx="137583" cy="82516"/>
           </a:xfrm>
           <a:prstGeom prst="line">
@@ -35013,7 +32692,7 @@
         </p:nvCxnSpPr>
         <p:spPr>
           <a:xfrm flipV="1">
-            <a:off x="4239683" y="4878334"/>
+            <a:off x="4219363" y="4541149"/>
             <a:ext cx="137584" cy="102479"/>
           </a:xfrm>
           <a:prstGeom prst="line">
@@ -35048,7 +32727,7 @@
         </p:nvCxnSpPr>
         <p:spPr>
           <a:xfrm flipV="1">
-            <a:off x="4377267" y="4751062"/>
+            <a:off x="4356947" y="4413877"/>
             <a:ext cx="137583" cy="127272"/>
           </a:xfrm>
           <a:prstGeom prst="line">
@@ -35083,7 +32762,7 @@
         </p:nvCxnSpPr>
         <p:spPr>
           <a:xfrm flipV="1">
-            <a:off x="4514850" y="4592998"/>
+            <a:off x="4494530" y="4255813"/>
             <a:ext cx="137583" cy="158064"/>
           </a:xfrm>
           <a:prstGeom prst="line">
@@ -35118,7 +32797,7 @@
         </p:nvCxnSpPr>
         <p:spPr>
           <a:xfrm flipV="1">
-            <a:off x="4652433" y="4396695"/>
+            <a:off x="4632113" y="4059510"/>
             <a:ext cx="137584" cy="196303"/>
           </a:xfrm>
           <a:prstGeom prst="line">
@@ -35153,7 +32832,7 @@
         </p:nvCxnSpPr>
         <p:spPr>
           <a:xfrm flipV="1">
-            <a:off x="4790017" y="4152900"/>
+            <a:off x="4769697" y="3815715"/>
             <a:ext cx="137583" cy="243795"/>
           </a:xfrm>
           <a:prstGeom prst="line">
@@ -35188,7 +32867,7 @@
         </p:nvCxnSpPr>
         <p:spPr>
           <a:xfrm flipV="1">
-            <a:off x="7264400" y="5397126"/>
+            <a:off x="7244080" y="5059941"/>
             <a:ext cx="137583" cy="374"/>
           </a:xfrm>
           <a:prstGeom prst="line">
@@ -35223,7 +32902,7 @@
         </p:nvCxnSpPr>
         <p:spPr>
           <a:xfrm flipV="1">
-            <a:off x="7401983" y="5395387"/>
+            <a:off x="7381663" y="5058202"/>
             <a:ext cx="137584" cy="1739"/>
           </a:xfrm>
           <a:prstGeom prst="line">
@@ -35258,7 +32937,7 @@
         </p:nvCxnSpPr>
         <p:spPr>
           <a:xfrm flipV="1">
-            <a:off x="7539567" y="5391677"/>
+            <a:off x="7519247" y="5054492"/>
             <a:ext cx="137583" cy="3710"/>
           </a:xfrm>
           <a:prstGeom prst="line">
@@ -35293,7 +32972,7 @@
         </p:nvCxnSpPr>
         <p:spPr>
           <a:xfrm flipV="1">
-            <a:off x="7677150" y="5385546"/>
+            <a:off x="7656830" y="5048361"/>
             <a:ext cx="137583" cy="6131"/>
           </a:xfrm>
           <a:prstGeom prst="line">
@@ -35328,7 +33007,7 @@
         </p:nvCxnSpPr>
         <p:spPr>
           <a:xfrm flipV="1">
-            <a:off x="7814733" y="5376618"/>
+            <a:off x="7794413" y="5039433"/>
             <a:ext cx="137584" cy="8928"/>
           </a:xfrm>
           <a:prstGeom prst="line">
@@ -35363,7 +33042,7 @@
         </p:nvCxnSpPr>
         <p:spPr>
           <a:xfrm flipV="1">
-            <a:off x="7952317" y="5364559"/>
+            <a:off x="7931997" y="5027374"/>
             <a:ext cx="137583" cy="12059"/>
           </a:xfrm>
           <a:prstGeom prst="line">
@@ -35398,7 +33077,7 @@
         </p:nvCxnSpPr>
         <p:spPr>
           <a:xfrm flipV="1">
-            <a:off x="8089900" y="5349072"/>
+            <a:off x="8069580" y="5011887"/>
             <a:ext cx="137583" cy="15487"/>
           </a:xfrm>
           <a:prstGeom prst="line">
@@ -35433,7 +33112,7 @@
         </p:nvCxnSpPr>
         <p:spPr>
           <a:xfrm flipV="1">
-            <a:off x="8227483" y="5329879"/>
+            <a:off x="8207163" y="4992694"/>
             <a:ext cx="137584" cy="19193"/>
           </a:xfrm>
           <a:prstGeom prst="line">
@@ -35468,7 +33147,7 @@
         </p:nvCxnSpPr>
         <p:spPr>
           <a:xfrm flipV="1">
-            <a:off x="8365067" y="5306726"/>
+            <a:off x="8344747" y="4969541"/>
             <a:ext cx="137583" cy="23153"/>
           </a:xfrm>
           <a:prstGeom prst="line">
@@ -35503,7 +33182,7 @@
         </p:nvCxnSpPr>
         <p:spPr>
           <a:xfrm flipV="1">
-            <a:off x="8502650" y="5279372"/>
+            <a:off x="8482330" y="4942187"/>
             <a:ext cx="137583" cy="27354"/>
           </a:xfrm>
           <a:prstGeom prst="line">
@@ -35538,7 +33217,7 @@
         </p:nvCxnSpPr>
         <p:spPr>
           <a:xfrm flipV="1">
-            <a:off x="8640233" y="5247588"/>
+            <a:off x="8619913" y="4910403"/>
             <a:ext cx="137584" cy="31784"/>
           </a:xfrm>
           <a:prstGeom prst="line">
@@ -35573,7 +33252,7 @@
         </p:nvCxnSpPr>
         <p:spPr>
           <a:xfrm flipV="1">
-            <a:off x="8777817" y="5211160"/>
+            <a:off x="8757497" y="4873975"/>
             <a:ext cx="137583" cy="36428"/>
           </a:xfrm>
           <a:prstGeom prst="line">
@@ -35608,7 +33287,7 @@
         </p:nvCxnSpPr>
         <p:spPr>
           <a:xfrm flipV="1">
-            <a:off x="8915400" y="5169879"/>
+            <a:off x="8895080" y="4832694"/>
             <a:ext cx="137583" cy="41281"/>
           </a:xfrm>
           <a:prstGeom prst="line">
@@ -35643,7 +33322,7 @@
         </p:nvCxnSpPr>
         <p:spPr>
           <a:xfrm flipV="1">
-            <a:off x="9052983" y="5123549"/>
+            <a:off x="9032663" y="4786364"/>
             <a:ext cx="137584" cy="46330"/>
           </a:xfrm>
           <a:prstGeom prst="line">
@@ -35678,7 +33357,7 @@
         </p:nvCxnSpPr>
         <p:spPr>
           <a:xfrm flipV="1">
-            <a:off x="9190567" y="5071977"/>
+            <a:off x="9170247" y="4734792"/>
             <a:ext cx="137583" cy="51572"/>
           </a:xfrm>
           <a:prstGeom prst="line">
@@ -35713,7 +33392,7 @@
         </p:nvCxnSpPr>
         <p:spPr>
           <a:xfrm flipV="1">
-            <a:off x="9328150" y="5014980"/>
+            <a:off x="9307830" y="4677795"/>
             <a:ext cx="137583" cy="56997"/>
           </a:xfrm>
           <a:prstGeom prst="line">
@@ -35748,7 +33427,7 @@
         </p:nvCxnSpPr>
         <p:spPr>
           <a:xfrm flipV="1">
-            <a:off x="9465733" y="4952381"/>
+            <a:off x="9445413" y="4615196"/>
             <a:ext cx="137584" cy="62599"/>
           </a:xfrm>
           <a:prstGeom prst="line">
@@ -35783,7 +33462,7 @@
         </p:nvCxnSpPr>
         <p:spPr>
           <a:xfrm flipV="1">
-            <a:off x="9603317" y="4884007"/>
+            <a:off x="9582997" y="4546822"/>
             <a:ext cx="137583" cy="68374"/>
           </a:xfrm>
           <a:prstGeom prst="line">
@@ -35818,7 +33497,7 @@
         </p:nvCxnSpPr>
         <p:spPr>
           <a:xfrm flipV="1">
-            <a:off x="9740900" y="4809689"/>
+            <a:off x="9720580" y="4472504"/>
             <a:ext cx="137583" cy="74318"/>
           </a:xfrm>
           <a:prstGeom prst="line">
@@ -35853,7 +33532,7 @@
         </p:nvCxnSpPr>
         <p:spPr>
           <a:xfrm flipV="1">
-            <a:off x="9878483" y="4729266"/>
+            <a:off x="9858163" y="4392081"/>
             <a:ext cx="137584" cy="80423"/>
           </a:xfrm>
           <a:prstGeom prst="line">
@@ -35888,7 +33567,7 @@
         </p:nvCxnSpPr>
         <p:spPr>
           <a:xfrm flipV="1">
-            <a:off x="10016067" y="4642578"/>
+            <a:off x="9995747" y="4305393"/>
             <a:ext cx="137583" cy="86688"/>
           </a:xfrm>
           <a:prstGeom prst="line">
@@ -35923,7 +33602,7 @@
         </p:nvCxnSpPr>
         <p:spPr>
           <a:xfrm flipV="1">
-            <a:off x="10153650" y="4549472"/>
+            <a:off x="10133330" y="4212287"/>
             <a:ext cx="137583" cy="93106"/>
           </a:xfrm>
           <a:prstGeom prst="line">
@@ -35958,7 +33637,7 @@
         </p:nvCxnSpPr>
         <p:spPr>
           <a:xfrm flipV="1">
-            <a:off x="10291233" y="4449795"/>
+            <a:off x="10270913" y="4112610"/>
             <a:ext cx="137584" cy="99677"/>
           </a:xfrm>
           <a:prstGeom prst="line">
@@ -35993,7 +33672,7 @@
         </p:nvCxnSpPr>
         <p:spPr>
           <a:xfrm flipV="1">
-            <a:off x="10428817" y="4343400"/>
+            <a:off x="10408497" y="4006215"/>
             <a:ext cx="137583" cy="106395"/>
           </a:xfrm>
           <a:prstGeom prst="line">
@@ -36028,7 +33707,7 @@
         </p:nvCxnSpPr>
         <p:spPr>
           <a:xfrm>
-            <a:off x="3870960" y="4114800"/>
+            <a:off x="3850640" y="3777615"/>
             <a:ext cx="0" cy="1282700"/>
           </a:xfrm>
           <a:prstGeom prst="line">
@@ -36064,7 +33743,7 @@
         </p:nvSpPr>
         <p:spPr>
           <a:xfrm>
-            <a:off x="3934460" y="4203700"/>
+            <a:off x="3914140" y="3866515"/>
             <a:ext cx="863600" cy="233910"/>
           </a:xfrm>
           <a:prstGeom prst="rect">
@@ -36117,7 +33796,7 @@
         </p:nvSpPr>
         <p:spPr>
           <a:xfrm>
-            <a:off x="8788400" y="4267200"/>
+            <a:off x="8768080" y="3930015"/>
             <a:ext cx="1346200" cy="304800"/>
           </a:xfrm>
           <a:prstGeom prst="roundRect">
@@ -36165,7 +33844,7 @@
         </p:nvSpPr>
         <p:spPr>
           <a:xfrm>
-            <a:off x="8915400" y="4356100"/>
+            <a:off x="8895080" y="4018915"/>
             <a:ext cx="1092200" cy="129266"/>
           </a:xfrm>
           <a:prstGeom prst="rect">
@@ -36208,7 +33887,7 @@
         </p:nvSpPr>
         <p:spPr>
           <a:xfrm>
-            <a:off x="1625600" y="3530600"/>
+            <a:off x="1605280" y="3193415"/>
             <a:ext cx="3492500" cy="254635"/>
           </a:xfrm>
           <a:prstGeom prst="rect">
@@ -36254,7 +33933,7 @@
         </p:nvSpPr>
         <p:spPr>
           <a:xfrm>
-            <a:off x="7264400" y="3530600"/>
+            <a:off x="7244080" y="3193415"/>
             <a:ext cx="3492500" cy="301621"/>
           </a:xfrm>
           <a:prstGeom prst="rect">
@@ -36311,7 +33990,7 @@
         </p:nvSpPr>
         <p:spPr>
           <a:xfrm>
-            <a:off x="5918200" y="3835400"/>
+            <a:off x="5897880" y="3498215"/>
             <a:ext cx="558800" cy="307777"/>
           </a:xfrm>
           <a:prstGeom prst="rect">
@@ -36354,7 +34033,7 @@
         </p:nvCxnSpPr>
         <p:spPr>
           <a:xfrm>
-            <a:off x="5803900" y="4216400"/>
+            <a:off x="5783580" y="3879215"/>
             <a:ext cx="787400" cy="0"/>
           </a:xfrm>
           <a:prstGeom prst="line">
@@ -36390,7 +34069,7 @@
         </p:nvSpPr>
         <p:spPr>
           <a:xfrm>
-            <a:off x="2628900" y="6172200"/>
+            <a:off x="2608580" y="6067425"/>
             <a:ext cx="7137400" cy="431800"/>
           </a:xfrm>
           <a:prstGeom prst="roundRect">
@@ -36438,7 +34117,7 @@
         </p:nvSpPr>
         <p:spPr>
           <a:xfrm>
-            <a:off x="2921000" y="6311900"/>
+            <a:off x="2900680" y="6207125"/>
             <a:ext cx="6553200" cy="158505"/>
           </a:xfrm>
           <a:prstGeom prst="rect">
@@ -36452,6 +34131,7 @@
           </a:bodyPr>
           <a:lstStyle/>
           <a:p>
+            <a:pPr algn="ctr"/>
             <a:r>
               <a:rPr sz="900" b="1">
                 <a:solidFill>
@@ -36478,7 +34158,7 @@
         </p:nvSpPr>
         <p:spPr>
           <a:xfrm>
-            <a:off x="7086600" y="5715000"/>
+            <a:off x="7066280" y="5377815"/>
             <a:ext cx="3566160" cy="201168"/>
           </a:xfrm>
           <a:prstGeom prst="rect">
@@ -36519,7 +34199,7 @@
         </p:nvSpPr>
         <p:spPr>
           <a:xfrm>
-            <a:off x="11350752" y="6528816"/>
+            <a:off x="11330432" y="6191631"/>
             <a:ext cx="713232" cy="182880"/>
           </a:xfrm>
           <a:prstGeom prst="rect">
@@ -36564,151 +34244,9 @@
     <a:masterClrMapping/>
   </p:clrMapOvr>
   <mc:AlternateContent xmlns:mc="http://schemas.openxmlformats.org/markup-compatibility/2006" xmlns:p159="http://schemas.microsoft.com/office/powerpoint/2015/09/main">
-    <mc:Choice Requires="p159">
-      <p:transition xmlns:p14="http://schemas.microsoft.com/office/powerpoint/2010/main" spd="slow" p14:dur="2000">
-        <p159:morph option="byObject"/>
-      </p:transition>
-    </mc:Choice>
-    <mc:Fallback>
-      <p:transition spd="slow">
-        <p:fade/>
-      </p:transition>
-    </mc:Fallback>
+    <mc:Choice Requires="p159"/>
+    <mc:Fallback/>
   </mc:AlternateContent>
-  <p:timing>
-    <p:tnLst>
-      <p:par>
-        <p:cTn id="1" dur="indefinite" restart="never" nodeType="tmRoot">
-          <p:childTnLst>
-            <p:seq concurrent="1" nextAc="seek">
-              <p:cTn id="2" dur="indefinite" nodeType="mainSeq">
-                <p:childTnLst>
-                  <p:par>
-                    <p:cTn id="3" fill="hold">
-                      <p:stCondLst>
-                        <p:cond delay="indefinite"/>
-                        <p:cond evt="onBegin" delay="0">
-                          <p:tn val="2"/>
-                        </p:cond>
-                      </p:stCondLst>
-                      <p:childTnLst>
-                        <p:par>
-                          <p:cTn id="4" fill="hold">
-                            <p:stCondLst>
-                              <p:cond delay="0"/>
-                            </p:stCondLst>
-                            <p:childTnLst>
-                              <p:par>
-                                <p:cTn id="5" presetID="10" presetClass="entr" presetSubtype="0" fill="hold" grpId="0" nodeType="afterEffect">
-                                  <p:stCondLst>
-                                    <p:cond delay="0"/>
-                                  </p:stCondLst>
-                                  <p:childTnLst>
-                                    <p:set>
-                                      <p:cBhvr>
-                                        <p:cTn id="6" dur="1" fill="hold">
-                                          <p:stCondLst>
-                                            <p:cond delay="0"/>
-                                          </p:stCondLst>
-                                        </p:cTn>
-                                        <p:tgtEl>
-                                          <p:spTgt spid="64"/>
-                                        </p:tgtEl>
-                                        <p:attrNameLst>
-                                          <p:attrName>style.visibility</p:attrName>
-                                        </p:attrNameLst>
-                                      </p:cBhvr>
-                                      <p:to>
-                                        <p:strVal val="visible"/>
-                                      </p:to>
-                                    </p:set>
-                                    <p:animEffect transition="in" filter="fade">
-                                      <p:cBhvr>
-                                        <p:cTn id="7" dur="500"/>
-                                        <p:tgtEl>
-                                          <p:spTgt spid="64"/>
-                                        </p:tgtEl>
-                                      </p:cBhvr>
-                                    </p:animEffect>
-                                  </p:childTnLst>
-                                </p:cTn>
-                              </p:par>
-                            </p:childTnLst>
-                          </p:cTn>
-                        </p:par>
-                        <p:par>
-                          <p:cTn id="8" fill="hold">
-                            <p:stCondLst>
-                              <p:cond delay="500"/>
-                            </p:stCondLst>
-                            <p:childTnLst>
-                              <p:par>
-                                <p:cTn id="9" presetID="10" presetClass="entr" presetSubtype="0" fill="hold" grpId="0" nodeType="afterEffect">
-                                  <p:stCondLst>
-                                    <p:cond delay="0"/>
-                                  </p:stCondLst>
-                                  <p:childTnLst>
-                                    <p:set>
-                                      <p:cBhvr>
-                                        <p:cTn id="10" dur="1" fill="hold">
-                                          <p:stCondLst>
-                                            <p:cond delay="0"/>
-                                          </p:stCondLst>
-                                        </p:cTn>
-                                        <p:tgtEl>
-                                          <p:spTgt spid="87"/>
-                                        </p:tgtEl>
-                                        <p:attrNameLst>
-                                          <p:attrName>style.visibility</p:attrName>
-                                        </p:attrNameLst>
-                                      </p:cBhvr>
-                                      <p:to>
-                                        <p:strVal val="visible"/>
-                                      </p:to>
-                                    </p:set>
-                                    <p:animEffect transition="in" filter="fade">
-                                      <p:cBhvr>
-                                        <p:cTn id="11" dur="500"/>
-                                        <p:tgtEl>
-                                          <p:spTgt spid="87"/>
-                                        </p:tgtEl>
-                                      </p:cBhvr>
-                                    </p:animEffect>
-                                  </p:childTnLst>
-                                </p:cTn>
-                              </p:par>
-                            </p:childTnLst>
-                          </p:cTn>
-                        </p:par>
-                      </p:childTnLst>
-                    </p:cTn>
-                  </p:par>
-                </p:childTnLst>
-              </p:cTn>
-              <p:prevCondLst>
-                <p:cond evt="onPrev" delay="0">
-                  <p:tgtEl>
-                    <p:sldTgt/>
-                  </p:tgtEl>
-                </p:cond>
-              </p:prevCondLst>
-              <p:nextCondLst>
-                <p:cond evt="onNext" delay="0">
-                  <p:tgtEl>
-                    <p:sldTgt/>
-                  </p:tgtEl>
-                </p:cond>
-              </p:nextCondLst>
-            </p:seq>
-          </p:childTnLst>
-        </p:cTn>
-      </p:par>
-    </p:tnLst>
-    <p:bldLst>
-      <p:bldP spid="64" grpId="0" animBg="1"/>
-      <p:bldP spid="87" grpId="0" animBg="1"/>
-    </p:bldLst>
-  </p:timing>
 </p:sld>
 </file>
 
@@ -39289,151 +36827,9 @@
     <a:masterClrMapping/>
   </p:clrMapOvr>
   <mc:AlternateContent xmlns:mc="http://schemas.openxmlformats.org/markup-compatibility/2006" xmlns:p159="http://schemas.microsoft.com/office/powerpoint/2015/09/main">
-    <mc:Choice Requires="p159">
-      <p:transition xmlns:p14="http://schemas.microsoft.com/office/powerpoint/2010/main" spd="slow" p14:dur="2000">
-        <p159:morph option="byObject"/>
-      </p:transition>
-    </mc:Choice>
-    <mc:Fallback>
-      <p:transition spd="slow">
-        <p:fade/>
-      </p:transition>
-    </mc:Fallback>
+    <mc:Choice Requires="p159"/>
+    <mc:Fallback/>
   </mc:AlternateContent>
-  <p:timing>
-    <p:tnLst>
-      <p:par>
-        <p:cTn id="1" dur="indefinite" restart="never" nodeType="tmRoot">
-          <p:childTnLst>
-            <p:seq concurrent="1" nextAc="seek">
-              <p:cTn id="2" dur="indefinite" nodeType="mainSeq">
-                <p:childTnLst>
-                  <p:par>
-                    <p:cTn id="3" fill="hold">
-                      <p:stCondLst>
-                        <p:cond delay="indefinite"/>
-                        <p:cond evt="onBegin" delay="0">
-                          <p:tn val="2"/>
-                        </p:cond>
-                      </p:stCondLst>
-                      <p:childTnLst>
-                        <p:par>
-                          <p:cTn id="4" fill="hold">
-                            <p:stCondLst>
-                              <p:cond delay="0"/>
-                            </p:stCondLst>
-                            <p:childTnLst>
-                              <p:par>
-                                <p:cTn id="5" presetID="10" presetClass="entr" presetSubtype="0" fill="hold" grpId="0" nodeType="afterEffect">
-                                  <p:stCondLst>
-                                    <p:cond delay="0"/>
-                                  </p:stCondLst>
-                                  <p:childTnLst>
-                                    <p:set>
-                                      <p:cBhvr>
-                                        <p:cTn id="6" dur="1" fill="hold">
-                                          <p:stCondLst>
-                                            <p:cond delay="0"/>
-                                          </p:stCondLst>
-                                        </p:cTn>
-                                        <p:tgtEl>
-                                          <p:spTgt spid="64"/>
-                                        </p:tgtEl>
-                                        <p:attrNameLst>
-                                          <p:attrName>style.visibility</p:attrName>
-                                        </p:attrNameLst>
-                                      </p:cBhvr>
-                                      <p:to>
-                                        <p:strVal val="visible"/>
-                                      </p:to>
-                                    </p:set>
-                                    <p:animEffect transition="in" filter="fade">
-                                      <p:cBhvr>
-                                        <p:cTn id="7" dur="500"/>
-                                        <p:tgtEl>
-                                          <p:spTgt spid="64"/>
-                                        </p:tgtEl>
-                                      </p:cBhvr>
-                                    </p:animEffect>
-                                  </p:childTnLst>
-                                </p:cTn>
-                              </p:par>
-                            </p:childTnLst>
-                          </p:cTn>
-                        </p:par>
-                        <p:par>
-                          <p:cTn id="8" fill="hold">
-                            <p:stCondLst>
-                              <p:cond delay="500"/>
-                            </p:stCondLst>
-                            <p:childTnLst>
-                              <p:par>
-                                <p:cTn id="9" presetID="10" presetClass="entr" presetSubtype="0" fill="hold" grpId="0" nodeType="afterEffect">
-                                  <p:stCondLst>
-                                    <p:cond delay="0"/>
-                                  </p:stCondLst>
-                                  <p:childTnLst>
-                                    <p:set>
-                                      <p:cBhvr>
-                                        <p:cTn id="10" dur="1" fill="hold">
-                                          <p:stCondLst>
-                                            <p:cond delay="0"/>
-                                          </p:stCondLst>
-                                        </p:cTn>
-                                        <p:tgtEl>
-                                          <p:spTgt spid="87"/>
-                                        </p:tgtEl>
-                                        <p:attrNameLst>
-                                          <p:attrName>style.visibility</p:attrName>
-                                        </p:attrNameLst>
-                                      </p:cBhvr>
-                                      <p:to>
-                                        <p:strVal val="visible"/>
-                                      </p:to>
-                                    </p:set>
-                                    <p:animEffect transition="in" filter="fade">
-                                      <p:cBhvr>
-                                        <p:cTn id="11" dur="500"/>
-                                        <p:tgtEl>
-                                          <p:spTgt spid="87"/>
-                                        </p:tgtEl>
-                                      </p:cBhvr>
-                                    </p:animEffect>
-                                  </p:childTnLst>
-                                </p:cTn>
-                              </p:par>
-                            </p:childTnLst>
-                          </p:cTn>
-                        </p:par>
-                      </p:childTnLst>
-                    </p:cTn>
-                  </p:par>
-                </p:childTnLst>
-              </p:cTn>
-              <p:prevCondLst>
-                <p:cond evt="onPrev" delay="0">
-                  <p:tgtEl>
-                    <p:sldTgt/>
-                  </p:tgtEl>
-                </p:cond>
-              </p:prevCondLst>
-              <p:nextCondLst>
-                <p:cond evt="onNext" delay="0">
-                  <p:tgtEl>
-                    <p:sldTgt/>
-                  </p:tgtEl>
-                </p:cond>
-              </p:nextCondLst>
-            </p:seq>
-          </p:childTnLst>
-        </p:cTn>
-      </p:par>
-    </p:tnLst>
-    <p:bldLst>
-      <p:bldP spid="64" grpId="0" animBg="1"/>
-      <p:bldP spid="87" grpId="0" animBg="1"/>
-    </p:bldLst>
-  </p:timing>
 </p:sld>
 </file>
 
@@ -41727,8 +39123,8 @@
         </p:nvSpPr>
         <p:spPr>
           <a:xfrm>
-            <a:off x="896112" y="5971032"/>
-            <a:ext cx="9601200" cy="164592"/>
+            <a:off x="896112" y="5851017"/>
+            <a:ext cx="9601200" cy="204470"/>
           </a:xfrm>
           <a:prstGeom prst="rect">
             <a:avLst/>
@@ -41742,7 +39138,7 @@
           <a:lstStyle/>
           <a:p>
             <a:r>
-              <a:rPr sz="850" b="1">
+              <a:rPr sz="1100" b="1">
                 <a:solidFill>
                   <a:srgbClr val="FFFFFF"/>
                 </a:solidFill>
@@ -41750,7 +39146,7 @@
               </a:rPr>
               <a:t>front layer 把搜索焦点限制在当前真正受阻的双比特门附近。</a:t>
             </a:r>
-            <a:endParaRPr sz="850" b="1">
+            <a:endParaRPr sz="1100" b="1">
               <a:solidFill>
                 <a:srgbClr val="FFFFFF"/>
               </a:solidFill>
@@ -42111,151 +39507,9 @@
     <a:masterClrMapping/>
   </p:clrMapOvr>
   <mc:AlternateContent xmlns:mc="http://schemas.openxmlformats.org/markup-compatibility/2006" xmlns:p159="http://schemas.microsoft.com/office/powerpoint/2015/09/main">
-    <mc:Choice Requires="p159">
-      <p:transition xmlns:p14="http://schemas.microsoft.com/office/powerpoint/2010/main" spd="slow" p14:dur="2000">
-        <p159:morph option="byObject"/>
-      </p:transition>
-    </mc:Choice>
-    <mc:Fallback>
-      <p:transition spd="slow">
-        <p:fade/>
-      </p:transition>
-    </mc:Fallback>
+    <mc:Choice Requires="p159"/>
+    <mc:Fallback/>
   </mc:AlternateContent>
-  <p:timing>
-    <p:tnLst>
-      <p:par>
-        <p:cTn id="1" dur="indefinite" restart="never" nodeType="tmRoot">
-          <p:childTnLst>
-            <p:seq concurrent="1" nextAc="seek">
-              <p:cTn id="2" dur="indefinite" nodeType="mainSeq">
-                <p:childTnLst>
-                  <p:par>
-                    <p:cTn id="3" fill="hold">
-                      <p:stCondLst>
-                        <p:cond delay="indefinite"/>
-                        <p:cond evt="onBegin" delay="0">
-                          <p:tn val="2"/>
-                        </p:cond>
-                      </p:stCondLst>
-                      <p:childTnLst>
-                        <p:par>
-                          <p:cTn id="4" fill="hold">
-                            <p:stCondLst>
-                              <p:cond delay="0"/>
-                            </p:stCondLst>
-                            <p:childTnLst>
-                              <p:par>
-                                <p:cTn id="5" presetID="10" presetClass="entr" presetSubtype="0" fill="hold" grpId="0" nodeType="afterEffect">
-                                  <p:stCondLst>
-                                    <p:cond delay="0"/>
-                                  </p:stCondLst>
-                                  <p:childTnLst>
-                                    <p:set>
-                                      <p:cBhvr>
-                                        <p:cTn id="6" dur="1" fill="hold">
-                                          <p:stCondLst>
-                                            <p:cond delay="0"/>
-                                          </p:stCondLst>
-                                        </p:cTn>
-                                        <p:tgtEl>
-                                          <p:spTgt spid="64"/>
-                                        </p:tgtEl>
-                                        <p:attrNameLst>
-                                          <p:attrName>style.visibility</p:attrName>
-                                        </p:attrNameLst>
-                                      </p:cBhvr>
-                                      <p:to>
-                                        <p:strVal val="visible"/>
-                                      </p:to>
-                                    </p:set>
-                                    <p:animEffect transition="in" filter="fade">
-                                      <p:cBhvr>
-                                        <p:cTn id="7" dur="500"/>
-                                        <p:tgtEl>
-                                          <p:spTgt spid="64"/>
-                                        </p:tgtEl>
-                                      </p:cBhvr>
-                                    </p:animEffect>
-                                  </p:childTnLst>
-                                </p:cTn>
-                              </p:par>
-                            </p:childTnLst>
-                          </p:cTn>
-                        </p:par>
-                        <p:par>
-                          <p:cTn id="8" fill="hold">
-                            <p:stCondLst>
-                              <p:cond delay="500"/>
-                            </p:stCondLst>
-                            <p:childTnLst>
-                              <p:par>
-                                <p:cTn id="9" presetID="10" presetClass="entr" presetSubtype="0" fill="hold" grpId="0" nodeType="afterEffect">
-                                  <p:stCondLst>
-                                    <p:cond delay="0"/>
-                                  </p:stCondLst>
-                                  <p:childTnLst>
-                                    <p:set>
-                                      <p:cBhvr>
-                                        <p:cTn id="10" dur="1" fill="hold">
-                                          <p:stCondLst>
-                                            <p:cond delay="0"/>
-                                          </p:stCondLst>
-                                        </p:cTn>
-                                        <p:tgtEl>
-                                          <p:spTgt spid="87"/>
-                                        </p:tgtEl>
-                                        <p:attrNameLst>
-                                          <p:attrName>style.visibility</p:attrName>
-                                        </p:attrNameLst>
-                                      </p:cBhvr>
-                                      <p:to>
-                                        <p:strVal val="visible"/>
-                                      </p:to>
-                                    </p:set>
-                                    <p:animEffect transition="in" filter="fade">
-                                      <p:cBhvr>
-                                        <p:cTn id="11" dur="500"/>
-                                        <p:tgtEl>
-                                          <p:spTgt spid="87"/>
-                                        </p:tgtEl>
-                                      </p:cBhvr>
-                                    </p:animEffect>
-                                  </p:childTnLst>
-                                </p:cTn>
-                              </p:par>
-                            </p:childTnLst>
-                          </p:cTn>
-                        </p:par>
-                      </p:childTnLst>
-                    </p:cTn>
-                  </p:par>
-                </p:childTnLst>
-              </p:cTn>
-              <p:prevCondLst>
-                <p:cond evt="onPrev" delay="0">
-                  <p:tgtEl>
-                    <p:sldTgt/>
-                  </p:tgtEl>
-                </p:cond>
-              </p:prevCondLst>
-              <p:nextCondLst>
-                <p:cond evt="onNext" delay="0">
-                  <p:tgtEl>
-                    <p:sldTgt/>
-                  </p:tgtEl>
-                </p:cond>
-              </p:nextCondLst>
-            </p:seq>
-          </p:childTnLst>
-        </p:cTn>
-      </p:par>
-    </p:tnLst>
-    <p:bldLst>
-      <p:bldP spid="64" grpId="0" animBg="1"/>
-      <p:bldP spid="87" grpId="0" animBg="1"/>
-    </p:bldLst>
-  </p:timing>
 </p:sld>
 </file>
 

</xml_diff>

<commit_message>
Remove inherited transitions and add team contribution
</commit_message>
<xml_diff>
--- a/FinalProject/SABRE_Final_Presentation.pptx
+++ b/FinalProject/SABRE_Final_Presentation.pptx
@@ -741,16 +741,8 @@
     <a:masterClrMapping/>
   </p:clrMapOvr>
   <mc:AlternateContent xmlns:mc="http://schemas.openxmlformats.org/markup-compatibility/2006">
-    <mc:Choice xmlns:p14="http://schemas.microsoft.com/office/powerpoint/2010/main" Requires="p14">
-      <p:transition spd="slow" p14:dur="1500">
-        <p:split orient="vert"/>
-      </p:transition>
-    </mc:Choice>
-    <mc:Fallback>
-      <p:transition spd="slow">
-        <p:split orient="vert"/>
-      </p:transition>
-    </mc:Fallback>
+    <mc:Choice xmlns:p14="http://schemas.microsoft.com/office/powerpoint/2010/main" Requires="p14"/>
+    <mc:Fallback/>
   </mc:AlternateContent>
 </p:sldLayout>
 </file>
@@ -960,16 +952,8 @@
     <a:masterClrMapping/>
   </p:clrMapOvr>
   <mc:AlternateContent xmlns:mc="http://schemas.openxmlformats.org/markup-compatibility/2006">
-    <mc:Choice xmlns:p14="http://schemas.microsoft.com/office/powerpoint/2010/main" Requires="p14">
-      <p:transition spd="slow" p14:dur="1500">
-        <p:split orient="vert"/>
-      </p:transition>
-    </mc:Choice>
-    <mc:Fallback>
-      <p:transition spd="slow">
-        <p:split orient="vert"/>
-      </p:transition>
-    </mc:Fallback>
+    <mc:Choice xmlns:p14="http://schemas.microsoft.com/office/powerpoint/2010/main" Requires="p14"/>
+    <mc:Fallback/>
   </mc:AlternateContent>
 </p:sldLayout>
 </file>
@@ -1179,16 +1163,8 @@
     <a:masterClrMapping/>
   </p:clrMapOvr>
   <mc:AlternateContent xmlns:mc="http://schemas.openxmlformats.org/markup-compatibility/2006">
-    <mc:Choice xmlns:p14="http://schemas.microsoft.com/office/powerpoint/2010/main" Requires="p14">
-      <p:transition spd="slow" p14:dur="1500">
-        <p:split orient="vert"/>
-      </p:transition>
-    </mc:Choice>
-    <mc:Fallback>
-      <p:transition spd="slow">
-        <p:split orient="vert"/>
-      </p:transition>
-    </mc:Fallback>
+    <mc:Choice xmlns:p14="http://schemas.microsoft.com/office/powerpoint/2010/main" Requires="p14"/>
+    <mc:Fallback/>
   </mc:AlternateContent>
 </p:sldLayout>
 </file>
@@ -1398,16 +1374,8 @@
     <a:masterClrMapping/>
   </p:clrMapOvr>
   <mc:AlternateContent xmlns:mc="http://schemas.openxmlformats.org/markup-compatibility/2006">
-    <mc:Choice xmlns:p14="http://schemas.microsoft.com/office/powerpoint/2010/main" Requires="p14">
-      <p:transition spd="slow" p14:dur="1500">
-        <p:split orient="vert"/>
-      </p:transition>
-    </mc:Choice>
-    <mc:Fallback>
-      <p:transition spd="slow">
-        <p:split orient="vert"/>
-      </p:transition>
-    </mc:Fallback>
+    <mc:Choice xmlns:p14="http://schemas.microsoft.com/office/powerpoint/2010/main" Requires="p14"/>
+    <mc:Fallback/>
   </mc:AlternateContent>
 </p:sldLayout>
 </file>
@@ -1680,16 +1648,8 @@
     <a:masterClrMapping/>
   </p:clrMapOvr>
   <mc:AlternateContent xmlns:mc="http://schemas.openxmlformats.org/markup-compatibility/2006">
-    <mc:Choice xmlns:p14="http://schemas.microsoft.com/office/powerpoint/2010/main" Requires="p14">
-      <p:transition spd="slow" p14:dur="1500">
-        <p:split orient="vert"/>
-      </p:transition>
-    </mc:Choice>
-    <mc:Fallback>
-      <p:transition spd="slow">
-        <p:split orient="vert"/>
-      </p:transition>
-    </mc:Fallback>
+    <mc:Choice xmlns:p14="http://schemas.microsoft.com/office/powerpoint/2010/main" Requires="p14"/>
+    <mc:Fallback/>
   </mc:AlternateContent>
 </p:sldLayout>
 </file>
@@ -1963,16 +1923,8 @@
     <a:masterClrMapping/>
   </p:clrMapOvr>
   <mc:AlternateContent xmlns:mc="http://schemas.openxmlformats.org/markup-compatibility/2006">
-    <mc:Choice xmlns:p14="http://schemas.microsoft.com/office/powerpoint/2010/main" Requires="p14">
-      <p:transition spd="slow" p14:dur="1500">
-        <p:split orient="vert"/>
-      </p:transition>
-    </mc:Choice>
-    <mc:Fallback>
-      <p:transition spd="slow">
-        <p:split orient="vert"/>
-      </p:transition>
-    </mc:Fallback>
+    <mc:Choice xmlns:p14="http://schemas.microsoft.com/office/powerpoint/2010/main" Requires="p14"/>
+    <mc:Fallback/>
   </mc:AlternateContent>
 </p:sldLayout>
 </file>
@@ -2384,16 +2336,8 @@
     <a:masterClrMapping/>
   </p:clrMapOvr>
   <mc:AlternateContent xmlns:mc="http://schemas.openxmlformats.org/markup-compatibility/2006">
-    <mc:Choice xmlns:p14="http://schemas.microsoft.com/office/powerpoint/2010/main" Requires="p14">
-      <p:transition spd="slow" p14:dur="1500">
-        <p:split orient="vert"/>
-      </p:transition>
-    </mc:Choice>
-    <mc:Fallback>
-      <p:transition spd="slow">
-        <p:split orient="vert"/>
-      </p:transition>
-    </mc:Fallback>
+    <mc:Choice xmlns:p14="http://schemas.microsoft.com/office/powerpoint/2010/main" Requires="p14"/>
+    <mc:Fallback/>
   </mc:AlternateContent>
 </p:sldLayout>
 </file>
@@ -2539,16 +2483,8 @@
     <a:masterClrMapping/>
   </p:clrMapOvr>
   <mc:AlternateContent xmlns:mc="http://schemas.openxmlformats.org/markup-compatibility/2006">
-    <mc:Choice xmlns:p14="http://schemas.microsoft.com/office/powerpoint/2010/main" Requires="p14">
-      <p:transition spd="slow" p14:dur="1500">
-        <p:split orient="vert"/>
-      </p:transition>
-    </mc:Choice>
-    <mc:Fallback>
-      <p:transition spd="slow">
-        <p:split orient="vert"/>
-      </p:transition>
-    </mc:Fallback>
+    <mc:Choice xmlns:p14="http://schemas.microsoft.com/office/powerpoint/2010/main" Requires="p14"/>
+    <mc:Fallback/>
   </mc:AlternateContent>
 </p:sldLayout>
 </file>
@@ -2663,16 +2599,8 @@
     <a:masterClrMapping/>
   </p:clrMapOvr>
   <mc:AlternateContent xmlns:mc="http://schemas.openxmlformats.org/markup-compatibility/2006">
-    <mc:Choice xmlns:p14="http://schemas.microsoft.com/office/powerpoint/2010/main" Requires="p14">
-      <p:transition spd="slow" p14:dur="1500">
-        <p:split orient="vert"/>
-      </p:transition>
-    </mc:Choice>
-    <mc:Fallback>
-      <p:transition spd="slow">
-        <p:split orient="vert"/>
-      </p:transition>
-    </mc:Fallback>
+    <mc:Choice xmlns:p14="http://schemas.microsoft.com/office/powerpoint/2010/main" Requires="p14"/>
+    <mc:Fallback/>
   </mc:AlternateContent>
 </p:sldLayout>
 </file>
@@ -2983,16 +2911,8 @@
     <a:masterClrMapping/>
   </p:clrMapOvr>
   <mc:AlternateContent xmlns:mc="http://schemas.openxmlformats.org/markup-compatibility/2006">
-    <mc:Choice xmlns:p14="http://schemas.microsoft.com/office/powerpoint/2010/main" Requires="p14">
-      <p:transition spd="slow" p14:dur="1500">
-        <p:split orient="vert"/>
-      </p:transition>
-    </mc:Choice>
-    <mc:Fallback>
-      <p:transition spd="slow">
-        <p:split orient="vert"/>
-      </p:transition>
-    </mc:Fallback>
+    <mc:Choice xmlns:p14="http://schemas.microsoft.com/office/powerpoint/2010/main" Requires="p14"/>
+    <mc:Fallback/>
   </mc:AlternateContent>
 </p:sldLayout>
 </file>
@@ -3275,16 +3195,8 @@
     <a:masterClrMapping/>
   </p:clrMapOvr>
   <mc:AlternateContent xmlns:mc="http://schemas.openxmlformats.org/markup-compatibility/2006">
-    <mc:Choice xmlns:p14="http://schemas.microsoft.com/office/powerpoint/2010/main" Requires="p14">
-      <p:transition spd="slow" p14:dur="1500">
-        <p:split orient="vert"/>
-      </p:transition>
-    </mc:Choice>
-    <mc:Fallback>
-      <p:transition spd="slow">
-        <p:split orient="vert"/>
-      </p:transition>
-    </mc:Fallback>
+    <mc:Choice xmlns:p14="http://schemas.microsoft.com/office/powerpoint/2010/main" Requires="p14"/>
+    <mc:Fallback/>
   </mc:AlternateContent>
 </p:sldLayout>
 </file>
@@ -3331,16 +3243,8 @@
     <p:sldLayoutId id="2147483659" r:id="rId11"/>
   </p:sldLayoutIdLst>
   <mc:AlternateContent xmlns:mc="http://schemas.openxmlformats.org/markup-compatibility/2006">
-    <mc:Choice xmlns:p14="http://schemas.microsoft.com/office/powerpoint/2010/main" Requires="p14">
-      <p:transition spd="slow" p14:dur="1500">
-        <p:split orient="vert"/>
-      </p:transition>
-    </mc:Choice>
-    <mc:Fallback>
-      <p:transition spd="slow">
-        <p:split orient="vert"/>
-      </p:transition>
-    </mc:Fallback>
+    <mc:Choice xmlns:p14="http://schemas.microsoft.com/office/powerpoint/2010/main" Requires="p14"/>
+    <mc:Fallback/>
   </mc:AlternateContent>
   <p:txStyles>
     <p:titleStyle>

</xml_diff>